<commit_message>
Updated PowerPoint and report
</commit_message>
<xml_diff>
--- a/Task 1/TASK 1 PowerPoint.pptx
+++ b/Task 1/TASK 1 PowerPoint.pptx
@@ -130,6 +130,11 @@
       </a:defRPr>
     </a:lvl9pPr>
   </p:defaultTextStyle>
+  <p:extLst>
+    <p:ext uri="{EFAFB233-063F-42B5-8137-9DF3F51BA10A}">
+      <p15:sldGuideLst xmlns:p15="http://schemas.microsoft.com/office/powerpoint/2012/main"/>
+    </p:ext>
+  </p:extLst>
 </p:presentation>
 </file>
 
@@ -183,7 +188,7 @@
           <a:noFill/>
           <a:extLst>
             <a:ext uri="{909E8E84-426E-40dd-AFC4-6F175D3DCCD1}">
-              <a14:hiddenFill xmlns:a14="http://schemas.microsoft.com/office/drawing/2010/main" xmlns="">
+              <a14:hiddenFill xmlns="" xmlns:a14="http://schemas.microsoft.com/office/drawing/2010/main">
                 <a:solidFill>
                   <a:srgbClr val="FFFFFF"/>
                 </a:solidFill>
@@ -243,7 +248,7 @@
             </a:ln>
             <a:extLst>
               <a:ext uri="{91240B29-F687-4f45-9708-019B960494DF}">
-                <a14:hiddenLine xmlns:a14="http://schemas.microsoft.com/office/drawing/2010/main" xmlns="" w="9525">
+                <a14:hiddenLine xmlns="" xmlns:a14="http://schemas.microsoft.com/office/drawing/2010/main" w="9525">
                   <a:solidFill>
                     <a:srgbClr val="000000"/>
                   </a:solidFill>
@@ -340,7 +345,7 @@
             </a:ln>
             <a:extLst>
               <a:ext uri="{91240B29-F687-4f45-9708-019B960494DF}">
-                <a14:hiddenLine xmlns:a14="http://schemas.microsoft.com/office/drawing/2010/main" xmlns="" w="9525">
+                <a14:hiddenLine xmlns="" xmlns:a14="http://schemas.microsoft.com/office/drawing/2010/main" w="9525">
                   <a:solidFill>
                     <a:srgbClr val="000000"/>
                   </a:solidFill>
@@ -437,7 +442,7 @@
             </a:ln>
             <a:extLst>
               <a:ext uri="{91240B29-F687-4f45-9708-019B960494DF}">
-                <a14:hiddenLine xmlns:a14="http://schemas.microsoft.com/office/drawing/2010/main" xmlns="" w="9525">
+                <a14:hiddenLine xmlns="" xmlns:a14="http://schemas.microsoft.com/office/drawing/2010/main" w="9525">
                   <a:solidFill>
                     <a:srgbClr val="000000"/>
                   </a:solidFill>
@@ -478,7 +483,7 @@
             </a:ln>
             <a:extLst>
               <a:ext uri="{91240B29-F687-4f45-9708-019B960494DF}">
-                <a14:hiddenLine xmlns:a14="http://schemas.microsoft.com/office/drawing/2010/main" xmlns="" w="9525">
+                <a14:hiddenLine xmlns="" xmlns:a14="http://schemas.microsoft.com/office/drawing/2010/main" w="9525">
                   <a:solidFill>
                     <a:srgbClr val="000000"/>
                   </a:solidFill>
@@ -575,7 +580,7 @@
             </a:ln>
             <a:extLst>
               <a:ext uri="{91240B29-F687-4f45-9708-019B960494DF}">
-                <a14:hiddenLine xmlns:a14="http://schemas.microsoft.com/office/drawing/2010/main" xmlns="" w="9525">
+                <a14:hiddenLine xmlns="" xmlns:a14="http://schemas.microsoft.com/office/drawing/2010/main" w="9525">
                   <a:solidFill>
                     <a:srgbClr val="000000"/>
                   </a:solidFill>
@@ -644,7 +649,7 @@
             </a:ln>
             <a:extLst>
               <a:ext uri="{91240B29-F687-4f45-9708-019B960494DF}">
-                <a14:hiddenLine xmlns:a14="http://schemas.microsoft.com/office/drawing/2010/main" xmlns="" w="9525">
+                <a14:hiddenLine xmlns="" xmlns:a14="http://schemas.microsoft.com/office/drawing/2010/main" w="9525">
                   <a:solidFill>
                     <a:srgbClr val="000000"/>
                   </a:solidFill>
@@ -713,7 +718,7 @@
             </a:ln>
             <a:extLst>
               <a:ext uri="{91240B29-F687-4f45-9708-019B960494DF}">
-                <a14:hiddenLine xmlns:a14="http://schemas.microsoft.com/office/drawing/2010/main" xmlns="" w="9525">
+                <a14:hiddenLine xmlns="" xmlns:a14="http://schemas.microsoft.com/office/drawing/2010/main" w="9525">
                   <a:solidFill>
                     <a:srgbClr val="000000"/>
                   </a:solidFill>
@@ -810,7 +815,7 @@
             </a:ln>
             <a:extLst>
               <a:ext uri="{91240B29-F687-4f45-9708-019B960494DF}">
-                <a14:hiddenLine xmlns:a14="http://schemas.microsoft.com/office/drawing/2010/main" xmlns="" w="9525">
+                <a14:hiddenLine xmlns="" xmlns:a14="http://schemas.microsoft.com/office/drawing/2010/main" w="9525">
                   <a:solidFill>
                     <a:srgbClr val="000000"/>
                   </a:solidFill>
@@ -879,7 +884,7 @@
             </a:ln>
             <a:extLst>
               <a:ext uri="{91240B29-F687-4f45-9708-019B960494DF}">
-                <a14:hiddenLine xmlns:a14="http://schemas.microsoft.com/office/drawing/2010/main" xmlns="" w="9525">
+                <a14:hiddenLine xmlns="" xmlns:a14="http://schemas.microsoft.com/office/drawing/2010/main" w="9525">
                   <a:solidFill>
                     <a:srgbClr val="000000"/>
                   </a:solidFill>
@@ -948,7 +953,7 @@
             </a:ln>
             <a:extLst>
               <a:ext uri="{91240B29-F687-4f45-9708-019B960494DF}">
-                <a14:hiddenLine xmlns:a14="http://schemas.microsoft.com/office/drawing/2010/main" xmlns="" w="9525">
+                <a14:hiddenLine xmlns="" xmlns:a14="http://schemas.microsoft.com/office/drawing/2010/main" w="9525">
                   <a:solidFill>
                     <a:srgbClr val="000000"/>
                   </a:solidFill>
@@ -1045,7 +1050,7 @@
             </a:ln>
             <a:extLst>
               <a:ext uri="{91240B29-F687-4f45-9708-019B960494DF}">
-                <a14:hiddenLine xmlns:a14="http://schemas.microsoft.com/office/drawing/2010/main" xmlns="" w="9525">
+                <a14:hiddenLine xmlns="" xmlns:a14="http://schemas.microsoft.com/office/drawing/2010/main" w="9525">
                   <a:solidFill>
                     <a:srgbClr val="000000"/>
                   </a:solidFill>
@@ -1142,7 +1147,7 @@
             </a:ln>
             <a:extLst>
               <a:ext uri="{91240B29-F687-4f45-9708-019B960494DF}">
-                <a14:hiddenLine xmlns:a14="http://schemas.microsoft.com/office/drawing/2010/main" xmlns="" w="9525">
+                <a14:hiddenLine xmlns="" xmlns:a14="http://schemas.microsoft.com/office/drawing/2010/main" w="9525">
                   <a:solidFill>
                     <a:srgbClr val="000000"/>
                   </a:solidFill>
@@ -1211,7 +1216,7 @@
             </a:ln>
             <a:extLst>
               <a:ext uri="{91240B29-F687-4f45-9708-019B960494DF}">
-                <a14:hiddenLine xmlns:a14="http://schemas.microsoft.com/office/drawing/2010/main" xmlns="" w="9525">
+                <a14:hiddenLine xmlns="" xmlns:a14="http://schemas.microsoft.com/office/drawing/2010/main" w="9525">
                   <a:solidFill>
                     <a:srgbClr val="000000"/>
                   </a:solidFill>
@@ -1328,7 +1333,7 @@
             </a:ln>
             <a:extLst>
               <a:ext uri="{91240B29-F687-4f45-9708-019B960494DF}">
-                <a14:hiddenLine xmlns:a14="http://schemas.microsoft.com/office/drawing/2010/main" xmlns="" w="9525">
+                <a14:hiddenLine xmlns="" xmlns:a14="http://schemas.microsoft.com/office/drawing/2010/main" w="9525">
                   <a:solidFill>
                     <a:srgbClr val="000000"/>
                   </a:solidFill>
@@ -1397,7 +1402,7 @@
             </a:ln>
             <a:extLst>
               <a:ext uri="{91240B29-F687-4f45-9708-019B960494DF}">
-                <a14:hiddenLine xmlns:a14="http://schemas.microsoft.com/office/drawing/2010/main" xmlns="" w="9525">
+                <a14:hiddenLine xmlns="" xmlns:a14="http://schemas.microsoft.com/office/drawing/2010/main" w="9525">
                   <a:solidFill>
                     <a:srgbClr val="000000"/>
                   </a:solidFill>
@@ -1494,7 +1499,7 @@
             </a:ln>
             <a:extLst>
               <a:ext uri="{91240B29-F687-4f45-9708-019B960494DF}">
-                <a14:hiddenLine xmlns:a14="http://schemas.microsoft.com/office/drawing/2010/main" xmlns="" w="9525">
+                <a14:hiddenLine xmlns="" xmlns:a14="http://schemas.microsoft.com/office/drawing/2010/main" w="9525">
                   <a:solidFill>
                     <a:srgbClr val="000000"/>
                   </a:solidFill>
@@ -1591,7 +1596,7 @@
             </a:ln>
             <a:extLst>
               <a:ext uri="{91240B29-F687-4f45-9708-019B960494DF}">
-                <a14:hiddenLine xmlns:a14="http://schemas.microsoft.com/office/drawing/2010/main" xmlns="" w="9525">
+                <a14:hiddenLine xmlns="" xmlns:a14="http://schemas.microsoft.com/office/drawing/2010/main" w="9525">
                   <a:solidFill>
                     <a:srgbClr val="000000"/>
                   </a:solidFill>
@@ -1660,7 +1665,7 @@
             </a:ln>
             <a:extLst>
               <a:ext uri="{91240B29-F687-4f45-9708-019B960494DF}">
-                <a14:hiddenLine xmlns:a14="http://schemas.microsoft.com/office/drawing/2010/main" xmlns="" w="9525">
+                <a14:hiddenLine xmlns="" xmlns:a14="http://schemas.microsoft.com/office/drawing/2010/main" w="9525">
                   <a:solidFill>
                     <a:srgbClr val="000000"/>
                   </a:solidFill>
@@ -1757,7 +1762,7 @@
             </a:ln>
             <a:extLst>
               <a:ext uri="{91240B29-F687-4f45-9708-019B960494DF}">
-                <a14:hiddenLine xmlns:a14="http://schemas.microsoft.com/office/drawing/2010/main" xmlns="" w="9525">
+                <a14:hiddenLine xmlns="" xmlns:a14="http://schemas.microsoft.com/office/drawing/2010/main" w="9525">
                   <a:solidFill>
                     <a:srgbClr val="000000"/>
                   </a:solidFill>
@@ -1854,7 +1859,7 @@
             </a:ln>
             <a:extLst>
               <a:ext uri="{91240B29-F687-4f45-9708-019B960494DF}">
-                <a14:hiddenLine xmlns:a14="http://schemas.microsoft.com/office/drawing/2010/main" xmlns="" w="9525">
+                <a14:hiddenLine xmlns="" xmlns:a14="http://schemas.microsoft.com/office/drawing/2010/main" w="9525">
                   <a:solidFill>
                     <a:srgbClr val="000000"/>
                   </a:solidFill>
@@ -1917,7 +1922,7 @@
             </a:ln>
             <a:extLst>
               <a:ext uri="{91240B29-F687-4f45-9708-019B960494DF}">
-                <a14:hiddenLine xmlns:a14="http://schemas.microsoft.com/office/drawing/2010/main" xmlns="" w="9525">
+                <a14:hiddenLine xmlns="" xmlns:a14="http://schemas.microsoft.com/office/drawing/2010/main" w="9525">
                   <a:solidFill>
                     <a:srgbClr val="000000"/>
                   </a:solidFill>
@@ -2014,7 +2019,7 @@
             </a:ln>
             <a:extLst>
               <a:ext uri="{91240B29-F687-4f45-9708-019B960494DF}">
-                <a14:hiddenLine xmlns:a14="http://schemas.microsoft.com/office/drawing/2010/main" xmlns="" w="9525">
+                <a14:hiddenLine xmlns="" xmlns:a14="http://schemas.microsoft.com/office/drawing/2010/main" w="9525">
                   <a:solidFill>
                     <a:srgbClr val="000000"/>
                   </a:solidFill>
@@ -2077,7 +2082,7 @@
             </a:ln>
             <a:extLst>
               <a:ext uri="{91240B29-F687-4f45-9708-019B960494DF}">
-                <a14:hiddenLine xmlns:a14="http://schemas.microsoft.com/office/drawing/2010/main" xmlns="" w="9525">
+                <a14:hiddenLine xmlns="" xmlns:a14="http://schemas.microsoft.com/office/drawing/2010/main" w="9525">
                   <a:solidFill>
                     <a:srgbClr val="000000"/>
                   </a:solidFill>
@@ -2174,7 +2179,7 @@
             </a:ln>
             <a:extLst>
               <a:ext uri="{91240B29-F687-4f45-9708-019B960494DF}">
-                <a14:hiddenLine xmlns:a14="http://schemas.microsoft.com/office/drawing/2010/main" xmlns="" w="9525">
+                <a14:hiddenLine xmlns="" xmlns:a14="http://schemas.microsoft.com/office/drawing/2010/main" w="9525">
                   <a:solidFill>
                     <a:srgbClr val="000000"/>
                   </a:solidFill>
@@ -2249,7 +2254,7 @@
             </a:ln>
             <a:extLst>
               <a:ext uri="{91240B29-F687-4f45-9708-019B960494DF}">
-                <a14:hiddenLine xmlns:a14="http://schemas.microsoft.com/office/drawing/2010/main" xmlns="" w="9525">
+                <a14:hiddenLine xmlns="" xmlns:a14="http://schemas.microsoft.com/office/drawing/2010/main" w="9525">
                   <a:solidFill>
                     <a:srgbClr val="000000"/>
                   </a:solidFill>
@@ -2346,7 +2351,7 @@
             </a:ln>
             <a:extLst>
               <a:ext uri="{91240B29-F687-4f45-9708-019B960494DF}">
-                <a14:hiddenLine xmlns:a14="http://schemas.microsoft.com/office/drawing/2010/main" xmlns="" w="9525">
+                <a14:hiddenLine xmlns="" xmlns:a14="http://schemas.microsoft.com/office/drawing/2010/main" w="9525">
                   <a:solidFill>
                     <a:srgbClr val="000000"/>
                   </a:solidFill>
@@ -2421,7 +2426,7 @@
             </a:ln>
             <a:extLst>
               <a:ext uri="{91240B29-F687-4f45-9708-019B960494DF}">
-                <a14:hiddenLine xmlns:a14="http://schemas.microsoft.com/office/drawing/2010/main" xmlns="" w="9525">
+                <a14:hiddenLine xmlns="" xmlns:a14="http://schemas.microsoft.com/office/drawing/2010/main" w="9525">
                   <a:solidFill>
                     <a:srgbClr val="000000"/>
                   </a:solidFill>
@@ -2518,7 +2523,7 @@
             </a:ln>
             <a:extLst>
               <a:ext uri="{91240B29-F687-4f45-9708-019B960494DF}">
-                <a14:hiddenLine xmlns:a14="http://schemas.microsoft.com/office/drawing/2010/main" xmlns="" w="9525">
+                <a14:hiddenLine xmlns="" xmlns:a14="http://schemas.microsoft.com/office/drawing/2010/main" w="9525">
                   <a:solidFill>
                     <a:srgbClr val="000000"/>
                   </a:solidFill>
@@ -2559,7 +2564,7 @@
             </a:ln>
             <a:extLst>
               <a:ext uri="{91240B29-F687-4f45-9708-019B960494DF}">
-                <a14:hiddenLine xmlns:a14="http://schemas.microsoft.com/office/drawing/2010/main" xmlns="" w="9525">
+                <a14:hiddenLine xmlns="" xmlns:a14="http://schemas.microsoft.com/office/drawing/2010/main" w="9525">
                   <a:solidFill>
                     <a:srgbClr val="000000"/>
                   </a:solidFill>
@@ -2656,7 +2661,7 @@
             </a:ln>
             <a:extLst>
               <a:ext uri="{91240B29-F687-4f45-9708-019B960494DF}">
-                <a14:hiddenLine xmlns:a14="http://schemas.microsoft.com/office/drawing/2010/main" xmlns="" w="9525">
+                <a14:hiddenLine xmlns="" xmlns:a14="http://schemas.microsoft.com/office/drawing/2010/main" w="9525">
                   <a:solidFill>
                     <a:srgbClr val="000000"/>
                   </a:solidFill>
@@ -2725,7 +2730,7 @@
             </a:ln>
             <a:extLst>
               <a:ext uri="{91240B29-F687-4f45-9708-019B960494DF}">
-                <a14:hiddenLine xmlns:a14="http://schemas.microsoft.com/office/drawing/2010/main" xmlns="" w="9525">
+                <a14:hiddenLine xmlns="" xmlns:a14="http://schemas.microsoft.com/office/drawing/2010/main" w="9525">
                   <a:solidFill>
                     <a:srgbClr val="000000"/>
                   </a:solidFill>
@@ -2794,7 +2799,7 @@
             </a:ln>
             <a:extLst>
               <a:ext uri="{91240B29-F687-4f45-9708-019B960494DF}">
-                <a14:hiddenLine xmlns:a14="http://schemas.microsoft.com/office/drawing/2010/main" xmlns="" w="9525">
+                <a14:hiddenLine xmlns="" xmlns:a14="http://schemas.microsoft.com/office/drawing/2010/main" w="9525">
                   <a:solidFill>
                     <a:srgbClr val="000000"/>
                   </a:solidFill>
@@ -2891,7 +2896,7 @@
             </a:ln>
             <a:extLst>
               <a:ext uri="{91240B29-F687-4f45-9708-019B960494DF}">
-                <a14:hiddenLine xmlns:a14="http://schemas.microsoft.com/office/drawing/2010/main" xmlns="" w="9525">
+                <a14:hiddenLine xmlns="" xmlns:a14="http://schemas.microsoft.com/office/drawing/2010/main" w="9525">
                   <a:solidFill>
                     <a:srgbClr val="000000"/>
                   </a:solidFill>
@@ -2966,7 +2971,7 @@
             </a:ln>
             <a:extLst>
               <a:ext uri="{91240B29-F687-4f45-9708-019B960494DF}">
-                <a14:hiddenLine xmlns:a14="http://schemas.microsoft.com/office/drawing/2010/main" xmlns="" w="9525">
+                <a14:hiddenLine xmlns="" xmlns:a14="http://schemas.microsoft.com/office/drawing/2010/main" w="9525">
                   <a:solidFill>
                     <a:srgbClr val="000000"/>
                   </a:solidFill>
@@ -3035,7 +3040,7 @@
             </a:ln>
             <a:extLst>
               <a:ext uri="{91240B29-F687-4f45-9708-019B960494DF}">
-                <a14:hiddenLine xmlns:a14="http://schemas.microsoft.com/office/drawing/2010/main" xmlns="" w="9525">
+                <a14:hiddenLine xmlns="" xmlns:a14="http://schemas.microsoft.com/office/drawing/2010/main" w="9525">
                   <a:solidFill>
                     <a:srgbClr val="000000"/>
                   </a:solidFill>
@@ -3132,7 +3137,7 @@
             </a:ln>
             <a:extLst>
               <a:ext uri="{91240B29-F687-4f45-9708-019B960494DF}">
-                <a14:hiddenLine xmlns:a14="http://schemas.microsoft.com/office/drawing/2010/main" xmlns="" w="9525">
+                <a14:hiddenLine xmlns="" xmlns:a14="http://schemas.microsoft.com/office/drawing/2010/main" w="9525">
                   <a:solidFill>
                     <a:srgbClr val="000000"/>
                   </a:solidFill>
@@ -3201,7 +3206,7 @@
             </a:ln>
             <a:extLst>
               <a:ext uri="{91240B29-F687-4f45-9708-019B960494DF}">
-                <a14:hiddenLine xmlns:a14="http://schemas.microsoft.com/office/drawing/2010/main" xmlns="" w="9525">
+                <a14:hiddenLine xmlns="" xmlns:a14="http://schemas.microsoft.com/office/drawing/2010/main" w="9525">
                   <a:solidFill>
                     <a:srgbClr val="000000"/>
                   </a:solidFill>
@@ -3298,7 +3303,7 @@
             </a:ln>
             <a:extLst>
               <a:ext uri="{91240B29-F687-4f45-9708-019B960494DF}">
-                <a14:hiddenLine xmlns:a14="http://schemas.microsoft.com/office/drawing/2010/main" xmlns="" w="9525">
+                <a14:hiddenLine xmlns="" xmlns:a14="http://schemas.microsoft.com/office/drawing/2010/main" w="9525">
                   <a:solidFill>
                     <a:srgbClr val="000000"/>
                   </a:solidFill>
@@ -3367,7 +3372,7 @@
             </a:ln>
             <a:extLst>
               <a:ext uri="{91240B29-F687-4f45-9708-019B960494DF}">
-                <a14:hiddenLine xmlns:a14="http://schemas.microsoft.com/office/drawing/2010/main" xmlns="" w="9525">
+                <a14:hiddenLine xmlns="" xmlns:a14="http://schemas.microsoft.com/office/drawing/2010/main" w="9525">
                   <a:solidFill>
                     <a:srgbClr val="000000"/>
                   </a:solidFill>
@@ -3464,7 +3469,7 @@
             </a:ln>
             <a:extLst>
               <a:ext uri="{91240B29-F687-4f45-9708-019B960494DF}">
-                <a14:hiddenLine xmlns:a14="http://schemas.microsoft.com/office/drawing/2010/main" xmlns="" w="9525">
+                <a14:hiddenLine xmlns="" xmlns:a14="http://schemas.microsoft.com/office/drawing/2010/main" w="9525">
                   <a:solidFill>
                     <a:srgbClr val="000000"/>
                   </a:solidFill>
@@ -3505,7 +3510,7 @@
             </a:ln>
             <a:extLst>
               <a:ext uri="{91240B29-F687-4f45-9708-019B960494DF}">
-                <a14:hiddenLine xmlns:a14="http://schemas.microsoft.com/office/drawing/2010/main" xmlns="" w="9525">
+                <a14:hiddenLine xmlns="" xmlns:a14="http://schemas.microsoft.com/office/drawing/2010/main" w="9525">
                   <a:solidFill>
                     <a:srgbClr val="000000"/>
                   </a:solidFill>
@@ -3577,7 +3582,7 @@
             </a:ln>
             <a:extLst>
               <a:ext uri="{91240B29-F687-4f45-9708-019B960494DF}">
-                <a14:hiddenLine xmlns:a14="http://schemas.microsoft.com/office/drawing/2010/main" xmlns="" w="9525">
+                <a14:hiddenLine xmlns="" xmlns:a14="http://schemas.microsoft.com/office/drawing/2010/main" w="9525">
                   <a:solidFill>
                     <a:srgbClr val="000000"/>
                   </a:solidFill>
@@ -3674,7 +3679,7 @@
             </a:ln>
             <a:extLst>
               <a:ext uri="{91240B29-F687-4f45-9708-019B960494DF}">
-                <a14:hiddenLine xmlns:a14="http://schemas.microsoft.com/office/drawing/2010/main" xmlns="" w="9525">
+                <a14:hiddenLine xmlns="" xmlns:a14="http://schemas.microsoft.com/office/drawing/2010/main" w="9525">
                   <a:solidFill>
                     <a:srgbClr val="000000"/>
                   </a:solidFill>
@@ -3743,7 +3748,7 @@
             </a:ln>
             <a:extLst>
               <a:ext uri="{91240B29-F687-4f45-9708-019B960494DF}">
-                <a14:hiddenLine xmlns:a14="http://schemas.microsoft.com/office/drawing/2010/main" xmlns="" w="9525">
+                <a14:hiddenLine xmlns="" xmlns:a14="http://schemas.microsoft.com/office/drawing/2010/main" w="9525">
                   <a:solidFill>
                     <a:srgbClr val="000000"/>
                   </a:solidFill>
@@ -3840,7 +3845,7 @@
             </a:ln>
             <a:extLst>
               <a:ext uri="{91240B29-F687-4f45-9708-019B960494DF}">
-                <a14:hiddenLine xmlns:a14="http://schemas.microsoft.com/office/drawing/2010/main" xmlns="" w="9525">
+                <a14:hiddenLine xmlns="" xmlns:a14="http://schemas.microsoft.com/office/drawing/2010/main" w="9525">
                   <a:solidFill>
                     <a:srgbClr val="000000"/>
                   </a:solidFill>
@@ -3937,7 +3942,7 @@
             </a:ln>
             <a:extLst>
               <a:ext uri="{91240B29-F687-4f45-9708-019B960494DF}">
-                <a14:hiddenLine xmlns:a14="http://schemas.microsoft.com/office/drawing/2010/main" xmlns="" w="9525">
+                <a14:hiddenLine xmlns="" xmlns:a14="http://schemas.microsoft.com/office/drawing/2010/main" w="9525">
                   <a:solidFill>
                     <a:srgbClr val="000000"/>
                   </a:solidFill>
@@ -4009,7 +4014,7 @@
             </a:ln>
             <a:extLst>
               <a:ext uri="{91240B29-F687-4f45-9708-019B960494DF}">
-                <a14:hiddenLine xmlns:a14="http://schemas.microsoft.com/office/drawing/2010/main" xmlns="" w="9525">
+                <a14:hiddenLine xmlns="" xmlns:a14="http://schemas.microsoft.com/office/drawing/2010/main" w="9525">
                   <a:solidFill>
                     <a:srgbClr val="000000"/>
                   </a:solidFill>
@@ -4078,7 +4083,7 @@
             </a:ln>
             <a:extLst>
               <a:ext uri="{91240B29-F687-4f45-9708-019B960494DF}">
-                <a14:hiddenLine xmlns:a14="http://schemas.microsoft.com/office/drawing/2010/main" xmlns="" w="9525">
+                <a14:hiddenLine xmlns="" xmlns:a14="http://schemas.microsoft.com/office/drawing/2010/main" w="9525">
                   <a:solidFill>
                     <a:srgbClr val="000000"/>
                   </a:solidFill>
@@ -4175,7 +4180,7 @@
             </a:ln>
             <a:extLst>
               <a:ext uri="{91240B29-F687-4f45-9708-019B960494DF}">
-                <a14:hiddenLine xmlns:a14="http://schemas.microsoft.com/office/drawing/2010/main" xmlns="" w="9525">
+                <a14:hiddenLine xmlns="" xmlns:a14="http://schemas.microsoft.com/office/drawing/2010/main" w="9525">
                   <a:solidFill>
                     <a:srgbClr val="000000"/>
                   </a:solidFill>
@@ -4272,7 +4277,7 @@
             </a:ln>
             <a:extLst>
               <a:ext uri="{91240B29-F687-4f45-9708-019B960494DF}">
-                <a14:hiddenLine xmlns:a14="http://schemas.microsoft.com/office/drawing/2010/main" xmlns="" w="9525">
+                <a14:hiddenLine xmlns="" xmlns:a14="http://schemas.microsoft.com/office/drawing/2010/main" w="9525">
                   <a:solidFill>
                     <a:srgbClr val="000000"/>
                   </a:solidFill>
@@ -4341,7 +4346,7 @@
             </a:ln>
             <a:extLst>
               <a:ext uri="{91240B29-F687-4f45-9708-019B960494DF}">
-                <a14:hiddenLine xmlns:a14="http://schemas.microsoft.com/office/drawing/2010/main" xmlns="" w="9525">
+                <a14:hiddenLine xmlns="" xmlns:a14="http://schemas.microsoft.com/office/drawing/2010/main" w="9525">
                   <a:solidFill>
                     <a:srgbClr val="000000"/>
                   </a:solidFill>
@@ -4468,7 +4473,7 @@
             </a:ln>
             <a:extLst>
               <a:ext uri="{91240B29-F687-4f45-9708-019B960494DF}">
-                <a14:hiddenLine xmlns:a14="http://schemas.microsoft.com/office/drawing/2010/main" xmlns="" w="9525">
+                <a14:hiddenLine xmlns="" xmlns:a14="http://schemas.microsoft.com/office/drawing/2010/main" w="9525">
                   <a:solidFill>
                     <a:srgbClr val="000000"/>
                   </a:solidFill>
@@ -4543,7 +4548,7 @@
             </a:ln>
             <a:extLst>
               <a:ext uri="{91240B29-F687-4f45-9708-019B960494DF}">
-                <a14:hiddenLine xmlns:a14="http://schemas.microsoft.com/office/drawing/2010/main" xmlns="" w="9525">
+                <a14:hiddenLine xmlns="" xmlns:a14="http://schemas.microsoft.com/office/drawing/2010/main" w="9525">
                   <a:solidFill>
                     <a:srgbClr val="000000"/>
                   </a:solidFill>
@@ -4640,7 +4645,7 @@
             </a:ln>
             <a:extLst>
               <a:ext uri="{91240B29-F687-4f45-9708-019B960494DF}">
-                <a14:hiddenLine xmlns:a14="http://schemas.microsoft.com/office/drawing/2010/main" xmlns="" w="9525">
+                <a14:hiddenLine xmlns="" xmlns:a14="http://schemas.microsoft.com/office/drawing/2010/main" w="9525">
                   <a:solidFill>
                     <a:srgbClr val="000000"/>
                   </a:solidFill>
@@ -4787,7 +4792,7 @@
           <a:p>
             <a:fld id="{48A87A34-81AB-432B-8DAE-1953F412C126}" type="datetimeFigureOut">
               <a:rPr lang="en-US" dirty="0"/>
-              <a:t>4/6/2026</a:t>
+              <a:t>4/7/2026</a:t>
             </a:fld>
             <a:endParaRPr lang="en-US" dirty="0"/>
           </a:p>
@@ -5049,7 +5054,7 @@
           <a:p>
             <a:fld id="{48A87A34-81AB-432B-8DAE-1953F412C126}" type="datetimeFigureOut">
               <a:rPr lang="en-US" dirty="0"/>
-              <a:t>4/6/2026</a:t>
+              <a:t>4/7/2026</a:t>
             </a:fld>
             <a:endParaRPr lang="en-US" dirty="0"/>
           </a:p>
@@ -5240,7 +5245,7 @@
           <a:p>
             <a:fld id="{48A87A34-81AB-432B-8DAE-1953F412C126}" type="datetimeFigureOut">
               <a:rPr lang="en-US" dirty="0"/>
-              <a:t>4/6/2026</a:t>
+              <a:t>4/7/2026</a:t>
             </a:fld>
             <a:endParaRPr lang="en-US" dirty="0"/>
           </a:p>
@@ -5498,7 +5503,7 @@
           <a:p>
             <a:fld id="{48A87A34-81AB-432B-8DAE-1953F412C126}" type="datetimeFigureOut">
               <a:rPr lang="en-US" dirty="0"/>
-              <a:t>4/6/2026</a:t>
+              <a:t>4/7/2026</a:t>
             </a:fld>
             <a:endParaRPr lang="en-US" dirty="0"/>
           </a:p>
@@ -5927,7 +5932,7 @@
           <a:p>
             <a:fld id="{48A87A34-81AB-432B-8DAE-1953F412C126}" type="datetimeFigureOut">
               <a:rPr lang="en-US" dirty="0"/>
-              <a:t>4/6/2026</a:t>
+              <a:t>4/7/2026</a:t>
             </a:fld>
             <a:endParaRPr lang="en-US" dirty="0"/>
           </a:p>
@@ -6468,7 +6473,7 @@
           <a:p>
             <a:fld id="{48A87A34-81AB-432B-8DAE-1953F412C126}" type="datetimeFigureOut">
               <a:rPr lang="en-US" dirty="0"/>
-              <a:t>4/6/2026</a:t>
+              <a:t>4/7/2026</a:t>
             </a:fld>
             <a:endParaRPr lang="en-US" dirty="0"/>
           </a:p>
@@ -7183,7 +7188,7 @@
           <a:p>
             <a:fld id="{48A87A34-81AB-432B-8DAE-1953F412C126}" type="datetimeFigureOut">
               <a:rPr lang="en-US" dirty="0"/>
-              <a:t>4/6/2026</a:t>
+              <a:t>4/7/2026</a:t>
             </a:fld>
             <a:endParaRPr lang="en-US" dirty="0"/>
           </a:p>
@@ -7348,7 +7353,7 @@
           <a:p>
             <a:fld id="{48A87A34-81AB-432B-8DAE-1953F412C126}" type="datetimeFigureOut">
               <a:rPr lang="en-US" dirty="0"/>
-              <a:t>4/6/2026</a:t>
+              <a:t>4/7/2026</a:t>
             </a:fld>
             <a:endParaRPr lang="en-US" dirty="0"/>
           </a:p>
@@ -7523,7 +7528,7 @@
           <a:p>
             <a:fld id="{48A87A34-81AB-432B-8DAE-1953F412C126}" type="datetimeFigureOut">
               <a:rPr lang="en-US" dirty="0"/>
-              <a:t>4/6/2026</a:t>
+              <a:t>4/7/2026</a:t>
             </a:fld>
             <a:endParaRPr lang="en-US" dirty="0"/>
           </a:p>
@@ -7688,7 +7693,7 @@
           <a:p>
             <a:fld id="{48A87A34-81AB-432B-8DAE-1953F412C126}" type="datetimeFigureOut">
               <a:rPr lang="en-US" dirty="0"/>
-              <a:t>4/6/2026</a:t>
+              <a:t>4/7/2026</a:t>
             </a:fld>
             <a:endParaRPr lang="en-US" dirty="0"/>
           </a:p>
@@ -7933,7 +7938,7 @@
           <a:p>
             <a:fld id="{48A87A34-81AB-432B-8DAE-1953F412C126}" type="datetimeFigureOut">
               <a:rPr lang="en-US" dirty="0"/>
-              <a:t>4/6/2026</a:t>
+              <a:t>4/7/2026</a:t>
             </a:fld>
             <a:endParaRPr lang="en-US" dirty="0"/>
           </a:p>
@@ -8160,7 +8165,7 @@
           <a:p>
             <a:fld id="{48A87A34-81AB-432B-8DAE-1953F412C126}" type="datetimeFigureOut">
               <a:rPr lang="en-US" dirty="0"/>
-              <a:t>4/6/2026</a:t>
+              <a:t>4/7/2026</a:t>
             </a:fld>
             <a:endParaRPr lang="en-US" dirty="0"/>
           </a:p>
@@ -8536,7 +8541,7 @@
           <a:p>
             <a:fld id="{48A87A34-81AB-432B-8DAE-1953F412C126}" type="datetimeFigureOut">
               <a:rPr lang="en-US" dirty="0"/>
-              <a:t>4/6/2026</a:t>
+              <a:t>4/7/2026</a:t>
             </a:fld>
             <a:endParaRPr lang="en-US" dirty="0"/>
           </a:p>
@@ -8649,7 +8654,7 @@
           <a:p>
             <a:fld id="{48A87A34-81AB-432B-8DAE-1953F412C126}" type="datetimeFigureOut">
               <a:rPr lang="en-US" dirty="0"/>
-              <a:t>4/6/2026</a:t>
+              <a:t>4/7/2026</a:t>
             </a:fld>
             <a:endParaRPr lang="en-US" dirty="0"/>
           </a:p>
@@ -8739,7 +8744,7 @@
           <a:p>
             <a:fld id="{48A87A34-81AB-432B-8DAE-1953F412C126}" type="datetimeFigureOut">
               <a:rPr lang="en-US" dirty="0"/>
-              <a:t>4/6/2026</a:t>
+              <a:t>4/7/2026</a:t>
             </a:fld>
             <a:endParaRPr lang="en-US" dirty="0"/>
           </a:p>
@@ -8983,7 +8988,7 @@
           <a:p>
             <a:fld id="{48A87A34-81AB-432B-8DAE-1953F412C126}" type="datetimeFigureOut">
               <a:rPr lang="en-US" dirty="0"/>
-              <a:t>4/6/2026</a:t>
+              <a:t>4/7/2026</a:t>
             </a:fld>
             <a:endParaRPr lang="en-US" dirty="0"/>
           </a:p>
@@ -9258,7 +9263,7 @@
           <a:p>
             <a:fld id="{48A87A34-81AB-432B-8DAE-1953F412C126}" type="datetimeFigureOut">
               <a:rPr lang="en-US" dirty="0"/>
-              <a:t>4/6/2026</a:t>
+              <a:t>4/7/2026</a:t>
             </a:fld>
             <a:endParaRPr lang="en-US" dirty="0"/>
           </a:p>
@@ -9369,7 +9374,7 @@
           <a:noFill/>
           <a:extLst>
             <a:ext uri="{909E8E84-426E-40dd-AFC4-6F175D3DCCD1}">
-              <a14:hiddenFill xmlns:a14="http://schemas.microsoft.com/office/drawing/2010/main" xmlns="">
+              <a14:hiddenFill xmlns="" xmlns:a14="http://schemas.microsoft.com/office/drawing/2010/main">
                 <a:solidFill>
                   <a:srgbClr val="FFFFFF"/>
                 </a:solidFill>
@@ -9443,7 +9448,7 @@
               </a:ln>
               <a:extLst>
                 <a:ext uri="{91240B29-F687-4f45-9708-019B960494DF}">
-                  <a14:hiddenLine xmlns:a14="http://schemas.microsoft.com/office/drawing/2010/main" xmlns="" w="9525">
+                  <a14:hiddenLine xmlns="" xmlns:a14="http://schemas.microsoft.com/office/drawing/2010/main" w="9525">
                     <a:solidFill>
                       <a:srgbClr val="000000"/>
                     </a:solidFill>
@@ -9540,7 +9545,7 @@
               </a:ln>
               <a:extLst>
                 <a:ext uri="{91240B29-F687-4f45-9708-019B960494DF}">
-                  <a14:hiddenLine xmlns:a14="http://schemas.microsoft.com/office/drawing/2010/main" xmlns="" w="9525">
+                  <a14:hiddenLine xmlns="" xmlns:a14="http://schemas.microsoft.com/office/drawing/2010/main" w="9525">
                     <a:solidFill>
                       <a:srgbClr val="000000"/>
                     </a:solidFill>
@@ -9637,7 +9642,7 @@
               </a:ln>
               <a:extLst>
                 <a:ext uri="{91240B29-F687-4f45-9708-019B960494DF}">
-                  <a14:hiddenLine xmlns:a14="http://schemas.microsoft.com/office/drawing/2010/main" xmlns="" w="9525">
+                  <a14:hiddenLine xmlns="" xmlns:a14="http://schemas.microsoft.com/office/drawing/2010/main" w="9525">
                     <a:solidFill>
                       <a:srgbClr val="000000"/>
                     </a:solidFill>
@@ -9706,7 +9711,7 @@
               </a:ln>
               <a:extLst>
                 <a:ext uri="{91240B29-F687-4f45-9708-019B960494DF}">
-                  <a14:hiddenLine xmlns:a14="http://schemas.microsoft.com/office/drawing/2010/main" xmlns="" w="9525">
+                  <a14:hiddenLine xmlns="" xmlns:a14="http://schemas.microsoft.com/office/drawing/2010/main" w="9525">
                     <a:solidFill>
                       <a:srgbClr val="000000"/>
                     </a:solidFill>
@@ -9803,7 +9808,7 @@
               </a:ln>
               <a:extLst>
                 <a:ext uri="{91240B29-F687-4f45-9708-019B960494DF}">
-                  <a14:hiddenLine xmlns:a14="http://schemas.microsoft.com/office/drawing/2010/main" xmlns="" w="9525">
+                  <a14:hiddenLine xmlns="" xmlns:a14="http://schemas.microsoft.com/office/drawing/2010/main" w="9525">
                     <a:solidFill>
                       <a:srgbClr val="000000"/>
                     </a:solidFill>
@@ -9872,7 +9877,7 @@
               </a:ln>
               <a:extLst>
                 <a:ext uri="{91240B29-F687-4f45-9708-019B960494DF}">
-                  <a14:hiddenLine xmlns:a14="http://schemas.microsoft.com/office/drawing/2010/main" xmlns="" w="9525">
+                  <a14:hiddenLine xmlns="" xmlns:a14="http://schemas.microsoft.com/office/drawing/2010/main" w="9525">
                     <a:solidFill>
                       <a:srgbClr val="000000"/>
                     </a:solidFill>
@@ -9941,7 +9946,7 @@
               </a:ln>
               <a:extLst>
                 <a:ext uri="{91240B29-F687-4f45-9708-019B960494DF}">
-                  <a14:hiddenLine xmlns:a14="http://schemas.microsoft.com/office/drawing/2010/main" xmlns="" w="9525">
+                  <a14:hiddenLine xmlns="" xmlns:a14="http://schemas.microsoft.com/office/drawing/2010/main" w="9525">
                     <a:solidFill>
                       <a:srgbClr val="000000"/>
                     </a:solidFill>
@@ -10038,7 +10043,7 @@
               </a:ln>
               <a:extLst>
                 <a:ext uri="{91240B29-F687-4f45-9708-019B960494DF}">
-                  <a14:hiddenLine xmlns:a14="http://schemas.microsoft.com/office/drawing/2010/main" xmlns="" w="9525">
+                  <a14:hiddenLine xmlns="" xmlns:a14="http://schemas.microsoft.com/office/drawing/2010/main" w="9525">
                     <a:solidFill>
                       <a:srgbClr val="000000"/>
                     </a:solidFill>
@@ -10135,7 +10140,7 @@
               </a:ln>
               <a:extLst>
                 <a:ext uri="{91240B29-F687-4f45-9708-019B960494DF}">
-                  <a14:hiddenLine xmlns:a14="http://schemas.microsoft.com/office/drawing/2010/main" xmlns="" w="9525">
+                  <a14:hiddenLine xmlns="" xmlns:a14="http://schemas.microsoft.com/office/drawing/2010/main" w="9525">
                     <a:solidFill>
                       <a:srgbClr val="000000"/>
                     </a:solidFill>
@@ -10204,7 +10209,7 @@
               </a:ln>
               <a:extLst>
                 <a:ext uri="{91240B29-F687-4f45-9708-019B960494DF}">
-                  <a14:hiddenLine xmlns:a14="http://schemas.microsoft.com/office/drawing/2010/main" xmlns="" w="9525">
+                  <a14:hiddenLine xmlns="" xmlns:a14="http://schemas.microsoft.com/office/drawing/2010/main" w="9525">
                     <a:solidFill>
                       <a:srgbClr val="000000"/>
                     </a:solidFill>
@@ -10321,7 +10326,7 @@
               </a:ln>
               <a:extLst>
                 <a:ext uri="{91240B29-F687-4f45-9708-019B960494DF}">
-                  <a14:hiddenLine xmlns:a14="http://schemas.microsoft.com/office/drawing/2010/main" xmlns="" w="9525">
+                  <a14:hiddenLine xmlns="" xmlns:a14="http://schemas.microsoft.com/office/drawing/2010/main" w="9525">
                     <a:solidFill>
                       <a:srgbClr val="000000"/>
                     </a:solidFill>
@@ -10419,7 +10424,7 @@
               </a:ln>
               <a:extLst>
                 <a:ext uri="{91240B29-F687-4f45-9708-019B960494DF}">
-                  <a14:hiddenLine xmlns:a14="http://schemas.microsoft.com/office/drawing/2010/main" xmlns="" w="9525">
+                  <a14:hiddenLine xmlns="" xmlns:a14="http://schemas.microsoft.com/office/drawing/2010/main" w="9525">
                     <a:solidFill>
                       <a:srgbClr val="000000"/>
                     </a:solidFill>
@@ -10488,7 +10493,7 @@
               </a:ln>
               <a:extLst>
                 <a:ext uri="{91240B29-F687-4f45-9708-019B960494DF}">
-                  <a14:hiddenLine xmlns:a14="http://schemas.microsoft.com/office/drawing/2010/main" xmlns="" w="9525">
+                  <a14:hiddenLine xmlns="" xmlns:a14="http://schemas.microsoft.com/office/drawing/2010/main" w="9525">
                     <a:solidFill>
                       <a:srgbClr val="000000"/>
                     </a:solidFill>
@@ -10557,7 +10562,7 @@
               </a:ln>
               <a:extLst>
                 <a:ext uri="{91240B29-F687-4f45-9708-019B960494DF}">
-                  <a14:hiddenLine xmlns:a14="http://schemas.microsoft.com/office/drawing/2010/main" xmlns="" w="9525">
+                  <a14:hiddenLine xmlns="" xmlns:a14="http://schemas.microsoft.com/office/drawing/2010/main" w="9525">
                     <a:solidFill>
                       <a:srgbClr val="000000"/>
                     </a:solidFill>
@@ -10654,7 +10659,7 @@
               </a:ln>
               <a:extLst>
                 <a:ext uri="{91240B29-F687-4f45-9708-019B960494DF}">
-                  <a14:hiddenLine xmlns:a14="http://schemas.microsoft.com/office/drawing/2010/main" xmlns="" w="9525">
+                  <a14:hiddenLine xmlns="" xmlns:a14="http://schemas.microsoft.com/office/drawing/2010/main" w="9525">
                     <a:solidFill>
                       <a:srgbClr val="000000"/>
                     </a:solidFill>
@@ -10695,7 +10700,7 @@
               </a:ln>
               <a:extLst>
                 <a:ext uri="{91240B29-F687-4f45-9708-019B960494DF}">
-                  <a14:hiddenLine xmlns:a14="http://schemas.microsoft.com/office/drawing/2010/main" xmlns="" w="9525">
+                  <a14:hiddenLine xmlns="" xmlns:a14="http://schemas.microsoft.com/office/drawing/2010/main" w="9525">
                     <a:solidFill>
                       <a:srgbClr val="000000"/>
                     </a:solidFill>
@@ -10767,7 +10772,7 @@
               </a:ln>
               <a:extLst>
                 <a:ext uri="{91240B29-F687-4f45-9708-019B960494DF}">
-                  <a14:hiddenLine xmlns:a14="http://schemas.microsoft.com/office/drawing/2010/main" xmlns="" w="9525">
+                  <a14:hiddenLine xmlns="" xmlns:a14="http://schemas.microsoft.com/office/drawing/2010/main" w="9525">
                     <a:solidFill>
                       <a:srgbClr val="000000"/>
                     </a:solidFill>
@@ -10864,7 +10869,7 @@
               </a:ln>
               <a:extLst>
                 <a:ext uri="{91240B29-F687-4f45-9708-019B960494DF}">
-                  <a14:hiddenLine xmlns:a14="http://schemas.microsoft.com/office/drawing/2010/main" xmlns="" w="9525">
+                  <a14:hiddenLine xmlns="" xmlns:a14="http://schemas.microsoft.com/office/drawing/2010/main" w="9525">
                     <a:solidFill>
                       <a:srgbClr val="000000"/>
                     </a:solidFill>
@@ -10933,7 +10938,7 @@
               </a:ln>
               <a:extLst>
                 <a:ext uri="{91240B29-F687-4f45-9708-019B960494DF}">
-                  <a14:hiddenLine xmlns:a14="http://schemas.microsoft.com/office/drawing/2010/main" xmlns="" w="9525">
+                  <a14:hiddenLine xmlns="" xmlns:a14="http://schemas.microsoft.com/office/drawing/2010/main" w="9525">
                     <a:solidFill>
                       <a:srgbClr val="000000"/>
                     </a:solidFill>
@@ -11030,7 +11035,7 @@
               </a:ln>
               <a:extLst>
                 <a:ext uri="{91240B29-F687-4f45-9708-019B960494DF}">
-                  <a14:hiddenLine xmlns:a14="http://schemas.microsoft.com/office/drawing/2010/main" xmlns="" w="9525">
+                  <a14:hiddenLine xmlns="" xmlns:a14="http://schemas.microsoft.com/office/drawing/2010/main" w="9525">
                     <a:solidFill>
                       <a:srgbClr val="000000"/>
                     </a:solidFill>
@@ -11102,7 +11107,7 @@
               </a:ln>
               <a:extLst>
                 <a:ext uri="{91240B29-F687-4f45-9708-019B960494DF}">
-                  <a14:hiddenLine xmlns:a14="http://schemas.microsoft.com/office/drawing/2010/main" xmlns="" w="9525">
+                  <a14:hiddenLine xmlns="" xmlns:a14="http://schemas.microsoft.com/office/drawing/2010/main" w="9525">
                     <a:solidFill>
                       <a:srgbClr val="000000"/>
                     </a:solidFill>
@@ -11171,7 +11176,7 @@
               </a:ln>
               <a:extLst>
                 <a:ext uri="{91240B29-F687-4f45-9708-019B960494DF}">
-                  <a14:hiddenLine xmlns:a14="http://schemas.microsoft.com/office/drawing/2010/main" xmlns="" w="9525">
+                  <a14:hiddenLine xmlns="" xmlns:a14="http://schemas.microsoft.com/office/drawing/2010/main" w="9525">
                     <a:solidFill>
                       <a:srgbClr val="000000"/>
                     </a:solidFill>
@@ -11268,7 +11273,7 @@
               </a:ln>
               <a:extLst>
                 <a:ext uri="{91240B29-F687-4f45-9708-019B960494DF}">
-                  <a14:hiddenLine xmlns:a14="http://schemas.microsoft.com/office/drawing/2010/main" xmlns="" w="9525">
+                  <a14:hiddenLine xmlns="" xmlns:a14="http://schemas.microsoft.com/office/drawing/2010/main" w="9525">
                     <a:solidFill>
                       <a:srgbClr val="000000"/>
                     </a:solidFill>
@@ -11365,7 +11370,7 @@
               </a:ln>
               <a:extLst>
                 <a:ext uri="{91240B29-F687-4f45-9708-019B960494DF}">
-                  <a14:hiddenLine xmlns:a14="http://schemas.microsoft.com/office/drawing/2010/main" xmlns="" w="9525">
+                  <a14:hiddenLine xmlns="" xmlns:a14="http://schemas.microsoft.com/office/drawing/2010/main" w="9525">
                     <a:solidFill>
                       <a:srgbClr val="000000"/>
                     </a:solidFill>
@@ -11437,7 +11442,7 @@
               </a:ln>
               <a:extLst>
                 <a:ext uri="{91240B29-F687-4f45-9708-019B960494DF}">
-                  <a14:hiddenLine xmlns:a14="http://schemas.microsoft.com/office/drawing/2010/main" xmlns="" w="9525">
+                  <a14:hiddenLine xmlns="" xmlns:a14="http://schemas.microsoft.com/office/drawing/2010/main" w="9525">
                     <a:solidFill>
                       <a:srgbClr val="000000"/>
                     </a:solidFill>
@@ -11564,7 +11569,7 @@
               </a:ln>
               <a:extLst>
                 <a:ext uri="{91240B29-F687-4f45-9708-019B960494DF}">
-                  <a14:hiddenLine xmlns:a14="http://schemas.microsoft.com/office/drawing/2010/main" xmlns="" w="9525">
+                  <a14:hiddenLine xmlns="" xmlns:a14="http://schemas.microsoft.com/office/drawing/2010/main" w="9525">
                     <a:solidFill>
                       <a:srgbClr val="000000"/>
                     </a:solidFill>
@@ -11669,7 +11674,7 @@
               </a:ln>
               <a:extLst>
                 <a:ext uri="{91240B29-F687-4f45-9708-019B960494DF}">
-                  <a14:hiddenLine xmlns:a14="http://schemas.microsoft.com/office/drawing/2010/main" xmlns="" w="9525">
+                  <a14:hiddenLine xmlns="" xmlns:a14="http://schemas.microsoft.com/office/drawing/2010/main" w="9525">
                     <a:solidFill>
                       <a:srgbClr val="000000"/>
                     </a:solidFill>
@@ -11791,7 +11796,7 @@
               </a:ln>
               <a:extLst>
                 <a:ext uri="{91240B29-F687-4f45-9708-019B960494DF}">
-                  <a14:hiddenLine xmlns:a14="http://schemas.microsoft.com/office/drawing/2010/main" xmlns="" w="9525">
+                  <a14:hiddenLine xmlns="" xmlns:a14="http://schemas.microsoft.com/office/drawing/2010/main" w="9525">
                     <a:solidFill>
                       <a:srgbClr val="000000"/>
                     </a:solidFill>
@@ -11888,7 +11893,7 @@
               </a:ln>
               <a:extLst>
                 <a:ext uri="{91240B29-F687-4f45-9708-019B960494DF}">
-                  <a14:hiddenLine xmlns:a14="http://schemas.microsoft.com/office/drawing/2010/main" xmlns="" w="9525">
+                  <a14:hiddenLine xmlns="" xmlns:a14="http://schemas.microsoft.com/office/drawing/2010/main" w="9525">
                     <a:solidFill>
                       <a:srgbClr val="000000"/>
                     </a:solidFill>
@@ -11960,7 +11965,7 @@
               </a:ln>
               <a:extLst>
                 <a:ext uri="{91240B29-F687-4f45-9708-019B960494DF}">
-                  <a14:hiddenLine xmlns:a14="http://schemas.microsoft.com/office/drawing/2010/main" xmlns="" w="9525">
+                  <a14:hiddenLine xmlns="" xmlns:a14="http://schemas.microsoft.com/office/drawing/2010/main" w="9525">
                     <a:solidFill>
                       <a:srgbClr val="000000"/>
                     </a:solidFill>
@@ -12057,7 +12062,7 @@
               </a:ln>
               <a:extLst>
                 <a:ext uri="{91240B29-F687-4f45-9708-019B960494DF}">
-                  <a14:hiddenLine xmlns:a14="http://schemas.microsoft.com/office/drawing/2010/main" xmlns="" w="9525">
+                  <a14:hiddenLine xmlns="" xmlns:a14="http://schemas.microsoft.com/office/drawing/2010/main" w="9525">
                     <a:solidFill>
                       <a:srgbClr val="000000"/>
                     </a:solidFill>
@@ -12132,7 +12137,7 @@
               </a:ln>
               <a:extLst>
                 <a:ext uri="{91240B29-F687-4f45-9708-019B960494DF}">
-                  <a14:hiddenLine xmlns:a14="http://schemas.microsoft.com/office/drawing/2010/main" xmlns="" w="9525">
+                  <a14:hiddenLine xmlns="" xmlns:a14="http://schemas.microsoft.com/office/drawing/2010/main" w="9525">
                     <a:solidFill>
                       <a:srgbClr val="000000"/>
                     </a:solidFill>
@@ -12229,7 +12234,7 @@
               </a:ln>
               <a:extLst>
                 <a:ext uri="{91240B29-F687-4f45-9708-019B960494DF}">
-                  <a14:hiddenLine xmlns:a14="http://schemas.microsoft.com/office/drawing/2010/main" xmlns="" w="9525">
+                  <a14:hiddenLine xmlns="" xmlns:a14="http://schemas.microsoft.com/office/drawing/2010/main" w="9525">
                     <a:solidFill>
                       <a:srgbClr val="000000"/>
                     </a:solidFill>
@@ -12304,7 +12309,7 @@
               </a:ln>
               <a:extLst>
                 <a:ext uri="{91240B29-F687-4f45-9708-019B960494DF}">
-                  <a14:hiddenLine xmlns:a14="http://schemas.microsoft.com/office/drawing/2010/main" xmlns="" w="9525">
+                  <a14:hiddenLine xmlns="" xmlns:a14="http://schemas.microsoft.com/office/drawing/2010/main" w="9525">
                     <a:solidFill>
                       <a:srgbClr val="000000"/>
                     </a:solidFill>
@@ -12401,7 +12406,7 @@
               </a:ln>
               <a:extLst>
                 <a:ext uri="{91240B29-F687-4f45-9708-019B960494DF}">
-                  <a14:hiddenLine xmlns:a14="http://schemas.microsoft.com/office/drawing/2010/main" xmlns="" w="9525">
+                  <a14:hiddenLine xmlns="" xmlns:a14="http://schemas.microsoft.com/office/drawing/2010/main" w="9525">
                     <a:solidFill>
                       <a:srgbClr val="000000"/>
                     </a:solidFill>
@@ -12442,7 +12447,7 @@
               </a:ln>
               <a:extLst>
                 <a:ext uri="{91240B29-F687-4f45-9708-019B960494DF}">
-                  <a14:hiddenLine xmlns:a14="http://schemas.microsoft.com/office/drawing/2010/main" xmlns="" w="9525">
+                  <a14:hiddenLine xmlns="" xmlns:a14="http://schemas.microsoft.com/office/drawing/2010/main" w="9525">
                     <a:solidFill>
                       <a:srgbClr val="000000"/>
                     </a:solidFill>
@@ -12590,7 +12595,7 @@
             <a:fld id="{48A87A34-81AB-432B-8DAE-1953F412C126}" type="datetimeFigureOut">
               <a:rPr lang="en-US" dirty="0"/>
               <a:pPr/>
-              <a:t>4/6/2026</a:t>
+              <a:t>4/7/2026</a:t>
             </a:fld>
             <a:endParaRPr lang="en-US" dirty="0"/>
           </a:p>
@@ -17048,12 +17053,7 @@
             <p:ph type="title"/>
           </p:nvPr>
         </p:nvSpPr>
-        <p:spPr>
-          <a:xfrm>
-            <a:off x="1143001" y="2511486"/>
-            <a:ext cx="9905998" cy="1478570"/>
-          </a:xfrm>
-        </p:spPr>
+        <p:spPr/>
         <p:txBody>
           <a:bodyPr>
             <a:noAutofit/>
@@ -17069,6 +17069,42 @@
               <a:rPr lang="en-GB" sz="6000" dirty="0"/>
             </a:br>
             <a:endParaRPr lang="en-GB" sz="6000" dirty="0"/>
+          </a:p>
+        </p:txBody>
+      </p:sp>
+      <p:sp>
+        <p:nvSpPr>
+          <p:cNvPr id="3" name="Content Placeholder 2">
+            <a:extLst>
+              <a:ext uri="{FF2B5EF4-FFF2-40B4-BE49-F238E27FC236}">
+                <a16:creationId xmlns:a16="http://schemas.microsoft.com/office/drawing/2014/main" id="{0B21F28B-65B0-9C0D-3991-A93B69D3E1F6}"/>
+              </a:ext>
+            </a:extLst>
+          </p:cNvPr>
+          <p:cNvSpPr>
+            <a:spLocks noGrp="1"/>
+          </p:cNvSpPr>
+          <p:nvPr>
+            <p:ph idx="1"/>
+          </p:nvPr>
+        </p:nvSpPr>
+        <p:spPr/>
+        <p:txBody>
+          <a:bodyPr>
+            <a:normAutofit/>
+          </a:bodyPr>
+          <a:lstStyle/>
+          <a:p>
+            <a:r>
+              <a:rPr lang="en-GB" sz="4000" dirty="0"/>
+              <a:t>Functional Requirements</a:t>
+            </a:r>
+          </a:p>
+          <a:p>
+            <a:r>
+              <a:rPr lang="en-GB" sz="4000" dirty="0"/>
+              <a:t>Non – functional requirements</a:t>
+            </a:r>
           </a:p>
         </p:txBody>
       </p:sp>
@@ -19065,12 +19101,12 @@
                         <a:buNone/>
                       </a:pPr>
                       <a:r>
-                        <a:rPr lang="en-GB" sz="2400" kern="100">
+                        <a:rPr lang="en-GB" sz="2400" kern="100" dirty="0">
                           <a:effectLst/>
                         </a:rPr>
                         <a:t>$5k–$50k</a:t>
                       </a:r>
-                      <a:endParaRPr lang="en-GB" sz="2400" kern="100">
+                      <a:endParaRPr lang="en-GB" sz="2400" kern="100" dirty="0">
                         <a:effectLst/>
                         <a:latin typeface="Aptos" panose="020B0004020202020204" pitchFamily="34" charset="0"/>
                         <a:ea typeface="Aptos" panose="020B0004020202020204" pitchFamily="34" charset="0"/>
@@ -19095,12 +19131,12 @@
                         <a:buNone/>
                       </a:pPr>
                       <a:r>
-                        <a:rPr lang="en-GB" sz="2400" kern="100">
+                        <a:rPr lang="en-GB" sz="2400" kern="100" dirty="0">
                           <a:effectLst/>
                         </a:rPr>
                         <a:t>$50k–$120k</a:t>
                       </a:r>
-                      <a:endParaRPr lang="en-GB" sz="2400" kern="100">
+                      <a:endParaRPr lang="en-GB" sz="2400" kern="100" dirty="0">
                         <a:effectLst/>
                         <a:latin typeface="Aptos" panose="020B0004020202020204" pitchFamily="34" charset="0"/>
                         <a:ea typeface="Aptos" panose="020B0004020202020204" pitchFamily="34" charset="0"/>
@@ -20334,7 +20370,7 @@
           <a:p>
             <a:r>
               <a:rPr lang="en-GB" sz="4000" dirty="0"/>
-              <a:t>What is a native app?</a:t>
+              <a:t>What is a progressive app?</a:t>
             </a:r>
           </a:p>
           <a:p>
@@ -20346,13 +20382,13 @@
           <a:p>
             <a:r>
               <a:rPr lang="en-GB" sz="4000" dirty="0"/>
-              <a:t>Advantages of native apps</a:t>
+              <a:t>Advantages </a:t>
             </a:r>
           </a:p>
           <a:p>
             <a:r>
               <a:rPr lang="en-GB" sz="4000" dirty="0"/>
-              <a:t>Disadvantages of native apps</a:t>
+              <a:t>Disadvantages </a:t>
             </a:r>
           </a:p>
           <a:p>
@@ -20443,7 +20479,7 @@
           <a:p>
             <a:r>
               <a:rPr lang="en-GB" sz="4000" dirty="0"/>
-              <a:t>What is a native app?</a:t>
+              <a:t>What is a hybrid app?</a:t>
             </a:r>
           </a:p>
           <a:p>
@@ -20455,13 +20491,13 @@
           <a:p>
             <a:r>
               <a:rPr lang="en-GB" sz="4000" dirty="0"/>
-              <a:t>Advantages of native apps</a:t>
+              <a:t>Advantages </a:t>
             </a:r>
           </a:p>
           <a:p>
             <a:r>
               <a:rPr lang="en-GB" sz="4000" dirty="0"/>
-              <a:t>Disadvantages of native apps</a:t>
+              <a:t>Disadvantages</a:t>
             </a:r>
           </a:p>
           <a:p>

</xml_diff>

<commit_message>
Add report for task 2
</commit_message>
<xml_diff>
--- a/Task 1/TASK 1 PowerPoint.pptx
+++ b/Task 1/TASK 1 PowerPoint.pptx
@@ -14,24 +14,19 @@
     <p:sldId id="262" r:id="rId8"/>
     <p:sldId id="263" r:id="rId9"/>
     <p:sldId id="264" r:id="rId10"/>
-    <p:sldId id="265" r:id="rId11"/>
-    <p:sldId id="266" r:id="rId12"/>
-    <p:sldId id="267" r:id="rId13"/>
-    <p:sldId id="268" r:id="rId14"/>
-    <p:sldId id="269" r:id="rId15"/>
-    <p:sldId id="270" r:id="rId16"/>
-    <p:sldId id="271" r:id="rId17"/>
-    <p:sldId id="272" r:id="rId18"/>
-    <p:sldId id="273" r:id="rId19"/>
-    <p:sldId id="274" r:id="rId20"/>
-    <p:sldId id="275" r:id="rId21"/>
-    <p:sldId id="276" r:id="rId22"/>
-    <p:sldId id="277" r:id="rId23"/>
-    <p:sldId id="278" r:id="rId24"/>
-    <p:sldId id="279" r:id="rId25"/>
-    <p:sldId id="280" r:id="rId26"/>
-    <p:sldId id="281" r:id="rId27"/>
-    <p:sldId id="282" r:id="rId28"/>
+    <p:sldId id="271" r:id="rId11"/>
+    <p:sldId id="272" r:id="rId12"/>
+    <p:sldId id="273" r:id="rId13"/>
+    <p:sldId id="274" r:id="rId14"/>
+    <p:sldId id="283" r:id="rId15"/>
+    <p:sldId id="275" r:id="rId16"/>
+    <p:sldId id="276" r:id="rId17"/>
+    <p:sldId id="277" r:id="rId18"/>
+    <p:sldId id="278" r:id="rId19"/>
+    <p:sldId id="279" r:id="rId20"/>
+    <p:sldId id="280" r:id="rId21"/>
+    <p:sldId id="281" r:id="rId22"/>
+    <p:sldId id="282" r:id="rId23"/>
   </p:sldIdLst>
   <p:sldSz cx="12192000" cy="6858000"/>
   <p:notesSz cx="6858000" cy="9144000"/>
@@ -4792,7 +4787,7 @@
           <a:p>
             <a:fld id="{48A87A34-81AB-432B-8DAE-1953F412C126}" type="datetimeFigureOut">
               <a:rPr lang="en-US" dirty="0"/>
-              <a:t>4/7/2026</a:t>
+              <a:t>4/14/2026</a:t>
             </a:fld>
             <a:endParaRPr lang="en-US" dirty="0"/>
           </a:p>
@@ -5054,7 +5049,7 @@
           <a:p>
             <a:fld id="{48A87A34-81AB-432B-8DAE-1953F412C126}" type="datetimeFigureOut">
               <a:rPr lang="en-US" dirty="0"/>
-              <a:t>4/7/2026</a:t>
+              <a:t>4/14/2026</a:t>
             </a:fld>
             <a:endParaRPr lang="en-US" dirty="0"/>
           </a:p>
@@ -5245,7 +5240,7 @@
           <a:p>
             <a:fld id="{48A87A34-81AB-432B-8DAE-1953F412C126}" type="datetimeFigureOut">
               <a:rPr lang="en-US" dirty="0"/>
-              <a:t>4/7/2026</a:t>
+              <a:t>4/14/2026</a:t>
             </a:fld>
             <a:endParaRPr lang="en-US" dirty="0"/>
           </a:p>
@@ -5503,7 +5498,7 @@
           <a:p>
             <a:fld id="{48A87A34-81AB-432B-8DAE-1953F412C126}" type="datetimeFigureOut">
               <a:rPr lang="en-US" dirty="0"/>
-              <a:t>4/7/2026</a:t>
+              <a:t>4/14/2026</a:t>
             </a:fld>
             <a:endParaRPr lang="en-US" dirty="0"/>
           </a:p>
@@ -5932,7 +5927,7 @@
           <a:p>
             <a:fld id="{48A87A34-81AB-432B-8DAE-1953F412C126}" type="datetimeFigureOut">
               <a:rPr lang="en-US" dirty="0"/>
-              <a:t>4/7/2026</a:t>
+              <a:t>4/14/2026</a:t>
             </a:fld>
             <a:endParaRPr lang="en-US" dirty="0"/>
           </a:p>
@@ -6473,7 +6468,7 @@
           <a:p>
             <a:fld id="{48A87A34-81AB-432B-8DAE-1953F412C126}" type="datetimeFigureOut">
               <a:rPr lang="en-US" dirty="0"/>
-              <a:t>4/7/2026</a:t>
+              <a:t>4/14/2026</a:t>
             </a:fld>
             <a:endParaRPr lang="en-US" dirty="0"/>
           </a:p>
@@ -7188,7 +7183,7 @@
           <a:p>
             <a:fld id="{48A87A34-81AB-432B-8DAE-1953F412C126}" type="datetimeFigureOut">
               <a:rPr lang="en-US" dirty="0"/>
-              <a:t>4/7/2026</a:t>
+              <a:t>4/14/2026</a:t>
             </a:fld>
             <a:endParaRPr lang="en-US" dirty="0"/>
           </a:p>
@@ -7353,7 +7348,7 @@
           <a:p>
             <a:fld id="{48A87A34-81AB-432B-8DAE-1953F412C126}" type="datetimeFigureOut">
               <a:rPr lang="en-US" dirty="0"/>
-              <a:t>4/7/2026</a:t>
+              <a:t>4/14/2026</a:t>
             </a:fld>
             <a:endParaRPr lang="en-US" dirty="0"/>
           </a:p>
@@ -7528,7 +7523,7 @@
           <a:p>
             <a:fld id="{48A87A34-81AB-432B-8DAE-1953F412C126}" type="datetimeFigureOut">
               <a:rPr lang="en-US" dirty="0"/>
-              <a:t>4/7/2026</a:t>
+              <a:t>4/14/2026</a:t>
             </a:fld>
             <a:endParaRPr lang="en-US" dirty="0"/>
           </a:p>
@@ -7693,7 +7688,7 @@
           <a:p>
             <a:fld id="{48A87A34-81AB-432B-8DAE-1953F412C126}" type="datetimeFigureOut">
               <a:rPr lang="en-US" dirty="0"/>
-              <a:t>4/7/2026</a:t>
+              <a:t>4/14/2026</a:t>
             </a:fld>
             <a:endParaRPr lang="en-US" dirty="0"/>
           </a:p>
@@ -7938,7 +7933,7 @@
           <a:p>
             <a:fld id="{48A87A34-81AB-432B-8DAE-1953F412C126}" type="datetimeFigureOut">
               <a:rPr lang="en-US" dirty="0"/>
-              <a:t>4/7/2026</a:t>
+              <a:t>4/14/2026</a:t>
             </a:fld>
             <a:endParaRPr lang="en-US" dirty="0"/>
           </a:p>
@@ -8165,7 +8160,7 @@
           <a:p>
             <a:fld id="{48A87A34-81AB-432B-8DAE-1953F412C126}" type="datetimeFigureOut">
               <a:rPr lang="en-US" dirty="0"/>
-              <a:t>4/7/2026</a:t>
+              <a:t>4/14/2026</a:t>
             </a:fld>
             <a:endParaRPr lang="en-US" dirty="0"/>
           </a:p>
@@ -8541,7 +8536,7 @@
           <a:p>
             <a:fld id="{48A87A34-81AB-432B-8DAE-1953F412C126}" type="datetimeFigureOut">
               <a:rPr lang="en-US" dirty="0"/>
-              <a:t>4/7/2026</a:t>
+              <a:t>4/14/2026</a:t>
             </a:fld>
             <a:endParaRPr lang="en-US" dirty="0"/>
           </a:p>
@@ -8654,7 +8649,7 @@
           <a:p>
             <a:fld id="{48A87A34-81AB-432B-8DAE-1953F412C126}" type="datetimeFigureOut">
               <a:rPr lang="en-US" dirty="0"/>
-              <a:t>4/7/2026</a:t>
+              <a:t>4/14/2026</a:t>
             </a:fld>
             <a:endParaRPr lang="en-US" dirty="0"/>
           </a:p>
@@ -8744,7 +8739,7 @@
           <a:p>
             <a:fld id="{48A87A34-81AB-432B-8DAE-1953F412C126}" type="datetimeFigureOut">
               <a:rPr lang="en-US" dirty="0"/>
-              <a:t>4/7/2026</a:t>
+              <a:t>4/14/2026</a:t>
             </a:fld>
             <a:endParaRPr lang="en-US" dirty="0"/>
           </a:p>
@@ -8988,7 +8983,7 @@
           <a:p>
             <a:fld id="{48A87A34-81AB-432B-8DAE-1953F412C126}" type="datetimeFigureOut">
               <a:rPr lang="en-US" dirty="0"/>
-              <a:t>4/7/2026</a:t>
+              <a:t>4/14/2026</a:t>
             </a:fld>
             <a:endParaRPr lang="en-US" dirty="0"/>
           </a:p>
@@ -9263,7 +9258,7 @@
           <a:p>
             <a:fld id="{48A87A34-81AB-432B-8DAE-1953F412C126}" type="datetimeFigureOut">
               <a:rPr lang="en-US" dirty="0"/>
-              <a:t>4/7/2026</a:t>
+              <a:t>4/14/2026</a:t>
             </a:fld>
             <a:endParaRPr lang="en-US" dirty="0"/>
           </a:p>
@@ -12595,7 +12590,7 @@
             <a:fld id="{48A87A34-81AB-432B-8DAE-1953F412C126}" type="datetimeFigureOut">
               <a:rPr lang="en-US" dirty="0"/>
               <a:pPr/>
-              <a:t>4/7/2026</a:t>
+              <a:t>4/14/2026</a:t>
             </a:fld>
             <a:endParaRPr lang="en-US" dirty="0"/>
           </a:p>
@@ -13129,659 +13124,6 @@
           <p:cNvPr id="2" name="Title 1">
             <a:extLst>
               <a:ext uri="{FF2B5EF4-FFF2-40B4-BE49-F238E27FC236}">
-                <a16:creationId xmlns:a16="http://schemas.microsoft.com/office/drawing/2014/main" id="{B54245BD-5D25-7A2A-9633-17DFB3519D0F}"/>
-              </a:ext>
-            </a:extLst>
-          </p:cNvPr>
-          <p:cNvSpPr>
-            <a:spLocks noGrp="1"/>
-          </p:cNvSpPr>
-          <p:nvPr>
-            <p:ph type="title"/>
-          </p:nvPr>
-        </p:nvSpPr>
-        <p:spPr/>
-        <p:txBody>
-          <a:bodyPr>
-            <a:normAutofit/>
-          </a:bodyPr>
-          <a:lstStyle/>
-          <a:p>
-            <a:r>
-              <a:rPr lang="en-GB" sz="6000" dirty="0"/>
-              <a:t>KOTLIN</a:t>
-            </a:r>
-          </a:p>
-        </p:txBody>
-      </p:sp>
-      <p:sp>
-        <p:nvSpPr>
-          <p:cNvPr id="3" name="Content Placeholder 2">
-            <a:extLst>
-              <a:ext uri="{FF2B5EF4-FFF2-40B4-BE49-F238E27FC236}">
-                <a16:creationId xmlns:a16="http://schemas.microsoft.com/office/drawing/2014/main" id="{79D7365C-5D65-D095-60A9-36B0BA085062}"/>
-              </a:ext>
-            </a:extLst>
-          </p:cNvPr>
-          <p:cNvSpPr>
-            <a:spLocks noGrp="1"/>
-          </p:cNvSpPr>
-          <p:nvPr>
-            <p:ph idx="1"/>
-          </p:nvPr>
-        </p:nvSpPr>
-        <p:spPr/>
-        <p:txBody>
-          <a:bodyPr/>
-          <a:lstStyle/>
-          <a:p>
-            <a:r>
-              <a:rPr lang="en-GB" sz="4000" dirty="0"/>
-              <a:t>Primary platform</a:t>
-            </a:r>
-          </a:p>
-          <a:p>
-            <a:r>
-              <a:rPr lang="en-GB" sz="4000" dirty="0"/>
-              <a:t>Key advantage</a:t>
-            </a:r>
-          </a:p>
-          <a:p>
-            <a:r>
-              <a:rPr lang="en-GB" sz="4000" dirty="0"/>
-              <a:t>Limitation</a:t>
-            </a:r>
-          </a:p>
-          <a:p>
-            <a:r>
-              <a:rPr lang="en-GB" sz="4000" dirty="0"/>
-              <a:t>Typical use case</a:t>
-            </a:r>
-          </a:p>
-          <a:p>
-            <a:endParaRPr lang="en-GB" dirty="0"/>
-          </a:p>
-        </p:txBody>
-      </p:sp>
-    </p:spTree>
-    <p:extLst>
-      <p:ext uri="{BB962C8B-B14F-4D97-AF65-F5344CB8AC3E}">
-        <p14:creationId xmlns:p14="http://schemas.microsoft.com/office/powerpoint/2010/main" val="1382506120"/>
-      </p:ext>
-    </p:extLst>
-  </p:cSld>
-  <p:clrMapOvr>
-    <a:masterClrMapping/>
-  </p:clrMapOvr>
-</p:sld>
-</file>
-
-<file path=ppt/slides/slide11.xml><?xml version="1.0" encoding="utf-8"?>
-<p:sld xmlns:a="http://schemas.openxmlformats.org/drawingml/2006/main" xmlns:r="http://schemas.openxmlformats.org/officeDocument/2006/relationships" xmlns:p="http://schemas.openxmlformats.org/presentationml/2006/main">
-  <p:cSld>
-    <p:spTree>
-      <p:nvGrpSpPr>
-        <p:cNvPr id="1" name=""/>
-        <p:cNvGrpSpPr/>
-        <p:nvPr/>
-      </p:nvGrpSpPr>
-      <p:grpSpPr>
-        <a:xfrm>
-          <a:off x="0" y="0"/>
-          <a:ext cx="0" cy="0"/>
-          <a:chOff x="0" y="0"/>
-          <a:chExt cx="0" cy="0"/>
-        </a:xfrm>
-      </p:grpSpPr>
-      <p:sp>
-        <p:nvSpPr>
-          <p:cNvPr id="2" name="Title 1">
-            <a:extLst>
-              <a:ext uri="{FF2B5EF4-FFF2-40B4-BE49-F238E27FC236}">
-                <a16:creationId xmlns:a16="http://schemas.microsoft.com/office/drawing/2014/main" id="{13A4A2BF-8978-47B2-0FFC-891A686BF76D}"/>
-              </a:ext>
-            </a:extLst>
-          </p:cNvPr>
-          <p:cNvSpPr>
-            <a:spLocks noGrp="1"/>
-          </p:cNvSpPr>
-          <p:nvPr>
-            <p:ph type="title"/>
-          </p:nvPr>
-        </p:nvSpPr>
-        <p:spPr/>
-        <p:txBody>
-          <a:bodyPr>
-            <a:normAutofit/>
-          </a:bodyPr>
-          <a:lstStyle/>
-          <a:p>
-            <a:r>
-              <a:rPr lang="en-GB" sz="6000" dirty="0"/>
-              <a:t>SWIFT</a:t>
-            </a:r>
-          </a:p>
-        </p:txBody>
-      </p:sp>
-      <p:sp>
-        <p:nvSpPr>
-          <p:cNvPr id="3" name="Content Placeholder 2">
-            <a:extLst>
-              <a:ext uri="{FF2B5EF4-FFF2-40B4-BE49-F238E27FC236}">
-                <a16:creationId xmlns:a16="http://schemas.microsoft.com/office/drawing/2014/main" id="{511DABBF-02F4-0791-6481-BB789579240F}"/>
-              </a:ext>
-            </a:extLst>
-          </p:cNvPr>
-          <p:cNvSpPr>
-            <a:spLocks noGrp="1"/>
-          </p:cNvSpPr>
-          <p:nvPr>
-            <p:ph idx="1"/>
-          </p:nvPr>
-        </p:nvSpPr>
-        <p:spPr/>
-        <p:txBody>
-          <a:bodyPr>
-            <a:normAutofit/>
-          </a:bodyPr>
-          <a:lstStyle/>
-          <a:p>
-            <a:r>
-              <a:rPr lang="en-GB" sz="4000" dirty="0"/>
-              <a:t>Primary platform</a:t>
-            </a:r>
-          </a:p>
-          <a:p>
-            <a:r>
-              <a:rPr lang="en-GB" sz="4000" dirty="0"/>
-              <a:t>Key advantage</a:t>
-            </a:r>
-          </a:p>
-          <a:p>
-            <a:r>
-              <a:rPr lang="en-GB" sz="4000" dirty="0"/>
-              <a:t>Limitation</a:t>
-            </a:r>
-          </a:p>
-          <a:p>
-            <a:r>
-              <a:rPr lang="en-GB" sz="4000" dirty="0"/>
-              <a:t>Typical use case</a:t>
-            </a:r>
-          </a:p>
-        </p:txBody>
-      </p:sp>
-    </p:spTree>
-    <p:extLst>
-      <p:ext uri="{BB962C8B-B14F-4D97-AF65-F5344CB8AC3E}">
-        <p14:creationId xmlns:p14="http://schemas.microsoft.com/office/powerpoint/2010/main" val="161738847"/>
-      </p:ext>
-    </p:extLst>
-  </p:cSld>
-  <p:clrMapOvr>
-    <a:masterClrMapping/>
-  </p:clrMapOvr>
-</p:sld>
-</file>
-
-<file path=ppt/slides/slide12.xml><?xml version="1.0" encoding="utf-8"?>
-<p:sld xmlns:a="http://schemas.openxmlformats.org/drawingml/2006/main" xmlns:r="http://schemas.openxmlformats.org/officeDocument/2006/relationships" xmlns:p="http://schemas.openxmlformats.org/presentationml/2006/main">
-  <p:cSld>
-    <p:spTree>
-      <p:nvGrpSpPr>
-        <p:cNvPr id="1" name=""/>
-        <p:cNvGrpSpPr/>
-        <p:nvPr/>
-      </p:nvGrpSpPr>
-      <p:grpSpPr>
-        <a:xfrm>
-          <a:off x="0" y="0"/>
-          <a:ext cx="0" cy="0"/>
-          <a:chOff x="0" y="0"/>
-          <a:chExt cx="0" cy="0"/>
-        </a:xfrm>
-      </p:grpSpPr>
-      <p:sp>
-        <p:nvSpPr>
-          <p:cNvPr id="2" name="Title 1">
-            <a:extLst>
-              <a:ext uri="{FF2B5EF4-FFF2-40B4-BE49-F238E27FC236}">
-                <a16:creationId xmlns:a16="http://schemas.microsoft.com/office/drawing/2014/main" id="{3181E15C-57F4-1D60-7F29-CC9A3B9E315E}"/>
-              </a:ext>
-            </a:extLst>
-          </p:cNvPr>
-          <p:cNvSpPr>
-            <a:spLocks noGrp="1"/>
-          </p:cNvSpPr>
-          <p:nvPr>
-            <p:ph type="title"/>
-          </p:nvPr>
-        </p:nvSpPr>
-        <p:spPr/>
-        <p:txBody>
-          <a:bodyPr>
-            <a:normAutofit/>
-          </a:bodyPr>
-          <a:lstStyle/>
-          <a:p>
-            <a:r>
-              <a:rPr lang="en-GB" sz="6000" dirty="0"/>
-              <a:t>SWIFT</a:t>
-            </a:r>
-          </a:p>
-        </p:txBody>
-      </p:sp>
-      <p:sp>
-        <p:nvSpPr>
-          <p:cNvPr id="3" name="Content Placeholder 2">
-            <a:extLst>
-              <a:ext uri="{FF2B5EF4-FFF2-40B4-BE49-F238E27FC236}">
-                <a16:creationId xmlns:a16="http://schemas.microsoft.com/office/drawing/2014/main" id="{6908E11E-5656-99D3-44DD-FA49AC3DBD60}"/>
-              </a:ext>
-            </a:extLst>
-          </p:cNvPr>
-          <p:cNvSpPr>
-            <a:spLocks noGrp="1"/>
-          </p:cNvSpPr>
-          <p:nvPr>
-            <p:ph idx="1"/>
-          </p:nvPr>
-        </p:nvSpPr>
-        <p:spPr/>
-        <p:txBody>
-          <a:bodyPr/>
-          <a:lstStyle/>
-          <a:p>
-            <a:r>
-              <a:rPr lang="en-GB" sz="4000" dirty="0"/>
-              <a:t>Primary platform</a:t>
-            </a:r>
-          </a:p>
-          <a:p>
-            <a:r>
-              <a:rPr lang="en-GB" sz="4000" dirty="0"/>
-              <a:t>Key advantage</a:t>
-            </a:r>
-          </a:p>
-          <a:p>
-            <a:r>
-              <a:rPr lang="en-GB" sz="4000" dirty="0"/>
-              <a:t>Limitation</a:t>
-            </a:r>
-          </a:p>
-          <a:p>
-            <a:r>
-              <a:rPr lang="en-GB" sz="4000" dirty="0"/>
-              <a:t>Typical use case</a:t>
-            </a:r>
-          </a:p>
-          <a:p>
-            <a:endParaRPr lang="en-GB" dirty="0"/>
-          </a:p>
-        </p:txBody>
-      </p:sp>
-    </p:spTree>
-    <p:extLst>
-      <p:ext uri="{BB962C8B-B14F-4D97-AF65-F5344CB8AC3E}">
-        <p14:creationId xmlns:p14="http://schemas.microsoft.com/office/powerpoint/2010/main" val="4087601758"/>
-      </p:ext>
-    </p:extLst>
-  </p:cSld>
-  <p:clrMapOvr>
-    <a:masterClrMapping/>
-  </p:clrMapOvr>
-</p:sld>
-</file>
-
-<file path=ppt/slides/slide13.xml><?xml version="1.0" encoding="utf-8"?>
-<p:sld xmlns:a="http://schemas.openxmlformats.org/drawingml/2006/main" xmlns:r="http://schemas.openxmlformats.org/officeDocument/2006/relationships" xmlns:p="http://schemas.openxmlformats.org/presentationml/2006/main">
-  <p:cSld>
-    <p:spTree>
-      <p:nvGrpSpPr>
-        <p:cNvPr id="1" name=""/>
-        <p:cNvGrpSpPr/>
-        <p:nvPr/>
-      </p:nvGrpSpPr>
-      <p:grpSpPr>
-        <a:xfrm>
-          <a:off x="0" y="0"/>
-          <a:ext cx="0" cy="0"/>
-          <a:chOff x="0" y="0"/>
-          <a:chExt cx="0" cy="0"/>
-        </a:xfrm>
-      </p:grpSpPr>
-      <p:sp>
-        <p:nvSpPr>
-          <p:cNvPr id="2" name="Title 1">
-            <a:extLst>
-              <a:ext uri="{FF2B5EF4-FFF2-40B4-BE49-F238E27FC236}">
-                <a16:creationId xmlns:a16="http://schemas.microsoft.com/office/drawing/2014/main" id="{49A3BE72-9FAF-2721-2C81-9B9684A6C1D1}"/>
-              </a:ext>
-            </a:extLst>
-          </p:cNvPr>
-          <p:cNvSpPr>
-            <a:spLocks noGrp="1"/>
-          </p:cNvSpPr>
-          <p:nvPr>
-            <p:ph type="title"/>
-          </p:nvPr>
-        </p:nvSpPr>
-        <p:spPr/>
-        <p:txBody>
-          <a:bodyPr>
-            <a:normAutofit/>
-          </a:bodyPr>
-          <a:lstStyle/>
-          <a:p>
-            <a:r>
-              <a:rPr lang="en-GB" sz="6000" dirty="0"/>
-              <a:t>OBJECTIVE-C</a:t>
-            </a:r>
-          </a:p>
-        </p:txBody>
-      </p:sp>
-      <p:sp>
-        <p:nvSpPr>
-          <p:cNvPr id="3" name="Content Placeholder 2">
-            <a:extLst>
-              <a:ext uri="{FF2B5EF4-FFF2-40B4-BE49-F238E27FC236}">
-                <a16:creationId xmlns:a16="http://schemas.microsoft.com/office/drawing/2014/main" id="{0576C3EB-D94C-5F19-34C5-7E4341DACE7C}"/>
-              </a:ext>
-            </a:extLst>
-          </p:cNvPr>
-          <p:cNvSpPr>
-            <a:spLocks noGrp="1"/>
-          </p:cNvSpPr>
-          <p:nvPr>
-            <p:ph idx="1"/>
-          </p:nvPr>
-        </p:nvSpPr>
-        <p:spPr/>
-        <p:txBody>
-          <a:bodyPr/>
-          <a:lstStyle/>
-          <a:p>
-            <a:r>
-              <a:rPr lang="en-GB" sz="4000" dirty="0"/>
-              <a:t>Primary platform</a:t>
-            </a:r>
-          </a:p>
-          <a:p>
-            <a:r>
-              <a:rPr lang="en-GB" sz="4000" dirty="0"/>
-              <a:t>Key advantage</a:t>
-            </a:r>
-          </a:p>
-          <a:p>
-            <a:r>
-              <a:rPr lang="en-GB" sz="4000" dirty="0"/>
-              <a:t>Limitation</a:t>
-            </a:r>
-          </a:p>
-          <a:p>
-            <a:r>
-              <a:rPr lang="en-GB" sz="4000" dirty="0"/>
-              <a:t>Typical use case</a:t>
-            </a:r>
-          </a:p>
-          <a:p>
-            <a:endParaRPr lang="en-GB" dirty="0"/>
-          </a:p>
-        </p:txBody>
-      </p:sp>
-    </p:spTree>
-    <p:extLst>
-      <p:ext uri="{BB962C8B-B14F-4D97-AF65-F5344CB8AC3E}">
-        <p14:creationId xmlns:p14="http://schemas.microsoft.com/office/powerpoint/2010/main" val="2389066573"/>
-      </p:ext>
-    </p:extLst>
-  </p:cSld>
-  <p:clrMapOvr>
-    <a:masterClrMapping/>
-  </p:clrMapOvr>
-</p:sld>
-</file>
-
-<file path=ppt/slides/slide14.xml><?xml version="1.0" encoding="utf-8"?>
-<p:sld xmlns:a="http://schemas.openxmlformats.org/drawingml/2006/main" xmlns:r="http://schemas.openxmlformats.org/officeDocument/2006/relationships" xmlns:p="http://schemas.openxmlformats.org/presentationml/2006/main">
-  <p:cSld>
-    <p:spTree>
-      <p:nvGrpSpPr>
-        <p:cNvPr id="1" name=""/>
-        <p:cNvGrpSpPr/>
-        <p:nvPr/>
-      </p:nvGrpSpPr>
-      <p:grpSpPr>
-        <a:xfrm>
-          <a:off x="0" y="0"/>
-          <a:ext cx="0" cy="0"/>
-          <a:chOff x="0" y="0"/>
-          <a:chExt cx="0" cy="0"/>
-        </a:xfrm>
-      </p:grpSpPr>
-      <p:sp>
-        <p:nvSpPr>
-          <p:cNvPr id="2" name="Title 1">
-            <a:extLst>
-              <a:ext uri="{FF2B5EF4-FFF2-40B4-BE49-F238E27FC236}">
-                <a16:creationId xmlns:a16="http://schemas.microsoft.com/office/drawing/2014/main" id="{43EC3D9C-0353-2EE5-8345-591F20C50D09}"/>
-              </a:ext>
-            </a:extLst>
-          </p:cNvPr>
-          <p:cNvSpPr>
-            <a:spLocks noGrp="1"/>
-          </p:cNvSpPr>
-          <p:nvPr>
-            <p:ph type="title"/>
-          </p:nvPr>
-        </p:nvSpPr>
-        <p:spPr/>
-        <p:txBody>
-          <a:bodyPr>
-            <a:normAutofit/>
-          </a:bodyPr>
-          <a:lstStyle/>
-          <a:p>
-            <a:r>
-              <a:rPr lang="en-GB" sz="6000" dirty="0"/>
-              <a:t>DART</a:t>
-            </a:r>
-          </a:p>
-        </p:txBody>
-      </p:sp>
-      <p:sp>
-        <p:nvSpPr>
-          <p:cNvPr id="3" name="Content Placeholder 2">
-            <a:extLst>
-              <a:ext uri="{FF2B5EF4-FFF2-40B4-BE49-F238E27FC236}">
-                <a16:creationId xmlns:a16="http://schemas.microsoft.com/office/drawing/2014/main" id="{6CA503B2-66D4-E52A-63EC-2A6A69CDCEC3}"/>
-              </a:ext>
-            </a:extLst>
-          </p:cNvPr>
-          <p:cNvSpPr>
-            <a:spLocks noGrp="1"/>
-          </p:cNvSpPr>
-          <p:nvPr>
-            <p:ph idx="1"/>
-          </p:nvPr>
-        </p:nvSpPr>
-        <p:spPr/>
-        <p:txBody>
-          <a:bodyPr/>
-          <a:lstStyle/>
-          <a:p>
-            <a:r>
-              <a:rPr lang="en-GB" sz="4000" dirty="0"/>
-              <a:t>Primary platform</a:t>
-            </a:r>
-          </a:p>
-          <a:p>
-            <a:r>
-              <a:rPr lang="en-GB" sz="4000" dirty="0"/>
-              <a:t>Key advantage</a:t>
-            </a:r>
-          </a:p>
-          <a:p>
-            <a:r>
-              <a:rPr lang="en-GB" sz="4000" dirty="0"/>
-              <a:t>Limitation</a:t>
-            </a:r>
-          </a:p>
-          <a:p>
-            <a:r>
-              <a:rPr lang="en-GB" sz="4000" dirty="0"/>
-              <a:t>Typical use case</a:t>
-            </a:r>
-          </a:p>
-          <a:p>
-            <a:endParaRPr lang="en-GB" dirty="0"/>
-          </a:p>
-        </p:txBody>
-      </p:sp>
-    </p:spTree>
-    <p:extLst>
-      <p:ext uri="{BB962C8B-B14F-4D97-AF65-F5344CB8AC3E}">
-        <p14:creationId xmlns:p14="http://schemas.microsoft.com/office/powerpoint/2010/main" val="3823937231"/>
-      </p:ext>
-    </p:extLst>
-  </p:cSld>
-  <p:clrMapOvr>
-    <a:masterClrMapping/>
-  </p:clrMapOvr>
-</p:sld>
-</file>
-
-<file path=ppt/slides/slide15.xml><?xml version="1.0" encoding="utf-8"?>
-<p:sld xmlns:a="http://schemas.openxmlformats.org/drawingml/2006/main" xmlns:r="http://schemas.openxmlformats.org/officeDocument/2006/relationships" xmlns:p="http://schemas.openxmlformats.org/presentationml/2006/main">
-  <p:cSld>
-    <p:spTree>
-      <p:nvGrpSpPr>
-        <p:cNvPr id="1" name=""/>
-        <p:cNvGrpSpPr/>
-        <p:nvPr/>
-      </p:nvGrpSpPr>
-      <p:grpSpPr>
-        <a:xfrm>
-          <a:off x="0" y="0"/>
-          <a:ext cx="0" cy="0"/>
-          <a:chOff x="0" y="0"/>
-          <a:chExt cx="0" cy="0"/>
-        </a:xfrm>
-      </p:grpSpPr>
-      <p:sp>
-        <p:nvSpPr>
-          <p:cNvPr id="2" name="Title 1">
-            <a:extLst>
-              <a:ext uri="{FF2B5EF4-FFF2-40B4-BE49-F238E27FC236}">
-                <a16:creationId xmlns:a16="http://schemas.microsoft.com/office/drawing/2014/main" id="{4896F2AA-31C8-0DB9-9731-1673392EE42B}"/>
-              </a:ext>
-            </a:extLst>
-          </p:cNvPr>
-          <p:cNvSpPr>
-            <a:spLocks noGrp="1"/>
-          </p:cNvSpPr>
-          <p:nvPr>
-            <p:ph type="title"/>
-          </p:nvPr>
-        </p:nvSpPr>
-        <p:spPr/>
-        <p:txBody>
-          <a:bodyPr>
-            <a:normAutofit/>
-          </a:bodyPr>
-          <a:lstStyle/>
-          <a:p>
-            <a:r>
-              <a:rPr lang="en-GB" sz="6000" dirty="0"/>
-              <a:t>PYTHON</a:t>
-            </a:r>
-          </a:p>
-        </p:txBody>
-      </p:sp>
-      <p:sp>
-        <p:nvSpPr>
-          <p:cNvPr id="3" name="Content Placeholder 2">
-            <a:extLst>
-              <a:ext uri="{FF2B5EF4-FFF2-40B4-BE49-F238E27FC236}">
-                <a16:creationId xmlns:a16="http://schemas.microsoft.com/office/drawing/2014/main" id="{8D623DDD-D90D-55F9-EB1A-2B9CC4B463E2}"/>
-              </a:ext>
-            </a:extLst>
-          </p:cNvPr>
-          <p:cNvSpPr>
-            <a:spLocks noGrp="1"/>
-          </p:cNvSpPr>
-          <p:nvPr>
-            <p:ph idx="1"/>
-          </p:nvPr>
-        </p:nvSpPr>
-        <p:spPr/>
-        <p:txBody>
-          <a:bodyPr/>
-          <a:lstStyle/>
-          <a:p>
-            <a:r>
-              <a:rPr lang="en-GB" sz="4000" dirty="0"/>
-              <a:t>Primary platform</a:t>
-            </a:r>
-          </a:p>
-          <a:p>
-            <a:r>
-              <a:rPr lang="en-GB" sz="4000" dirty="0"/>
-              <a:t>Key advantage</a:t>
-            </a:r>
-          </a:p>
-          <a:p>
-            <a:r>
-              <a:rPr lang="en-GB" sz="4000" dirty="0"/>
-              <a:t>Limitation</a:t>
-            </a:r>
-          </a:p>
-          <a:p>
-            <a:r>
-              <a:rPr lang="en-GB" sz="4000" dirty="0"/>
-              <a:t>Typical use case</a:t>
-            </a:r>
-          </a:p>
-          <a:p>
-            <a:endParaRPr lang="en-GB" dirty="0"/>
-          </a:p>
-        </p:txBody>
-      </p:sp>
-    </p:spTree>
-    <p:extLst>
-      <p:ext uri="{BB962C8B-B14F-4D97-AF65-F5344CB8AC3E}">
-        <p14:creationId xmlns:p14="http://schemas.microsoft.com/office/powerpoint/2010/main" val="394585465"/>
-      </p:ext>
-    </p:extLst>
-  </p:cSld>
-  <p:clrMapOvr>
-    <a:masterClrMapping/>
-  </p:clrMapOvr>
-</p:sld>
-</file>
-
-<file path=ppt/slides/slide16.xml><?xml version="1.0" encoding="utf-8"?>
-<p:sld xmlns:a="http://schemas.openxmlformats.org/drawingml/2006/main" xmlns:r="http://schemas.openxmlformats.org/officeDocument/2006/relationships" xmlns:p="http://schemas.openxmlformats.org/presentationml/2006/main">
-  <p:cSld>
-    <p:spTree>
-      <p:nvGrpSpPr>
-        <p:cNvPr id="1" name=""/>
-        <p:cNvGrpSpPr/>
-        <p:nvPr/>
-      </p:nvGrpSpPr>
-      <p:grpSpPr>
-        <a:xfrm>
-          <a:off x="0" y="0"/>
-          <a:ext cx="0" cy="0"/>
-          <a:chOff x="0" y="0"/>
-          <a:chExt cx="0" cy="0"/>
-        </a:xfrm>
-      </p:grpSpPr>
-      <p:sp>
-        <p:nvSpPr>
-          <p:cNvPr id="2" name="Title 1">
-            <a:extLst>
-              <a:ext uri="{FF2B5EF4-FFF2-40B4-BE49-F238E27FC236}">
                 <a16:creationId xmlns:a16="http://schemas.microsoft.com/office/drawing/2014/main" id="{3C7436F9-07F8-9DF6-5FB3-21B02637ED99}"/>
               </a:ext>
             </a:extLst>
@@ -13849,7 +13191,7 @@
           <a:p>
             <a:r>
               <a:rPr lang="en-GB" sz="4000" dirty="0"/>
-              <a:t>Xamarin / .NET MAUI </a:t>
+              <a:t>Xamarin  </a:t>
             </a:r>
           </a:p>
           <a:p>
@@ -13873,7 +13215,7 @@
 </p:sld>
 </file>
 
-<file path=ppt/slides/slide17.xml><?xml version="1.0" encoding="utf-8"?>
+<file path=ppt/slides/slide11.xml><?xml version="1.0" encoding="utf-8"?>
 <p:sld xmlns:a="http://schemas.openxmlformats.org/drawingml/2006/main" xmlns:r="http://schemas.openxmlformats.org/officeDocument/2006/relationships" xmlns:p="http://schemas.openxmlformats.org/presentationml/2006/main">
   <p:cSld>
     <p:spTree>
@@ -14666,12 +14008,12 @@
                         <a:buNone/>
                       </a:pPr>
                       <a:r>
-                        <a:rPr lang="en-GB" sz="2000" kern="100">
+                        <a:rPr lang="en-GB" sz="2000" kern="100" dirty="0">
                           <a:effectLst/>
                         </a:rPr>
                         <a:t>Fast (Hot Reload)</a:t>
                       </a:r>
-                      <a:endParaRPr lang="en-GB" sz="2000" kern="100">
+                      <a:endParaRPr lang="en-GB" sz="2000" kern="100" dirty="0">
                         <a:effectLst/>
                         <a:latin typeface="Aptos" panose="020B0004020202020204" pitchFamily="34" charset="0"/>
                         <a:ea typeface="Aptos" panose="020B0004020202020204" pitchFamily="34" charset="0"/>
@@ -14823,12 +14165,12 @@
                         <a:buNone/>
                       </a:pPr>
                       <a:r>
-                        <a:rPr lang="en-GB" sz="2000" kern="100">
+                        <a:rPr lang="en-GB" sz="2000" kern="100" dirty="0">
                           <a:effectLst/>
                         </a:rPr>
                         <a:t>Custom widgets, pixel-perfect</a:t>
                       </a:r>
-                      <a:endParaRPr lang="en-GB" sz="2000" kern="100">
+                      <a:endParaRPr lang="en-GB" sz="2000" kern="100" dirty="0">
                         <a:effectLst/>
                         <a:latin typeface="Aptos" panose="020B0004020202020204" pitchFamily="34" charset="0"/>
                         <a:ea typeface="Aptos" panose="020B0004020202020204" pitchFamily="34" charset="0"/>
@@ -15422,7 +14764,7 @@
 </p:sld>
 </file>
 
-<file path=ppt/slides/slide18.xml><?xml version="1.0" encoding="utf-8"?>
+<file path=ppt/slides/slide12.xml><?xml version="1.0" encoding="utf-8"?>
 <p:sld xmlns:a="http://schemas.openxmlformats.org/drawingml/2006/main" xmlns:r="http://schemas.openxmlformats.org/officeDocument/2006/relationships" xmlns:p="http://schemas.openxmlformats.org/presentationml/2006/main">
   <p:cSld>
     <p:spTree>
@@ -15504,30 +14846,25 @@
           <a:p>
             <a:r>
               <a:rPr lang="en-GB" sz="3200" dirty="0"/>
-              <a:t>MVC – Model View Controller</a:t>
+              <a:t>MVC </a:t>
             </a:r>
           </a:p>
           <a:p>
             <a:r>
               <a:rPr lang="en-GB" sz="3200" dirty="0"/>
-              <a:t>MVP – Model View Presenter</a:t>
+              <a:t>MVP </a:t>
             </a:r>
           </a:p>
           <a:p>
             <a:r>
               <a:rPr lang="en-GB" sz="3200" dirty="0"/>
-              <a:t>MVVM – Model View </a:t>
+              <a:t>MVVM </a:t>
             </a:r>
-            <a:r>
-              <a:rPr lang="en-GB" sz="3200" dirty="0" err="1"/>
-              <a:t>ViewModel</a:t>
-            </a:r>
-            <a:endParaRPr lang="en-GB" sz="3200" dirty="0"/>
           </a:p>
           <a:p>
             <a:r>
               <a:rPr lang="en-GB" sz="3200" dirty="0"/>
-              <a:t>MVI – Model-View-Intent</a:t>
+              <a:t>MVI </a:t>
             </a:r>
           </a:p>
           <a:p>
@@ -15557,7 +14894,7 @@
 </p:sld>
 </file>
 
-<file path=ppt/slides/slide19.xml><?xml version="1.0" encoding="utf-8"?>
+<file path=ppt/slides/slide13.xml><?xml version="1.0" encoding="utf-8"?>
 <p:sld xmlns:a="http://schemas.openxmlformats.org/drawingml/2006/main" xmlns:r="http://schemas.openxmlformats.org/officeDocument/2006/relationships" xmlns:p="http://schemas.openxmlformats.org/presentationml/2006/main">
   <p:cSld>
     <p:spTree>
@@ -15615,7 +14952,7 @@
             <p:ph idx="1"/>
             <p:extLst>
               <p:ext uri="{D42A27DB-BD31-4B8C-83A1-F6EECF244321}">
-                <p14:modId xmlns:p14="http://schemas.microsoft.com/office/powerpoint/2010/main" val="767828424"/>
+                <p14:modId xmlns:p14="http://schemas.microsoft.com/office/powerpoint/2010/main" val="4022096164"/>
               </p:ext>
             </p:extLst>
           </p:nvPr>
@@ -15673,7 +15010,7 @@
                     <a:bodyPr/>
                     <a:lstStyle/>
                     <a:p>
-                      <a:pPr>
+                      <a:pPr algn="ctr">
                         <a:lnSpc>
                           <a:spcPct val="115000"/>
                         </a:lnSpc>
@@ -15703,7 +15040,7 @@
                     <a:bodyPr/>
                     <a:lstStyle/>
                     <a:p>
-                      <a:pPr>
+                      <a:pPr algn="ctr">
                         <a:lnSpc>
                           <a:spcPct val="115000"/>
                         </a:lnSpc>
@@ -15733,7 +15070,7 @@
                     <a:bodyPr/>
                     <a:lstStyle/>
                     <a:p>
-                      <a:pPr>
+                      <a:pPr algn="ctr">
                         <a:lnSpc>
                           <a:spcPct val="115000"/>
                         </a:lnSpc>
@@ -15763,7 +15100,7 @@
                     <a:bodyPr/>
                     <a:lstStyle/>
                     <a:p>
-                      <a:pPr>
+                      <a:pPr algn="ctr">
                         <a:lnSpc>
                           <a:spcPct val="115000"/>
                         </a:lnSpc>
@@ -15793,7 +15130,7 @@
                     <a:bodyPr/>
                     <a:lstStyle/>
                     <a:p>
-                      <a:pPr>
+                      <a:pPr algn="ctr">
                         <a:lnSpc>
                           <a:spcPct val="115000"/>
                         </a:lnSpc>
@@ -15830,7 +15167,7 @@
                     <a:bodyPr/>
                     <a:lstStyle/>
                     <a:p>
-                      <a:pPr>
+                      <a:pPr algn="ctr">
                         <a:lnSpc>
                           <a:spcPct val="115000"/>
                         </a:lnSpc>
@@ -15840,12 +15177,12 @@
                         <a:buNone/>
                       </a:pPr>
                       <a:r>
-                        <a:rPr lang="en-GB" sz="2000" kern="100">
+                        <a:rPr lang="en-GB" sz="2000" kern="100" dirty="0">
                           <a:effectLst/>
                         </a:rPr>
                         <a:t>MVC</a:t>
                       </a:r>
-                      <a:endParaRPr lang="en-GB" sz="2000" kern="100">
+                      <a:endParaRPr lang="en-GB" sz="2000" kern="100" dirty="0">
                         <a:effectLst/>
                         <a:latin typeface="Aptos" panose="020B0004020202020204" pitchFamily="34" charset="0"/>
                         <a:ea typeface="Aptos" panose="020B0004020202020204" pitchFamily="34" charset="0"/>
@@ -15860,7 +15197,7 @@
                     <a:bodyPr/>
                     <a:lstStyle/>
                     <a:p>
-                      <a:pPr>
+                      <a:pPr algn="ctr">
                         <a:lnSpc>
                           <a:spcPct val="115000"/>
                         </a:lnSpc>
@@ -15890,7 +15227,7 @@
                     <a:bodyPr/>
                     <a:lstStyle/>
                     <a:p>
-                      <a:pPr>
+                      <a:pPr algn="ctr">
                         <a:lnSpc>
                           <a:spcPct val="115000"/>
                         </a:lnSpc>
@@ -15920,7 +15257,7 @@
                     <a:bodyPr/>
                     <a:lstStyle/>
                     <a:p>
-                      <a:pPr>
+                      <a:pPr algn="ctr">
                         <a:lnSpc>
                           <a:spcPct val="115000"/>
                         </a:lnSpc>
@@ -15950,7 +15287,7 @@
                     <a:bodyPr/>
                     <a:lstStyle/>
                     <a:p>
-                      <a:pPr>
+                      <a:pPr algn="ctr">
                         <a:lnSpc>
                           <a:spcPct val="115000"/>
                         </a:lnSpc>
@@ -15987,7 +15324,7 @@
                     <a:bodyPr/>
                     <a:lstStyle/>
                     <a:p>
-                      <a:pPr>
+                      <a:pPr algn="ctr">
                         <a:lnSpc>
                           <a:spcPct val="115000"/>
                         </a:lnSpc>
@@ -16017,7 +15354,7 @@
                     <a:bodyPr/>
                     <a:lstStyle/>
                     <a:p>
-                      <a:pPr>
+                      <a:pPr algn="ctr">
                         <a:lnSpc>
                           <a:spcPct val="115000"/>
                         </a:lnSpc>
@@ -16047,7 +15384,7 @@
                     <a:bodyPr/>
                     <a:lstStyle/>
                     <a:p>
-                      <a:pPr>
+                      <a:pPr algn="ctr">
                         <a:lnSpc>
                           <a:spcPct val="115000"/>
                         </a:lnSpc>
@@ -16077,7 +15414,7 @@
                     <a:bodyPr/>
                     <a:lstStyle/>
                     <a:p>
-                      <a:pPr>
+                      <a:pPr algn="ctr">
                         <a:lnSpc>
                           <a:spcPct val="115000"/>
                         </a:lnSpc>
@@ -16107,7 +15444,7 @@
                     <a:bodyPr/>
                     <a:lstStyle/>
                     <a:p>
-                      <a:pPr>
+                      <a:pPr algn="ctr">
                         <a:lnSpc>
                           <a:spcPct val="115000"/>
                         </a:lnSpc>
@@ -16144,7 +15481,7 @@
                     <a:bodyPr/>
                     <a:lstStyle/>
                     <a:p>
-                      <a:pPr>
+                      <a:pPr algn="ctr">
                         <a:lnSpc>
                           <a:spcPct val="115000"/>
                         </a:lnSpc>
@@ -16154,12 +15491,12 @@
                         <a:buNone/>
                       </a:pPr>
                       <a:r>
-                        <a:rPr lang="en-GB" sz="2000" kern="100">
+                        <a:rPr lang="en-GB" sz="2000" kern="100" dirty="0">
                           <a:effectLst/>
                         </a:rPr>
                         <a:t>MVVM</a:t>
                       </a:r>
-                      <a:endParaRPr lang="en-GB" sz="2000" kern="100">
+                      <a:endParaRPr lang="en-GB" sz="2000" kern="100" dirty="0">
                         <a:effectLst/>
                         <a:latin typeface="Aptos" panose="020B0004020202020204" pitchFamily="34" charset="0"/>
                         <a:ea typeface="Aptos" panose="020B0004020202020204" pitchFamily="34" charset="0"/>
@@ -16174,7 +15511,7 @@
                     <a:bodyPr/>
                     <a:lstStyle/>
                     <a:p>
-                      <a:pPr>
+                      <a:pPr algn="ctr">
                         <a:lnSpc>
                           <a:spcPct val="115000"/>
                         </a:lnSpc>
@@ -16204,7 +15541,7 @@
                     <a:bodyPr/>
                     <a:lstStyle/>
                     <a:p>
-                      <a:pPr>
+                      <a:pPr algn="ctr">
                         <a:lnSpc>
                           <a:spcPct val="115000"/>
                         </a:lnSpc>
@@ -16234,7 +15571,7 @@
                     <a:bodyPr/>
                     <a:lstStyle/>
                     <a:p>
-                      <a:pPr>
+                      <a:pPr algn="ctr">
                         <a:lnSpc>
                           <a:spcPct val="115000"/>
                         </a:lnSpc>
@@ -16264,7 +15601,7 @@
                     <a:bodyPr/>
                     <a:lstStyle/>
                     <a:p>
-                      <a:pPr>
+                      <a:pPr algn="ctr">
                         <a:lnSpc>
                           <a:spcPct val="115000"/>
                         </a:lnSpc>
@@ -16301,7 +15638,7 @@
                     <a:bodyPr/>
                     <a:lstStyle/>
                     <a:p>
-                      <a:pPr>
+                      <a:pPr algn="ctr">
                         <a:lnSpc>
                           <a:spcPct val="115000"/>
                         </a:lnSpc>
@@ -16331,7 +15668,7 @@
                     <a:bodyPr/>
                     <a:lstStyle/>
                     <a:p>
-                      <a:pPr>
+                      <a:pPr algn="ctr">
                         <a:lnSpc>
                           <a:spcPct val="115000"/>
                         </a:lnSpc>
@@ -16341,12 +15678,12 @@
                         <a:buNone/>
                       </a:pPr>
                       <a:r>
-                        <a:rPr lang="en-GB" sz="2000" kern="100">
+                        <a:rPr lang="en-GB" sz="2000" kern="100" dirty="0">
                           <a:effectLst/>
                         </a:rPr>
                         <a:t>Model, View, Intent</a:t>
                       </a:r>
-                      <a:endParaRPr lang="en-GB" sz="2000" kern="100">
+                      <a:endParaRPr lang="en-GB" sz="2000" kern="100" dirty="0">
                         <a:effectLst/>
                         <a:latin typeface="Aptos" panose="020B0004020202020204" pitchFamily="34" charset="0"/>
                         <a:ea typeface="Aptos" panose="020B0004020202020204" pitchFamily="34" charset="0"/>
@@ -16361,7 +15698,7 @@
                     <a:bodyPr/>
                     <a:lstStyle/>
                     <a:p>
-                      <a:pPr>
+                      <a:pPr algn="ctr">
                         <a:lnSpc>
                           <a:spcPct val="115000"/>
                         </a:lnSpc>
@@ -16391,7 +15728,7 @@
                     <a:bodyPr/>
                     <a:lstStyle/>
                     <a:p>
-                      <a:pPr>
+                      <a:pPr algn="ctr">
                         <a:lnSpc>
                           <a:spcPct val="115000"/>
                         </a:lnSpc>
@@ -16421,7 +15758,7 @@
                     <a:bodyPr/>
                     <a:lstStyle/>
                     <a:p>
-                      <a:pPr>
+                      <a:pPr algn="ctr">
                         <a:lnSpc>
                           <a:spcPct val="115000"/>
                         </a:lnSpc>
@@ -16458,7 +15795,7 @@
                     <a:bodyPr/>
                     <a:lstStyle/>
                     <a:p>
-                      <a:pPr>
+                      <a:pPr algn="ctr">
                         <a:lnSpc>
                           <a:spcPct val="115000"/>
                         </a:lnSpc>
@@ -16488,7 +15825,7 @@
                     <a:bodyPr/>
                     <a:lstStyle/>
                     <a:p>
-                      <a:pPr>
+                      <a:pPr algn="ctr">
                         <a:lnSpc>
                           <a:spcPct val="115000"/>
                         </a:lnSpc>
@@ -16498,12 +15835,12 @@
                         <a:buNone/>
                       </a:pPr>
                       <a:r>
-                        <a:rPr lang="en-GB" sz="2000" kern="100">
+                        <a:rPr lang="en-GB" sz="2000" kern="100" dirty="0">
                           <a:effectLst/>
                         </a:rPr>
                         <a:t>Domain, Data, Presentation</a:t>
                       </a:r>
-                      <a:endParaRPr lang="en-GB" sz="2000" kern="100">
+                      <a:endParaRPr lang="en-GB" sz="2000" kern="100" dirty="0">
                         <a:effectLst/>
                         <a:latin typeface="Aptos" panose="020B0004020202020204" pitchFamily="34" charset="0"/>
                         <a:ea typeface="Aptos" panose="020B0004020202020204" pitchFamily="34" charset="0"/>
@@ -16518,7 +15855,37 @@
                     <a:bodyPr/>
                     <a:lstStyle/>
                     <a:p>
-                      <a:pPr>
+                      <a:pPr algn="ctr">
+                        <a:lnSpc>
+                          <a:spcPct val="115000"/>
+                        </a:lnSpc>
+                        <a:spcAft>
+                          <a:spcPts val="800"/>
+                        </a:spcAft>
+                        <a:buNone/>
+                      </a:pPr>
+                      <a:r>
+                        <a:rPr lang="en-GB" sz="2000" kern="100" dirty="0">
+                          <a:effectLst/>
+                        </a:rPr>
+                        <a:t>Very High</a:t>
+                      </a:r>
+                      <a:endParaRPr lang="en-GB" sz="2000" kern="100" dirty="0">
+                        <a:effectLst/>
+                        <a:latin typeface="Aptos" panose="020B0004020202020204" pitchFamily="34" charset="0"/>
+                        <a:ea typeface="Aptos" panose="020B0004020202020204" pitchFamily="34" charset="0"/>
+                        <a:cs typeface="Times New Roman" panose="02020603050405020304" pitchFamily="18" charset="0"/>
+                      </a:endParaRPr>
+                    </a:p>
+                  </a:txBody>
+                  <a:tcPr marL="9525" marR="9525" marT="9525" marB="9525" anchor="ctr"/>
+                </a:tc>
+                <a:tc>
+                  <a:txBody>
+                    <a:bodyPr/>
+                    <a:lstStyle/>
+                    <a:p>
+                      <a:pPr algn="ctr">
                         <a:lnSpc>
                           <a:spcPct val="115000"/>
                         </a:lnSpc>
@@ -16548,7 +15915,7 @@
                     <a:bodyPr/>
                     <a:lstStyle/>
                     <a:p>
-                      <a:pPr>
+                      <a:pPr algn="ctr">
                         <a:lnSpc>
                           <a:spcPct val="115000"/>
                         </a:lnSpc>
@@ -16558,42 +15925,12 @@
                         <a:buNone/>
                       </a:pPr>
                       <a:r>
-                        <a:rPr lang="en-GB" sz="2000" kern="100">
-                          <a:effectLst/>
-                        </a:rPr>
-                        <a:t>Very High</a:t>
-                      </a:r>
-                      <a:endParaRPr lang="en-GB" sz="2000" kern="100">
-                        <a:effectLst/>
-                        <a:latin typeface="Aptos" panose="020B0004020202020204" pitchFamily="34" charset="0"/>
-                        <a:ea typeface="Aptos" panose="020B0004020202020204" pitchFamily="34" charset="0"/>
-                        <a:cs typeface="Times New Roman" panose="02020603050405020304" pitchFamily="18" charset="0"/>
-                      </a:endParaRPr>
-                    </a:p>
-                  </a:txBody>
-                  <a:tcPr marL="9525" marR="9525" marT="9525" marB="9525" anchor="ctr"/>
-                </a:tc>
-                <a:tc>
-                  <a:txBody>
-                    <a:bodyPr/>
-                    <a:lstStyle/>
-                    <a:p>
-                      <a:pPr>
-                        <a:lnSpc>
-                          <a:spcPct val="115000"/>
-                        </a:lnSpc>
-                        <a:spcAft>
-                          <a:spcPts val="800"/>
-                        </a:spcAft>
-                        <a:buNone/>
-                      </a:pPr>
-                      <a:r>
-                        <a:rPr lang="en-GB" sz="2000" kern="100">
+                        <a:rPr lang="en-GB" sz="2000" kern="100" dirty="0">
                           <a:effectLst/>
                         </a:rPr>
                         <a:t>Enterprise, large teams</a:t>
                       </a:r>
-                      <a:endParaRPr lang="en-GB" sz="2000" kern="100">
+                      <a:endParaRPr lang="en-GB" sz="2000" kern="100" dirty="0">
                         <a:effectLst/>
                         <a:latin typeface="Aptos" panose="020B0004020202020204" pitchFamily="34" charset="0"/>
                         <a:ea typeface="Aptos" panose="020B0004020202020204" pitchFamily="34" charset="0"/>
@@ -16615,7 +15952,7 @@
                     <a:bodyPr/>
                     <a:lstStyle/>
                     <a:p>
-                      <a:pPr>
+                      <a:pPr algn="ctr">
                         <a:lnSpc>
                           <a:spcPct val="115000"/>
                         </a:lnSpc>
@@ -16625,12 +15962,12 @@
                         <a:buNone/>
                       </a:pPr>
                       <a:r>
-                        <a:rPr lang="en-GB" sz="2000" kern="100">
+                        <a:rPr lang="en-GB" sz="2000" kern="100" dirty="0">
                           <a:effectLst/>
                         </a:rPr>
                         <a:t>VIPER</a:t>
                       </a:r>
-                      <a:endParaRPr lang="en-GB" sz="2000" kern="100">
+                      <a:endParaRPr lang="en-GB" sz="2000" kern="100" dirty="0">
                         <a:effectLst/>
                         <a:latin typeface="Aptos" panose="020B0004020202020204" pitchFamily="34" charset="0"/>
                         <a:ea typeface="Aptos" panose="020B0004020202020204" pitchFamily="34" charset="0"/>
@@ -16645,7 +15982,7 @@
                     <a:bodyPr/>
                     <a:lstStyle/>
                     <a:p>
-                      <a:pPr>
+                      <a:pPr algn="ctr">
                         <a:lnSpc>
                           <a:spcPct val="115000"/>
                         </a:lnSpc>
@@ -16675,7 +16012,7 @@
                     <a:bodyPr/>
                     <a:lstStyle/>
                     <a:p>
-                      <a:pPr>
+                      <a:pPr algn="ctr">
                         <a:lnSpc>
                           <a:spcPct val="115000"/>
                         </a:lnSpc>
@@ -16685,12 +16022,12 @@
                         <a:buNone/>
                       </a:pPr>
                       <a:r>
-                        <a:rPr lang="en-GB" sz="2000" kern="100">
+                        <a:rPr lang="en-GB" sz="2000" kern="100" dirty="0">
                           <a:effectLst/>
                         </a:rPr>
                         <a:t>High</a:t>
                       </a:r>
-                      <a:endParaRPr lang="en-GB" sz="2000" kern="100">
+                      <a:endParaRPr lang="en-GB" sz="2000" kern="100" dirty="0">
                         <a:effectLst/>
                         <a:latin typeface="Aptos" panose="020B0004020202020204" pitchFamily="34" charset="0"/>
                         <a:ea typeface="Aptos" panose="020B0004020202020204" pitchFamily="34" charset="0"/>
@@ -16705,7 +16042,7 @@
                     <a:bodyPr/>
                     <a:lstStyle/>
                     <a:p>
-                      <a:pPr>
+                      <a:pPr algn="ctr">
                         <a:lnSpc>
                           <a:spcPct val="115000"/>
                         </a:lnSpc>
@@ -16715,12 +16052,12 @@
                         <a:buNone/>
                       </a:pPr>
                       <a:r>
-                        <a:rPr lang="en-GB" sz="2000" kern="100">
+                        <a:rPr lang="en-GB" sz="2000" kern="100" dirty="0">
                           <a:effectLst/>
                         </a:rPr>
                         <a:t>Very High</a:t>
                       </a:r>
-                      <a:endParaRPr lang="en-GB" sz="2000" kern="100">
+                      <a:endParaRPr lang="en-GB" sz="2000" kern="100" dirty="0">
                         <a:effectLst/>
                         <a:latin typeface="Aptos" panose="020B0004020202020204" pitchFamily="34" charset="0"/>
                         <a:ea typeface="Aptos" panose="020B0004020202020204" pitchFamily="34" charset="0"/>
@@ -16735,7 +16072,7 @@
                     <a:bodyPr/>
                     <a:lstStyle/>
                     <a:p>
-                      <a:pPr>
+                      <a:pPr algn="ctr">
                         <a:lnSpc>
                           <a:spcPct val="115000"/>
                         </a:lnSpc>
@@ -16783,7 +16120,7 @@
 </p:sld>
 </file>
 
-<file path=ppt/slides/slide2.xml><?xml version="1.0" encoding="utf-8"?>
+<file path=ppt/slides/slide14.xml><?xml version="1.0" encoding="utf-8"?>
 <p:sld xmlns:a="http://schemas.openxmlformats.org/drawingml/2006/main" xmlns:r="http://schemas.openxmlformats.org/officeDocument/2006/relationships" xmlns:p="http://schemas.openxmlformats.org/presentationml/2006/main">
   <p:cSld>
     <p:spTree>
@@ -16805,7 +16142,7 @@
           <p:cNvPr id="2" name="Title 1">
             <a:extLst>
               <a:ext uri="{FF2B5EF4-FFF2-40B4-BE49-F238E27FC236}">
-                <a16:creationId xmlns:a16="http://schemas.microsoft.com/office/drawing/2014/main" id="{FA4BD4C1-36CF-1E67-CA94-4EF1EC6F7605}"/>
+                <a16:creationId xmlns:a16="http://schemas.microsoft.com/office/drawing/2014/main" id="{11D7E0EA-E54A-D6F8-037F-0A4AE4244146}"/>
               </a:ext>
             </a:extLst>
           </p:cNvPr>
@@ -16816,21 +16153,14 @@
             <p:ph type="title"/>
           </p:nvPr>
         </p:nvSpPr>
-        <p:spPr>
-          <a:xfrm>
-            <a:off x="1141413" y="161318"/>
-            <a:ext cx="9905998" cy="1478570"/>
-          </a:xfrm>
-        </p:spPr>
+        <p:spPr/>
         <p:txBody>
-          <a:bodyPr>
-            <a:normAutofit/>
-          </a:bodyPr>
+          <a:bodyPr/>
           <a:lstStyle/>
           <a:p>
             <a:r>
-              <a:rPr lang="en-GB" sz="8000" dirty="0"/>
-              <a:t>OUTLINE</a:t>
+              <a:rPr lang="en-GB" dirty="0"/>
+              <a:t>Design patterns</a:t>
             </a:r>
           </a:p>
         </p:txBody>
@@ -16840,7 +16170,7 @@
           <p:cNvPr id="3" name="Content Placeholder 2">
             <a:extLst>
               <a:ext uri="{FF2B5EF4-FFF2-40B4-BE49-F238E27FC236}">
-                <a16:creationId xmlns:a16="http://schemas.microsoft.com/office/drawing/2014/main" id="{9FC8155B-7BFC-30E9-C915-CEBAC7C55D69}"/>
+                <a16:creationId xmlns:a16="http://schemas.microsoft.com/office/drawing/2014/main" id="{9896374F-C5BD-C01C-4AD5-BCBE7327B39A}"/>
               </a:ext>
             </a:extLst>
           </p:cNvPr>
@@ -16851,51 +16181,40 @@
             <p:ph idx="1"/>
           </p:nvPr>
         </p:nvSpPr>
-        <p:spPr>
-          <a:xfrm>
-            <a:off x="1141412" y="1658143"/>
-            <a:ext cx="9905999" cy="3541714"/>
-          </a:xfrm>
-        </p:spPr>
+        <p:spPr/>
         <p:txBody>
           <a:bodyPr>
-            <a:noAutofit/>
+            <a:normAutofit fontScale="92500" lnSpcReduction="20000"/>
           </a:bodyPr>
           <a:lstStyle/>
           <a:p>
             <a:r>
-              <a:rPr lang="en-GB" sz="3600" dirty="0"/>
-              <a:t>Types of Mobile applications</a:t>
+              <a:rPr lang="en-GB" sz="2800" dirty="0"/>
+              <a:t>Singleton: Ensures that only one instance of a class exists in the entire application.</a:t>
             </a:r>
           </a:p>
           <a:p>
             <a:r>
-              <a:rPr lang="en-GB" sz="3600" dirty="0"/>
-              <a:t>Mobile apps programming languages</a:t>
+              <a:rPr lang="en-GB" sz="2800" dirty="0"/>
+              <a:t>Factory: Creates objects without specifying the exact class to instantiate</a:t>
             </a:r>
           </a:p>
           <a:p>
             <a:r>
-              <a:rPr lang="en-GB" sz="3600" dirty="0"/>
-              <a:t>Mobile app development frameworks</a:t>
+              <a:rPr lang="en-GB" sz="2800" dirty="0"/>
+              <a:t>Observer: Allows one object to notify many other objects automatically when it changes.</a:t>
             </a:r>
           </a:p>
           <a:p>
             <a:r>
-              <a:rPr lang="en-GB" sz="3600" dirty="0"/>
-              <a:t>Mobile app architectures and design patterns</a:t>
+              <a:rPr lang="en-GB" sz="2800" dirty="0"/>
+              <a:t>Dependency Injection</a:t>
             </a:r>
           </a:p>
           <a:p>
             <a:r>
-              <a:rPr lang="en-GB" sz="3600" dirty="0"/>
-              <a:t>Requirement engineering process</a:t>
-            </a:r>
-          </a:p>
-          <a:p>
-            <a:r>
-              <a:rPr lang="en-GB" sz="3600" dirty="0"/>
-              <a:t>Mobile app development cost estimation</a:t>
+              <a:rPr lang="en-GB" sz="2800" dirty="0"/>
+              <a:t>Repository patterns</a:t>
             </a:r>
           </a:p>
         </p:txBody>
@@ -16903,7 +16222,7 @@
     </p:spTree>
     <p:extLst>
       <p:ext uri="{BB962C8B-B14F-4D97-AF65-F5344CB8AC3E}">
-        <p14:creationId xmlns:p14="http://schemas.microsoft.com/office/powerpoint/2010/main" val="2961907334"/>
+        <p14:creationId xmlns:p14="http://schemas.microsoft.com/office/powerpoint/2010/main" val="85559075"/>
       </p:ext>
     </p:extLst>
   </p:cSld>
@@ -16913,7 +16232,7 @@
 </p:sld>
 </file>
 
-<file path=ppt/slides/slide20.xml><?xml version="1.0" encoding="utf-8"?>
+<file path=ppt/slides/slide15.xml><?xml version="1.0" encoding="utf-8"?>
 <p:sld xmlns:a="http://schemas.openxmlformats.org/drawingml/2006/main" xmlns:r="http://schemas.openxmlformats.org/officeDocument/2006/relationships" xmlns:p="http://schemas.openxmlformats.org/presentationml/2006/main">
   <p:cSld>
     <p:spTree>
@@ -17020,7 +16339,7 @@
 </p:sld>
 </file>
 
-<file path=ppt/slides/slide21.xml><?xml version="1.0" encoding="utf-8"?>
+<file path=ppt/slides/slide16.xml><?xml version="1.0" encoding="utf-8"?>
 <p:sld xmlns:a="http://schemas.openxmlformats.org/drawingml/2006/main" xmlns:r="http://schemas.openxmlformats.org/officeDocument/2006/relationships" xmlns:p="http://schemas.openxmlformats.org/presentationml/2006/main">
   <p:cSld>
     <p:spTree>
@@ -17091,19 +16410,19 @@
         <p:spPr/>
         <p:txBody>
           <a:bodyPr>
-            <a:normAutofit/>
+            <a:normAutofit lnSpcReduction="10000"/>
           </a:bodyPr>
           <a:lstStyle/>
           <a:p>
             <a:r>
               <a:rPr lang="en-GB" sz="4000" dirty="0"/>
-              <a:t>Functional Requirements</a:t>
+              <a:t>Functional Requirements: These define what the system does like logging into an account</a:t>
             </a:r>
           </a:p>
           <a:p>
             <a:r>
               <a:rPr lang="en-GB" sz="4000" dirty="0"/>
-              <a:t>Non – functional requirements</a:t>
+              <a:t>Non – functional requirements: These defines how a system performs focusing on speed and other factors</a:t>
             </a:r>
           </a:p>
         </p:txBody>
@@ -17121,7 +16440,7 @@
 </p:sld>
 </file>
 
-<file path=ppt/slides/slide22.xml><?xml version="1.0" encoding="utf-8"?>
+<file path=ppt/slides/slide17.xml><?xml version="1.0" encoding="utf-8"?>
 <p:sld xmlns:a="http://schemas.openxmlformats.org/drawingml/2006/main" xmlns:r="http://schemas.openxmlformats.org/officeDocument/2006/relationships" xmlns:p="http://schemas.openxmlformats.org/presentationml/2006/main">
   <p:cSld>
     <p:spTree>
@@ -17206,33 +16525,12 @@
           </a:bodyPr>
           <a:lstStyle/>
           <a:p>
+            <a:pPr marL="0" indent="0">
+              <a:buNone/>
+            </a:pPr>
             <a:r>
               <a:rPr lang="en-GB" sz="3600" dirty="0"/>
-              <a:t>Stakeholder Interviews</a:t>
-            </a:r>
-          </a:p>
-          <a:p>
-            <a:r>
-              <a:rPr lang="en-GB" sz="3600" dirty="0"/>
-              <a:t>Surveys &amp; Questionnaires</a:t>
-            </a:r>
-          </a:p>
-          <a:p>
-            <a:r>
-              <a:rPr lang="en-GB" sz="3600" dirty="0"/>
-              <a:t>Market &amp; Competitor Analysis</a:t>
-            </a:r>
-          </a:p>
-          <a:p>
-            <a:r>
-              <a:rPr lang="en-GB" sz="3600" dirty="0"/>
-              <a:t>Prototyping</a:t>
-            </a:r>
-          </a:p>
-          <a:p>
-            <a:r>
-              <a:rPr lang="en-GB" sz="3600" dirty="0"/>
-              <a:t>App Store Review Mining</a:t>
+              <a:t>To find these requirements, we use some techniques which include: interviews and surveys to hear directly from users, app analysis to benchmark competitors and creation of user personas to simulate real world behaviour</a:t>
             </a:r>
           </a:p>
         </p:txBody>
@@ -17250,7 +16548,7 @@
 </p:sld>
 </file>
 
-<file path=ppt/slides/slide23.xml><?xml version="1.0" encoding="utf-8"?>
+<file path=ppt/slides/slide18.xml><?xml version="1.0" encoding="utf-8"?>
 <p:sld xmlns:a="http://schemas.openxmlformats.org/drawingml/2006/main" xmlns:r="http://schemas.openxmlformats.org/officeDocument/2006/relationships" xmlns:p="http://schemas.openxmlformats.org/presentationml/2006/main">
   <p:cSld>
     <p:spTree>
@@ -17283,12 +16581,7 @@
             <p:ph type="title"/>
           </p:nvPr>
         </p:nvSpPr>
-        <p:spPr>
-          <a:xfrm>
-            <a:off x="1317876" y="2807368"/>
-            <a:ext cx="9905998" cy="1519572"/>
-          </a:xfrm>
-        </p:spPr>
+        <p:spPr/>
         <p:txBody>
           <a:bodyPr>
             <a:noAutofit/>
@@ -17309,10 +16602,10 @@
       </p:sp>
       <p:sp>
         <p:nvSpPr>
-          <p:cNvPr id="3" name="Content Placeholder 2">
+          <p:cNvPr id="4" name="Content Placeholder 3">
             <a:extLst>
               <a:ext uri="{FF2B5EF4-FFF2-40B4-BE49-F238E27FC236}">
-                <a16:creationId xmlns:a16="http://schemas.microsoft.com/office/drawing/2014/main" id="{9A56A08B-4BD0-AC7D-D4C7-8CB748437893}"/>
+                <a16:creationId xmlns:a16="http://schemas.microsoft.com/office/drawing/2014/main" id="{818721C1-D20A-A5DD-8A0B-1E69CC502CF6}"/>
               </a:ext>
             </a:extLst>
           </p:cNvPr>
@@ -17323,22 +16616,18 @@
             <p:ph idx="1"/>
           </p:nvPr>
         </p:nvSpPr>
-        <p:spPr>
-          <a:xfrm flipV="1">
-            <a:off x="1141412" y="5791200"/>
-            <a:ext cx="9905999" cy="45719"/>
-          </a:xfrm>
-        </p:spPr>
+        <p:spPr/>
         <p:txBody>
-          <a:bodyPr>
-            <a:normAutofit fontScale="25000" lnSpcReduction="20000"/>
-          </a:bodyPr>
+          <a:bodyPr/>
           <a:lstStyle/>
           <a:p>
-            <a:pPr marL="457200" indent="-457200">
-              <a:buFont typeface="+mj-lt"/>
-              <a:buAutoNum type="arabicPeriod"/>
-            </a:pPr>
+            <a:r>
+              <a:rPr lang="en-GB" sz="3600" dirty="0"/>
+              <a:t>Once gathered, we prioritize features to set THE PROJECT SCOPE THEN WE DOCUMENT THEM INTO user stories and we validate them to ensure everything is feasible and consistent</a:t>
+            </a:r>
+            <a:br>
+              <a:rPr lang="en-GB" sz="4400" dirty="0"/>
+            </a:br>
             <a:endParaRPr lang="en-GB" dirty="0"/>
           </a:p>
         </p:txBody>
@@ -17356,7 +16645,7 @@
 </p:sld>
 </file>
 
-<file path=ppt/slides/slide24.xml><?xml version="1.0" encoding="utf-8"?>
+<file path=ppt/slides/slide19.xml><?xml version="1.0" encoding="utf-8"?>
 <p:sld xmlns:a="http://schemas.openxmlformats.org/drawingml/2006/main" xmlns:r="http://schemas.openxmlformats.org/officeDocument/2006/relationships" xmlns:p="http://schemas.openxmlformats.org/presentationml/2006/main">
   <p:cSld>
     <p:spTree>
@@ -18500,7 +17789,137 @@
 </p:sld>
 </file>
 
-<file path=ppt/slides/slide25.xml><?xml version="1.0" encoding="utf-8"?>
+<file path=ppt/slides/slide2.xml><?xml version="1.0" encoding="utf-8"?>
+<p:sld xmlns:a="http://schemas.openxmlformats.org/drawingml/2006/main" xmlns:r="http://schemas.openxmlformats.org/officeDocument/2006/relationships" xmlns:p="http://schemas.openxmlformats.org/presentationml/2006/main">
+  <p:cSld>
+    <p:spTree>
+      <p:nvGrpSpPr>
+        <p:cNvPr id="1" name=""/>
+        <p:cNvGrpSpPr/>
+        <p:nvPr/>
+      </p:nvGrpSpPr>
+      <p:grpSpPr>
+        <a:xfrm>
+          <a:off x="0" y="0"/>
+          <a:ext cx="0" cy="0"/>
+          <a:chOff x="0" y="0"/>
+          <a:chExt cx="0" cy="0"/>
+        </a:xfrm>
+      </p:grpSpPr>
+      <p:sp>
+        <p:nvSpPr>
+          <p:cNvPr id="2" name="Title 1">
+            <a:extLst>
+              <a:ext uri="{FF2B5EF4-FFF2-40B4-BE49-F238E27FC236}">
+                <a16:creationId xmlns:a16="http://schemas.microsoft.com/office/drawing/2014/main" id="{FA4BD4C1-36CF-1E67-CA94-4EF1EC6F7605}"/>
+              </a:ext>
+            </a:extLst>
+          </p:cNvPr>
+          <p:cNvSpPr>
+            <a:spLocks noGrp="1"/>
+          </p:cNvSpPr>
+          <p:nvPr>
+            <p:ph type="title"/>
+          </p:nvPr>
+        </p:nvSpPr>
+        <p:spPr>
+          <a:xfrm>
+            <a:off x="1141413" y="161318"/>
+            <a:ext cx="9905998" cy="1478570"/>
+          </a:xfrm>
+        </p:spPr>
+        <p:txBody>
+          <a:bodyPr>
+            <a:normAutofit/>
+          </a:bodyPr>
+          <a:lstStyle/>
+          <a:p>
+            <a:r>
+              <a:rPr lang="en-GB" sz="8000" dirty="0"/>
+              <a:t>OUTLINE</a:t>
+            </a:r>
+          </a:p>
+        </p:txBody>
+      </p:sp>
+      <p:sp>
+        <p:nvSpPr>
+          <p:cNvPr id="3" name="Content Placeholder 2">
+            <a:extLst>
+              <a:ext uri="{FF2B5EF4-FFF2-40B4-BE49-F238E27FC236}">
+                <a16:creationId xmlns:a16="http://schemas.microsoft.com/office/drawing/2014/main" id="{9FC8155B-7BFC-30E9-C915-CEBAC7C55D69}"/>
+              </a:ext>
+            </a:extLst>
+          </p:cNvPr>
+          <p:cNvSpPr>
+            <a:spLocks noGrp="1"/>
+          </p:cNvSpPr>
+          <p:nvPr>
+            <p:ph idx="1"/>
+          </p:nvPr>
+        </p:nvSpPr>
+        <p:spPr>
+          <a:xfrm>
+            <a:off x="1141412" y="1658143"/>
+            <a:ext cx="9905999" cy="3541714"/>
+          </a:xfrm>
+        </p:spPr>
+        <p:txBody>
+          <a:bodyPr>
+            <a:noAutofit/>
+          </a:bodyPr>
+          <a:lstStyle/>
+          <a:p>
+            <a:r>
+              <a:rPr lang="en-GB" sz="3600" dirty="0"/>
+              <a:t>Types of Mobile applications</a:t>
+            </a:r>
+          </a:p>
+          <a:p>
+            <a:r>
+              <a:rPr lang="en-GB" sz="3600" dirty="0"/>
+              <a:t>Mobile apps programming languages</a:t>
+            </a:r>
+          </a:p>
+          <a:p>
+            <a:r>
+              <a:rPr lang="en-GB" sz="3600" dirty="0"/>
+              <a:t>Mobile app development frameworks</a:t>
+            </a:r>
+          </a:p>
+          <a:p>
+            <a:r>
+              <a:rPr lang="en-GB" sz="3600" dirty="0"/>
+              <a:t>Mobile app architectures and design patterns</a:t>
+            </a:r>
+          </a:p>
+          <a:p>
+            <a:r>
+              <a:rPr lang="en-GB" sz="3600" dirty="0"/>
+              <a:t>Requirement engineering process</a:t>
+            </a:r>
+          </a:p>
+          <a:p>
+            <a:r>
+              <a:rPr lang="en-GB" sz="3600" dirty="0"/>
+              <a:t>Mobile app development cost estimation</a:t>
+            </a:r>
+          </a:p>
+        </p:txBody>
+      </p:sp>
+    </p:spTree>
+    <p:extLst>
+      <p:ext uri="{BB962C8B-B14F-4D97-AF65-F5344CB8AC3E}">
+        <p14:creationId xmlns:p14="http://schemas.microsoft.com/office/powerpoint/2010/main" val="2961907334"/>
+      </p:ext>
+    </p:extLst>
+  </p:cSld>
+  <p:clrMapOvr>
+    <a:masterClrMapping/>
+  </p:clrMapOvr>
+</p:sld>
+</file>
+
+<file path=ppt/slides/slide20.xml><?xml version="1.0" encoding="utf-8"?>
 <p:sld xmlns:a="http://schemas.openxmlformats.org/drawingml/2006/main" xmlns:r="http://schemas.openxmlformats.org/officeDocument/2006/relationships" xmlns:p="http://schemas.openxmlformats.org/presentationml/2006/main">
   <p:cSld>
     <p:spTree>
@@ -18580,33 +17999,12 @@
           </a:bodyPr>
           <a:lstStyle/>
           <a:p>
+            <a:pPr marL="0" indent="0">
+              <a:buNone/>
+            </a:pPr>
             <a:r>
               <a:rPr lang="en-GB" sz="3600" dirty="0"/>
-              <a:t>The Core Cost Formula </a:t>
-            </a:r>
-          </a:p>
-          <a:p>
-            <a:r>
-              <a:rPr lang="en-GB" sz="3600" dirty="0"/>
-              <a:t>Cost by App Complexity</a:t>
-            </a:r>
-          </a:p>
-          <a:p>
-            <a:r>
-              <a:rPr lang="en-GB" sz="3600" dirty="0"/>
-              <a:t>Key Cost Factors</a:t>
-            </a:r>
-          </a:p>
-          <a:p>
-            <a:r>
-              <a:rPr lang="en-GB" sz="3600" dirty="0"/>
-              <a:t>Cost Estimation Methods</a:t>
-            </a:r>
-          </a:p>
-          <a:p>
-            <a:r>
-              <a:rPr lang="en-GB" sz="3600" dirty="0"/>
-              <a:t>Cost Breakdown by Development Phase</a:t>
+              <a:t>Estimating mobile app development costs is key to project success. It involves understanding the CORE COST FORMULA and how APP COMPLEXITY dramatically impacts the budget </a:t>
             </a:r>
           </a:p>
         </p:txBody>
@@ -18624,7 +18022,7 @@
 </p:sld>
 </file>
 
-<file path=ppt/slides/slide26.xml><?xml version="1.0" encoding="utf-8"?>
+<file path=ppt/slides/slide21.xml><?xml version="1.0" encoding="utf-8"?>
 <p:sld xmlns:a="http://schemas.openxmlformats.org/drawingml/2006/main" xmlns:r="http://schemas.openxmlformats.org/officeDocument/2006/relationships" xmlns:p="http://schemas.openxmlformats.org/presentationml/2006/main">
   <p:cSld>
     <p:spTree>
@@ -18643,10 +18041,10 @@
       </p:grpSpPr>
       <p:sp>
         <p:nvSpPr>
-          <p:cNvPr id="2" name="Title 1">
+          <p:cNvPr id="3" name="Title 2">
             <a:extLst>
               <a:ext uri="{FF2B5EF4-FFF2-40B4-BE49-F238E27FC236}">
-                <a16:creationId xmlns:a16="http://schemas.microsoft.com/office/drawing/2014/main" id="{C0E88B3F-7A60-5710-1F0C-DB5992C28B6F}"/>
+                <a16:creationId xmlns:a16="http://schemas.microsoft.com/office/drawing/2014/main" id="{946046EC-B3E7-D2D4-A9F4-383B162270C8}"/>
               </a:ext>
             </a:extLst>
           </p:cNvPr>
@@ -18657,1350 +18055,48 @@
             <p:ph type="title"/>
           </p:nvPr>
         </p:nvSpPr>
-        <p:spPr>
-          <a:xfrm>
-            <a:off x="1304699" y="0"/>
-            <a:ext cx="9905998" cy="1478570"/>
-          </a:xfrm>
-        </p:spPr>
+        <p:spPr/>
         <p:txBody>
           <a:bodyPr/>
           <a:lstStyle/>
           <a:p>
-            <a:r>
-              <a:rPr lang="en-GB" dirty="0"/>
-              <a:t>COST by app complexity (2025)</a:t>
-            </a:r>
+            <a:endParaRPr lang="en-GB"/>
           </a:p>
         </p:txBody>
       </p:sp>
-      <p:graphicFrame>
-        <p:nvGraphicFramePr>
-          <p:cNvPr id="5" name="Table 4">
+      <p:sp>
+        <p:nvSpPr>
+          <p:cNvPr id="4" name="Content Placeholder 3">
             <a:extLst>
               <a:ext uri="{FF2B5EF4-FFF2-40B4-BE49-F238E27FC236}">
-                <a16:creationId xmlns:a16="http://schemas.microsoft.com/office/drawing/2014/main" id="{34AFAB1D-D540-E566-8D60-040C04556C5A}"/>
+                <a16:creationId xmlns:a16="http://schemas.microsoft.com/office/drawing/2014/main" id="{A1D2B9C3-7F53-40C9-AFED-C6495C7DB75D}"/>
               </a:ext>
             </a:extLst>
           </p:cNvPr>
-          <p:cNvGraphicFramePr>
-            <a:graphicFrameLocks noGrp="1"/>
-          </p:cNvGraphicFramePr>
+          <p:cNvSpPr>
+            <a:spLocks noGrp="1"/>
+          </p:cNvSpPr>
           <p:nvPr>
-            <p:extLst>
-              <p:ext uri="{D42A27DB-BD31-4B8C-83A1-F6EECF244321}">
-                <p14:modId xmlns:p14="http://schemas.microsoft.com/office/powerpoint/2010/main" val="442023676"/>
-              </p:ext>
-            </p:extLst>
+            <p:ph idx="1"/>
           </p:nvPr>
-        </p:nvGraphicFramePr>
-        <p:xfrm>
-          <a:off x="0" y="1175656"/>
-          <a:ext cx="12191995" cy="5810188"/>
-        </p:xfrm>
-        <a:graphic>
-          <a:graphicData uri="http://schemas.openxmlformats.org/drawingml/2006/table">
-            <a:tbl>
-              <a:tblPr firstRow="1" firstCol="1" bandRow="1">
-                <a:tableStyleId>{8FD4443E-F989-4FC4-A0C8-D5A2AF1F390B}</a:tableStyleId>
-              </a:tblPr>
-              <a:tblGrid>
-                <a:gridCol w="2438399">
-                  <a:extLst>
-                    <a:ext uri="{9D8B030D-6E8A-4147-A177-3AD203B41FA5}">
-                      <a16:colId xmlns:a16="http://schemas.microsoft.com/office/drawing/2014/main" val="777623559"/>
-                    </a:ext>
-                  </a:extLst>
-                </a:gridCol>
-                <a:gridCol w="2438399">
-                  <a:extLst>
-                    <a:ext uri="{9D8B030D-6E8A-4147-A177-3AD203B41FA5}">
-                      <a16:colId xmlns:a16="http://schemas.microsoft.com/office/drawing/2014/main" val="3934093011"/>
-                    </a:ext>
-                  </a:extLst>
-                </a:gridCol>
-                <a:gridCol w="2438399">
-                  <a:extLst>
-                    <a:ext uri="{9D8B030D-6E8A-4147-A177-3AD203B41FA5}">
-                      <a16:colId xmlns:a16="http://schemas.microsoft.com/office/drawing/2014/main" val="4242026328"/>
-                    </a:ext>
-                  </a:extLst>
-                </a:gridCol>
-                <a:gridCol w="2438399">
-                  <a:extLst>
-                    <a:ext uri="{9D8B030D-6E8A-4147-A177-3AD203B41FA5}">
-                      <a16:colId xmlns:a16="http://schemas.microsoft.com/office/drawing/2014/main" val="1879307376"/>
-                    </a:ext>
-                  </a:extLst>
-                </a:gridCol>
-                <a:gridCol w="2438399">
-                  <a:extLst>
-                    <a:ext uri="{9D8B030D-6E8A-4147-A177-3AD203B41FA5}">
-                      <a16:colId xmlns:a16="http://schemas.microsoft.com/office/drawing/2014/main" val="1809691325"/>
-                    </a:ext>
-                  </a:extLst>
-                </a:gridCol>
-              </a:tblGrid>
-              <a:tr h="710293">
-                <a:tc>
-                  <a:txBody>
-                    <a:bodyPr/>
-                    <a:lstStyle/>
-                    <a:p>
-                      <a:pPr>
-                        <a:lnSpc>
-                          <a:spcPct val="115000"/>
-                        </a:lnSpc>
-                        <a:spcAft>
-                          <a:spcPts val="800"/>
-                        </a:spcAft>
-                        <a:buNone/>
-                      </a:pPr>
-                      <a:r>
-                        <a:rPr lang="en-GB" sz="2400" kern="100" dirty="0">
-                          <a:effectLst/>
-                        </a:rPr>
-                        <a:t>Category</a:t>
-                      </a:r>
-                      <a:endParaRPr lang="en-GB" sz="2400" kern="100" dirty="0">
-                        <a:effectLst/>
-                        <a:latin typeface="Aptos" panose="020B0004020202020204" pitchFamily="34" charset="0"/>
-                        <a:ea typeface="Aptos" panose="020B0004020202020204" pitchFamily="34" charset="0"/>
-                        <a:cs typeface="Times New Roman" panose="02020603050405020304" pitchFamily="18" charset="0"/>
-                      </a:endParaRPr>
-                    </a:p>
-                  </a:txBody>
-                  <a:tcPr marL="9525" marR="9525" marT="9525" marB="9525" anchor="ctr"/>
-                </a:tc>
-                <a:tc>
-                  <a:txBody>
-                    <a:bodyPr/>
-                    <a:lstStyle/>
-                    <a:p>
-                      <a:pPr>
-                        <a:lnSpc>
-                          <a:spcPct val="115000"/>
-                        </a:lnSpc>
-                        <a:spcAft>
-                          <a:spcPts val="800"/>
-                        </a:spcAft>
-                        <a:buNone/>
-                      </a:pPr>
-                      <a:r>
-                        <a:rPr lang="en-GB" sz="2400" kern="100">
-                          <a:effectLst/>
-                        </a:rPr>
-                        <a:t>Simple App</a:t>
-                      </a:r>
-                      <a:endParaRPr lang="en-GB" sz="2400" kern="100">
-                        <a:effectLst/>
-                        <a:latin typeface="Aptos" panose="020B0004020202020204" pitchFamily="34" charset="0"/>
-                        <a:ea typeface="Aptos" panose="020B0004020202020204" pitchFamily="34" charset="0"/>
-                        <a:cs typeface="Times New Roman" panose="02020603050405020304" pitchFamily="18" charset="0"/>
-                      </a:endParaRPr>
-                    </a:p>
-                  </a:txBody>
-                  <a:tcPr marL="9525" marR="9525" marT="9525" marB="9525" anchor="ctr"/>
-                </a:tc>
-                <a:tc>
-                  <a:txBody>
-                    <a:bodyPr/>
-                    <a:lstStyle/>
-                    <a:p>
-                      <a:pPr>
-                        <a:lnSpc>
-                          <a:spcPct val="115000"/>
-                        </a:lnSpc>
-                        <a:spcAft>
-                          <a:spcPts val="800"/>
-                        </a:spcAft>
-                        <a:buNone/>
-                      </a:pPr>
-                      <a:r>
-                        <a:rPr lang="en-GB" sz="2400" kern="100">
-                          <a:effectLst/>
-                        </a:rPr>
-                        <a:t>Medium App</a:t>
-                      </a:r>
-                      <a:endParaRPr lang="en-GB" sz="2400" kern="100">
-                        <a:effectLst/>
-                        <a:latin typeface="Aptos" panose="020B0004020202020204" pitchFamily="34" charset="0"/>
-                        <a:ea typeface="Aptos" panose="020B0004020202020204" pitchFamily="34" charset="0"/>
-                        <a:cs typeface="Times New Roman" panose="02020603050405020304" pitchFamily="18" charset="0"/>
-                      </a:endParaRPr>
-                    </a:p>
-                  </a:txBody>
-                  <a:tcPr marL="9525" marR="9525" marT="9525" marB="9525" anchor="ctr"/>
-                </a:tc>
-                <a:tc>
-                  <a:txBody>
-                    <a:bodyPr/>
-                    <a:lstStyle/>
-                    <a:p>
-                      <a:pPr>
-                        <a:lnSpc>
-                          <a:spcPct val="115000"/>
-                        </a:lnSpc>
-                        <a:spcAft>
-                          <a:spcPts val="800"/>
-                        </a:spcAft>
-                        <a:buNone/>
-                      </a:pPr>
-                      <a:r>
-                        <a:rPr lang="en-GB" sz="2400" kern="100">
-                          <a:effectLst/>
-                        </a:rPr>
-                        <a:t>Complex App</a:t>
-                      </a:r>
-                      <a:endParaRPr lang="en-GB" sz="2400" kern="100">
-                        <a:effectLst/>
-                        <a:latin typeface="Aptos" panose="020B0004020202020204" pitchFamily="34" charset="0"/>
-                        <a:ea typeface="Aptos" panose="020B0004020202020204" pitchFamily="34" charset="0"/>
-                        <a:cs typeface="Times New Roman" panose="02020603050405020304" pitchFamily="18" charset="0"/>
-                      </a:endParaRPr>
-                    </a:p>
-                  </a:txBody>
-                  <a:tcPr marL="9525" marR="9525" marT="9525" marB="9525" anchor="ctr"/>
-                </a:tc>
-                <a:tc>
-                  <a:txBody>
-                    <a:bodyPr/>
-                    <a:lstStyle/>
-                    <a:p>
-                      <a:pPr>
-                        <a:lnSpc>
-                          <a:spcPct val="115000"/>
-                        </a:lnSpc>
-                        <a:spcAft>
-                          <a:spcPts val="800"/>
-                        </a:spcAft>
-                        <a:buNone/>
-                      </a:pPr>
-                      <a:r>
-                        <a:rPr lang="en-GB" sz="2400" kern="100">
-                          <a:effectLst/>
-                        </a:rPr>
-                        <a:t>Enterprise App</a:t>
-                      </a:r>
-                      <a:endParaRPr lang="en-GB" sz="2400" kern="100">
-                        <a:effectLst/>
-                        <a:latin typeface="Aptos" panose="020B0004020202020204" pitchFamily="34" charset="0"/>
-                        <a:ea typeface="Aptos" panose="020B0004020202020204" pitchFamily="34" charset="0"/>
-                        <a:cs typeface="Times New Roman" panose="02020603050405020304" pitchFamily="18" charset="0"/>
-                      </a:endParaRPr>
-                    </a:p>
-                  </a:txBody>
-                  <a:tcPr marL="9525" marR="9525" marT="9525" marB="9525" anchor="ctr"/>
-                </a:tc>
-                <a:extLst>
-                  <a:ext uri="{0D108BD9-81ED-4DB2-BD59-A6C34878D82A}">
-                    <a16:rowId xmlns:a16="http://schemas.microsoft.com/office/drawing/2014/main" val="842949910"/>
-                  </a:ext>
-                </a:extLst>
-              </a:tr>
-              <a:tr h="710293">
-                <a:tc>
-                  <a:txBody>
-                    <a:bodyPr/>
-                    <a:lstStyle/>
-                    <a:p>
-                      <a:pPr>
-                        <a:lnSpc>
-                          <a:spcPct val="115000"/>
-                        </a:lnSpc>
-                        <a:spcAft>
-                          <a:spcPts val="800"/>
-                        </a:spcAft>
-                        <a:buNone/>
-                      </a:pPr>
-                      <a:r>
-                        <a:rPr lang="en-GB" sz="2400" kern="100">
-                          <a:effectLst/>
-                        </a:rPr>
-                        <a:t>Examples</a:t>
-                      </a:r>
-                      <a:endParaRPr lang="en-GB" sz="2400" kern="100">
-                        <a:effectLst/>
-                        <a:latin typeface="Aptos" panose="020B0004020202020204" pitchFamily="34" charset="0"/>
-                        <a:ea typeface="Aptos" panose="020B0004020202020204" pitchFamily="34" charset="0"/>
-                        <a:cs typeface="Times New Roman" panose="02020603050405020304" pitchFamily="18" charset="0"/>
-                      </a:endParaRPr>
-                    </a:p>
-                  </a:txBody>
-                  <a:tcPr marL="9525" marR="9525" marT="9525" marB="9525" anchor="ctr"/>
-                </a:tc>
-                <a:tc>
-                  <a:txBody>
-                    <a:bodyPr/>
-                    <a:lstStyle/>
-                    <a:p>
-                      <a:pPr>
-                        <a:lnSpc>
-                          <a:spcPct val="115000"/>
-                        </a:lnSpc>
-                        <a:spcAft>
-                          <a:spcPts val="800"/>
-                        </a:spcAft>
-                        <a:buNone/>
-                      </a:pPr>
-                      <a:r>
-                        <a:rPr lang="en-GB" sz="2400" kern="100">
-                          <a:effectLst/>
-                        </a:rPr>
-                        <a:t>Calculator, To-do list</a:t>
-                      </a:r>
-                      <a:endParaRPr lang="en-GB" sz="2400" kern="100">
-                        <a:effectLst/>
-                        <a:latin typeface="Aptos" panose="020B0004020202020204" pitchFamily="34" charset="0"/>
-                        <a:ea typeface="Aptos" panose="020B0004020202020204" pitchFamily="34" charset="0"/>
-                        <a:cs typeface="Times New Roman" panose="02020603050405020304" pitchFamily="18" charset="0"/>
-                      </a:endParaRPr>
-                    </a:p>
-                  </a:txBody>
-                  <a:tcPr marL="9525" marR="9525" marT="9525" marB="9525" anchor="ctr"/>
-                </a:tc>
-                <a:tc>
-                  <a:txBody>
-                    <a:bodyPr/>
-                    <a:lstStyle/>
-                    <a:p>
-                      <a:pPr>
-                        <a:lnSpc>
-                          <a:spcPct val="115000"/>
-                        </a:lnSpc>
-                        <a:spcAft>
-                          <a:spcPts val="800"/>
-                        </a:spcAft>
-                        <a:buNone/>
-                      </a:pPr>
-                      <a:r>
-                        <a:rPr lang="en-GB" sz="2400" kern="100">
-                          <a:effectLst/>
-                        </a:rPr>
-                        <a:t>E-commerce, Social feed</a:t>
-                      </a:r>
-                      <a:endParaRPr lang="en-GB" sz="2400" kern="100">
-                        <a:effectLst/>
-                        <a:latin typeface="Aptos" panose="020B0004020202020204" pitchFamily="34" charset="0"/>
-                        <a:ea typeface="Aptos" panose="020B0004020202020204" pitchFamily="34" charset="0"/>
-                        <a:cs typeface="Times New Roman" panose="02020603050405020304" pitchFamily="18" charset="0"/>
-                      </a:endParaRPr>
-                    </a:p>
-                  </a:txBody>
-                  <a:tcPr marL="9525" marR="9525" marT="9525" marB="9525" anchor="ctr"/>
-                </a:tc>
-                <a:tc>
-                  <a:txBody>
-                    <a:bodyPr/>
-                    <a:lstStyle/>
-                    <a:p>
-                      <a:pPr>
-                        <a:lnSpc>
-                          <a:spcPct val="115000"/>
-                        </a:lnSpc>
-                        <a:spcAft>
-                          <a:spcPts val="800"/>
-                        </a:spcAft>
-                        <a:buNone/>
-                      </a:pPr>
-                      <a:r>
-                        <a:rPr lang="en-GB" sz="2400" kern="100">
-                          <a:effectLst/>
-                        </a:rPr>
-                        <a:t>AR/VR, AI, Fintech</a:t>
-                      </a:r>
-                      <a:endParaRPr lang="en-GB" sz="2400" kern="100">
-                        <a:effectLst/>
-                        <a:latin typeface="Aptos" panose="020B0004020202020204" pitchFamily="34" charset="0"/>
-                        <a:ea typeface="Aptos" panose="020B0004020202020204" pitchFamily="34" charset="0"/>
-                        <a:cs typeface="Times New Roman" panose="02020603050405020304" pitchFamily="18" charset="0"/>
-                      </a:endParaRPr>
-                    </a:p>
-                  </a:txBody>
-                  <a:tcPr marL="9525" marR="9525" marT="9525" marB="9525" anchor="ctr"/>
-                </a:tc>
-                <a:tc>
-                  <a:txBody>
-                    <a:bodyPr/>
-                    <a:lstStyle/>
-                    <a:p>
-                      <a:pPr>
-                        <a:lnSpc>
-                          <a:spcPct val="115000"/>
-                        </a:lnSpc>
-                        <a:spcAft>
-                          <a:spcPts val="800"/>
-                        </a:spcAft>
-                        <a:buNone/>
-                      </a:pPr>
-                      <a:r>
-                        <a:rPr lang="en-GB" sz="2400" kern="100">
-                          <a:effectLst/>
-                        </a:rPr>
-                        <a:t>Multi-platform enterprise</a:t>
-                      </a:r>
-                      <a:endParaRPr lang="en-GB" sz="2400" kern="100">
-                        <a:effectLst/>
-                        <a:latin typeface="Aptos" panose="020B0004020202020204" pitchFamily="34" charset="0"/>
-                        <a:ea typeface="Aptos" panose="020B0004020202020204" pitchFamily="34" charset="0"/>
-                        <a:cs typeface="Times New Roman" panose="02020603050405020304" pitchFamily="18" charset="0"/>
-                      </a:endParaRPr>
-                    </a:p>
-                  </a:txBody>
-                  <a:tcPr marL="9525" marR="9525" marT="9525" marB="9525" anchor="ctr"/>
-                </a:tc>
-                <a:extLst>
-                  <a:ext uri="{0D108BD9-81ED-4DB2-BD59-A6C34878D82A}">
-                    <a16:rowId xmlns:a16="http://schemas.microsoft.com/office/drawing/2014/main" val="3451353821"/>
-                  </a:ext>
-                </a:extLst>
-              </a:tr>
-              <a:tr h="710293">
-                <a:tc>
-                  <a:txBody>
-                    <a:bodyPr/>
-                    <a:lstStyle/>
-                    <a:p>
-                      <a:pPr>
-                        <a:lnSpc>
-                          <a:spcPct val="115000"/>
-                        </a:lnSpc>
-                        <a:spcAft>
-                          <a:spcPts val="800"/>
-                        </a:spcAft>
-                        <a:buNone/>
-                      </a:pPr>
-                      <a:r>
-                        <a:rPr lang="en-GB" sz="2400" kern="100">
-                          <a:effectLst/>
-                        </a:rPr>
-                        <a:t>Cost Range</a:t>
-                      </a:r>
-                      <a:endParaRPr lang="en-GB" sz="2400" kern="100">
-                        <a:effectLst/>
-                        <a:latin typeface="Aptos" panose="020B0004020202020204" pitchFamily="34" charset="0"/>
-                        <a:ea typeface="Aptos" panose="020B0004020202020204" pitchFamily="34" charset="0"/>
-                        <a:cs typeface="Times New Roman" panose="02020603050405020304" pitchFamily="18" charset="0"/>
-                      </a:endParaRPr>
-                    </a:p>
-                  </a:txBody>
-                  <a:tcPr marL="9525" marR="9525" marT="9525" marB="9525" anchor="ctr"/>
-                </a:tc>
-                <a:tc>
-                  <a:txBody>
-                    <a:bodyPr/>
-                    <a:lstStyle/>
-                    <a:p>
-                      <a:pPr>
-                        <a:lnSpc>
-                          <a:spcPct val="115000"/>
-                        </a:lnSpc>
-                        <a:spcAft>
-                          <a:spcPts val="800"/>
-                        </a:spcAft>
-                        <a:buNone/>
-                      </a:pPr>
-                      <a:r>
-                        <a:rPr lang="en-GB" sz="2400" kern="100" dirty="0">
-                          <a:effectLst/>
-                        </a:rPr>
-                        <a:t>$5k–$50k</a:t>
-                      </a:r>
-                      <a:endParaRPr lang="en-GB" sz="2400" kern="100" dirty="0">
-                        <a:effectLst/>
-                        <a:latin typeface="Aptos" panose="020B0004020202020204" pitchFamily="34" charset="0"/>
-                        <a:ea typeface="Aptos" panose="020B0004020202020204" pitchFamily="34" charset="0"/>
-                        <a:cs typeface="Times New Roman" panose="02020603050405020304" pitchFamily="18" charset="0"/>
-                      </a:endParaRPr>
-                    </a:p>
-                  </a:txBody>
-                  <a:tcPr marL="9525" marR="9525" marT="9525" marB="9525" anchor="ctr"/>
-                </a:tc>
-                <a:tc>
-                  <a:txBody>
-                    <a:bodyPr/>
-                    <a:lstStyle/>
-                    <a:p>
-                      <a:pPr>
-                        <a:lnSpc>
-                          <a:spcPct val="115000"/>
-                        </a:lnSpc>
-                        <a:spcAft>
-                          <a:spcPts val="800"/>
-                        </a:spcAft>
-                        <a:buNone/>
-                      </a:pPr>
-                      <a:r>
-                        <a:rPr lang="en-GB" sz="2400" kern="100" dirty="0">
-                          <a:effectLst/>
-                        </a:rPr>
-                        <a:t>$50k–$120k</a:t>
-                      </a:r>
-                      <a:endParaRPr lang="en-GB" sz="2400" kern="100" dirty="0">
-                        <a:effectLst/>
-                        <a:latin typeface="Aptos" panose="020B0004020202020204" pitchFamily="34" charset="0"/>
-                        <a:ea typeface="Aptos" panose="020B0004020202020204" pitchFamily="34" charset="0"/>
-                        <a:cs typeface="Times New Roman" panose="02020603050405020304" pitchFamily="18" charset="0"/>
-                      </a:endParaRPr>
-                    </a:p>
-                  </a:txBody>
-                  <a:tcPr marL="9525" marR="9525" marT="9525" marB="9525" anchor="ctr"/>
-                </a:tc>
-                <a:tc>
-                  <a:txBody>
-                    <a:bodyPr/>
-                    <a:lstStyle/>
-                    <a:p>
-                      <a:pPr>
-                        <a:lnSpc>
-                          <a:spcPct val="115000"/>
-                        </a:lnSpc>
-                        <a:spcAft>
-                          <a:spcPts val="800"/>
-                        </a:spcAft>
-                        <a:buNone/>
-                      </a:pPr>
-                      <a:r>
-                        <a:rPr lang="en-GB" sz="2400" kern="100">
-                          <a:effectLst/>
-                        </a:rPr>
-                        <a:t>$100k–$300k</a:t>
-                      </a:r>
-                      <a:endParaRPr lang="en-GB" sz="2400" kern="100">
-                        <a:effectLst/>
-                        <a:latin typeface="Aptos" panose="020B0004020202020204" pitchFamily="34" charset="0"/>
-                        <a:ea typeface="Aptos" panose="020B0004020202020204" pitchFamily="34" charset="0"/>
-                        <a:cs typeface="Times New Roman" panose="02020603050405020304" pitchFamily="18" charset="0"/>
-                      </a:endParaRPr>
-                    </a:p>
-                  </a:txBody>
-                  <a:tcPr marL="9525" marR="9525" marT="9525" marB="9525" anchor="ctr"/>
-                </a:tc>
-                <a:tc>
-                  <a:txBody>
-                    <a:bodyPr/>
-                    <a:lstStyle/>
-                    <a:p>
-                      <a:pPr>
-                        <a:lnSpc>
-                          <a:spcPct val="115000"/>
-                        </a:lnSpc>
-                        <a:spcAft>
-                          <a:spcPts val="800"/>
-                        </a:spcAft>
-                        <a:buNone/>
-                      </a:pPr>
-                      <a:r>
-                        <a:rPr lang="en-GB" sz="2400" kern="100">
-                          <a:effectLst/>
-                        </a:rPr>
-                        <a:t>$300k–$500k+</a:t>
-                      </a:r>
-                      <a:endParaRPr lang="en-GB" sz="2400" kern="100">
-                        <a:effectLst/>
-                        <a:latin typeface="Aptos" panose="020B0004020202020204" pitchFamily="34" charset="0"/>
-                        <a:ea typeface="Aptos" panose="020B0004020202020204" pitchFamily="34" charset="0"/>
-                        <a:cs typeface="Times New Roman" panose="02020603050405020304" pitchFamily="18" charset="0"/>
-                      </a:endParaRPr>
-                    </a:p>
-                  </a:txBody>
-                  <a:tcPr marL="9525" marR="9525" marT="9525" marB="9525" anchor="ctr"/>
-                </a:tc>
-                <a:extLst>
-                  <a:ext uri="{0D108BD9-81ED-4DB2-BD59-A6C34878D82A}">
-                    <a16:rowId xmlns:a16="http://schemas.microsoft.com/office/drawing/2014/main" val="942479544"/>
-                  </a:ext>
-                </a:extLst>
-              </a:tr>
-              <a:tr h="710293">
-                <a:tc>
-                  <a:txBody>
-                    <a:bodyPr/>
-                    <a:lstStyle/>
-                    <a:p>
-                      <a:pPr>
-                        <a:lnSpc>
-                          <a:spcPct val="115000"/>
-                        </a:lnSpc>
-                        <a:spcAft>
-                          <a:spcPts val="800"/>
-                        </a:spcAft>
-                        <a:buNone/>
-                      </a:pPr>
-                      <a:r>
-                        <a:rPr lang="en-GB" sz="2400" kern="100">
-                          <a:effectLst/>
-                        </a:rPr>
-                        <a:t>Timeline</a:t>
-                      </a:r>
-                      <a:endParaRPr lang="en-GB" sz="2400" kern="100">
-                        <a:effectLst/>
-                        <a:latin typeface="Aptos" panose="020B0004020202020204" pitchFamily="34" charset="0"/>
-                        <a:ea typeface="Aptos" panose="020B0004020202020204" pitchFamily="34" charset="0"/>
-                        <a:cs typeface="Times New Roman" panose="02020603050405020304" pitchFamily="18" charset="0"/>
-                      </a:endParaRPr>
-                    </a:p>
-                  </a:txBody>
-                  <a:tcPr marL="9525" marR="9525" marT="9525" marB="9525" anchor="ctr"/>
-                </a:tc>
-                <a:tc>
-                  <a:txBody>
-                    <a:bodyPr/>
-                    <a:lstStyle/>
-                    <a:p>
-                      <a:pPr>
-                        <a:lnSpc>
-                          <a:spcPct val="115000"/>
-                        </a:lnSpc>
-                        <a:spcAft>
-                          <a:spcPts val="800"/>
-                        </a:spcAft>
-                        <a:buNone/>
-                      </a:pPr>
-                      <a:r>
-                        <a:rPr lang="en-GB" sz="2400" kern="100">
-                          <a:effectLst/>
-                        </a:rPr>
-                        <a:t>1–3 months</a:t>
-                      </a:r>
-                      <a:endParaRPr lang="en-GB" sz="2400" kern="100">
-                        <a:effectLst/>
-                        <a:latin typeface="Aptos" panose="020B0004020202020204" pitchFamily="34" charset="0"/>
-                        <a:ea typeface="Aptos" panose="020B0004020202020204" pitchFamily="34" charset="0"/>
-                        <a:cs typeface="Times New Roman" panose="02020603050405020304" pitchFamily="18" charset="0"/>
-                      </a:endParaRPr>
-                    </a:p>
-                  </a:txBody>
-                  <a:tcPr marL="9525" marR="9525" marT="9525" marB="9525" anchor="ctr"/>
-                </a:tc>
-                <a:tc>
-                  <a:txBody>
-                    <a:bodyPr/>
-                    <a:lstStyle/>
-                    <a:p>
-                      <a:pPr>
-                        <a:lnSpc>
-                          <a:spcPct val="115000"/>
-                        </a:lnSpc>
-                        <a:spcAft>
-                          <a:spcPts val="800"/>
-                        </a:spcAft>
-                        <a:buNone/>
-                      </a:pPr>
-                      <a:r>
-                        <a:rPr lang="en-GB" sz="2400" kern="100">
-                          <a:effectLst/>
-                        </a:rPr>
-                        <a:t>3–6 months</a:t>
-                      </a:r>
-                      <a:endParaRPr lang="en-GB" sz="2400" kern="100">
-                        <a:effectLst/>
-                        <a:latin typeface="Aptos" panose="020B0004020202020204" pitchFamily="34" charset="0"/>
-                        <a:ea typeface="Aptos" panose="020B0004020202020204" pitchFamily="34" charset="0"/>
-                        <a:cs typeface="Times New Roman" panose="02020603050405020304" pitchFamily="18" charset="0"/>
-                      </a:endParaRPr>
-                    </a:p>
-                  </a:txBody>
-                  <a:tcPr marL="9525" marR="9525" marT="9525" marB="9525" anchor="ctr"/>
-                </a:tc>
-                <a:tc>
-                  <a:txBody>
-                    <a:bodyPr/>
-                    <a:lstStyle/>
-                    <a:p>
-                      <a:pPr>
-                        <a:lnSpc>
-                          <a:spcPct val="115000"/>
-                        </a:lnSpc>
-                        <a:spcAft>
-                          <a:spcPts val="800"/>
-                        </a:spcAft>
-                        <a:buNone/>
-                      </a:pPr>
-                      <a:r>
-                        <a:rPr lang="en-GB" sz="2400" kern="100">
-                          <a:effectLst/>
-                        </a:rPr>
-                        <a:t>6–12 months</a:t>
-                      </a:r>
-                      <a:endParaRPr lang="en-GB" sz="2400" kern="100">
-                        <a:effectLst/>
-                        <a:latin typeface="Aptos" panose="020B0004020202020204" pitchFamily="34" charset="0"/>
-                        <a:ea typeface="Aptos" panose="020B0004020202020204" pitchFamily="34" charset="0"/>
-                        <a:cs typeface="Times New Roman" panose="02020603050405020304" pitchFamily="18" charset="0"/>
-                      </a:endParaRPr>
-                    </a:p>
-                  </a:txBody>
-                  <a:tcPr marL="9525" marR="9525" marT="9525" marB="9525" anchor="ctr"/>
-                </a:tc>
-                <a:tc>
-                  <a:txBody>
-                    <a:bodyPr/>
-                    <a:lstStyle/>
-                    <a:p>
-                      <a:pPr>
-                        <a:lnSpc>
-                          <a:spcPct val="115000"/>
-                        </a:lnSpc>
-                        <a:spcAft>
-                          <a:spcPts val="800"/>
-                        </a:spcAft>
-                        <a:buNone/>
-                      </a:pPr>
-                      <a:r>
-                        <a:rPr lang="en-GB" sz="2400" kern="100">
-                          <a:effectLst/>
-                        </a:rPr>
-                        <a:t>12+ months</a:t>
-                      </a:r>
-                      <a:endParaRPr lang="en-GB" sz="2400" kern="100">
-                        <a:effectLst/>
-                        <a:latin typeface="Aptos" panose="020B0004020202020204" pitchFamily="34" charset="0"/>
-                        <a:ea typeface="Aptos" panose="020B0004020202020204" pitchFamily="34" charset="0"/>
-                        <a:cs typeface="Times New Roman" panose="02020603050405020304" pitchFamily="18" charset="0"/>
-                      </a:endParaRPr>
-                    </a:p>
-                  </a:txBody>
-                  <a:tcPr marL="9525" marR="9525" marT="9525" marB="9525" anchor="ctr"/>
-                </a:tc>
-                <a:extLst>
-                  <a:ext uri="{0D108BD9-81ED-4DB2-BD59-A6C34878D82A}">
-                    <a16:rowId xmlns:a16="http://schemas.microsoft.com/office/drawing/2014/main" val="3768332501"/>
-                  </a:ext>
-                </a:extLst>
-              </a:tr>
-              <a:tr h="710293">
-                <a:tc>
-                  <a:txBody>
-                    <a:bodyPr/>
-                    <a:lstStyle/>
-                    <a:p>
-                      <a:pPr>
-                        <a:lnSpc>
-                          <a:spcPct val="115000"/>
-                        </a:lnSpc>
-                        <a:spcAft>
-                          <a:spcPts val="800"/>
-                        </a:spcAft>
-                        <a:buNone/>
-                      </a:pPr>
-                      <a:r>
-                        <a:rPr lang="en-GB" sz="2400" kern="100">
-                          <a:effectLst/>
-                        </a:rPr>
-                        <a:t>Team Size</a:t>
-                      </a:r>
-                      <a:endParaRPr lang="en-GB" sz="2400" kern="100">
-                        <a:effectLst/>
-                        <a:latin typeface="Aptos" panose="020B0004020202020204" pitchFamily="34" charset="0"/>
-                        <a:ea typeface="Aptos" panose="020B0004020202020204" pitchFamily="34" charset="0"/>
-                        <a:cs typeface="Times New Roman" panose="02020603050405020304" pitchFamily="18" charset="0"/>
-                      </a:endParaRPr>
-                    </a:p>
-                  </a:txBody>
-                  <a:tcPr marL="9525" marR="9525" marT="9525" marB="9525" anchor="ctr"/>
-                </a:tc>
-                <a:tc>
-                  <a:txBody>
-                    <a:bodyPr/>
-                    <a:lstStyle/>
-                    <a:p>
-                      <a:pPr>
-                        <a:lnSpc>
-                          <a:spcPct val="115000"/>
-                        </a:lnSpc>
-                        <a:spcAft>
-                          <a:spcPts val="800"/>
-                        </a:spcAft>
-                        <a:buNone/>
-                      </a:pPr>
-                      <a:r>
-                        <a:rPr lang="en-GB" sz="2400" kern="100">
-                          <a:effectLst/>
-                        </a:rPr>
-                        <a:t>2–3 people</a:t>
-                      </a:r>
-                      <a:endParaRPr lang="en-GB" sz="2400" kern="100">
-                        <a:effectLst/>
-                        <a:latin typeface="Aptos" panose="020B0004020202020204" pitchFamily="34" charset="0"/>
-                        <a:ea typeface="Aptos" panose="020B0004020202020204" pitchFamily="34" charset="0"/>
-                        <a:cs typeface="Times New Roman" panose="02020603050405020304" pitchFamily="18" charset="0"/>
-                      </a:endParaRPr>
-                    </a:p>
-                  </a:txBody>
-                  <a:tcPr marL="9525" marR="9525" marT="9525" marB="9525" anchor="ctr"/>
-                </a:tc>
-                <a:tc>
-                  <a:txBody>
-                    <a:bodyPr/>
-                    <a:lstStyle/>
-                    <a:p>
-                      <a:pPr>
-                        <a:lnSpc>
-                          <a:spcPct val="115000"/>
-                        </a:lnSpc>
-                        <a:spcAft>
-                          <a:spcPts val="800"/>
-                        </a:spcAft>
-                        <a:buNone/>
-                      </a:pPr>
-                      <a:r>
-                        <a:rPr lang="en-GB" sz="2400" kern="100" dirty="0">
-                          <a:effectLst/>
-                        </a:rPr>
-                        <a:t>4–6 people</a:t>
-                      </a:r>
-                      <a:endParaRPr lang="en-GB" sz="2400" kern="100" dirty="0">
-                        <a:effectLst/>
-                        <a:latin typeface="Aptos" panose="020B0004020202020204" pitchFamily="34" charset="0"/>
-                        <a:ea typeface="Aptos" panose="020B0004020202020204" pitchFamily="34" charset="0"/>
-                        <a:cs typeface="Times New Roman" panose="02020603050405020304" pitchFamily="18" charset="0"/>
-                      </a:endParaRPr>
-                    </a:p>
-                  </a:txBody>
-                  <a:tcPr marL="9525" marR="9525" marT="9525" marB="9525" anchor="ctr"/>
-                </a:tc>
-                <a:tc>
-                  <a:txBody>
-                    <a:bodyPr/>
-                    <a:lstStyle/>
-                    <a:p>
-                      <a:pPr>
-                        <a:lnSpc>
-                          <a:spcPct val="115000"/>
-                        </a:lnSpc>
-                        <a:spcAft>
-                          <a:spcPts val="800"/>
-                        </a:spcAft>
-                        <a:buNone/>
-                      </a:pPr>
-                      <a:r>
-                        <a:rPr lang="en-GB" sz="2400" kern="100">
-                          <a:effectLst/>
-                        </a:rPr>
-                        <a:t>7–12 people</a:t>
-                      </a:r>
-                      <a:endParaRPr lang="en-GB" sz="2400" kern="100">
-                        <a:effectLst/>
-                        <a:latin typeface="Aptos" panose="020B0004020202020204" pitchFamily="34" charset="0"/>
-                        <a:ea typeface="Aptos" panose="020B0004020202020204" pitchFamily="34" charset="0"/>
-                        <a:cs typeface="Times New Roman" panose="02020603050405020304" pitchFamily="18" charset="0"/>
-                      </a:endParaRPr>
-                    </a:p>
-                  </a:txBody>
-                  <a:tcPr marL="9525" marR="9525" marT="9525" marB="9525" anchor="ctr"/>
-                </a:tc>
-                <a:tc>
-                  <a:txBody>
-                    <a:bodyPr/>
-                    <a:lstStyle/>
-                    <a:p>
-                      <a:pPr>
-                        <a:lnSpc>
-                          <a:spcPct val="115000"/>
-                        </a:lnSpc>
-                        <a:spcAft>
-                          <a:spcPts val="800"/>
-                        </a:spcAft>
-                        <a:buNone/>
-                      </a:pPr>
-                      <a:r>
-                        <a:rPr lang="en-GB" sz="2400" kern="100">
-                          <a:effectLst/>
-                        </a:rPr>
-                        <a:t>12+ people</a:t>
-                      </a:r>
-                      <a:endParaRPr lang="en-GB" sz="2400" kern="100">
-                        <a:effectLst/>
-                        <a:latin typeface="Aptos" panose="020B0004020202020204" pitchFamily="34" charset="0"/>
-                        <a:ea typeface="Aptos" panose="020B0004020202020204" pitchFamily="34" charset="0"/>
-                        <a:cs typeface="Times New Roman" panose="02020603050405020304" pitchFamily="18" charset="0"/>
-                      </a:endParaRPr>
-                    </a:p>
-                  </a:txBody>
-                  <a:tcPr marL="9525" marR="9525" marT="9525" marB="9525" anchor="ctr"/>
-                </a:tc>
-                <a:extLst>
-                  <a:ext uri="{0D108BD9-81ED-4DB2-BD59-A6C34878D82A}">
-                    <a16:rowId xmlns:a16="http://schemas.microsoft.com/office/drawing/2014/main" val="268668875"/>
-                  </a:ext>
-                </a:extLst>
-              </a:tr>
-              <a:tr h="710293">
-                <a:tc>
-                  <a:txBody>
-                    <a:bodyPr/>
-                    <a:lstStyle/>
-                    <a:p>
-                      <a:pPr>
-                        <a:lnSpc>
-                          <a:spcPct val="115000"/>
-                        </a:lnSpc>
-                        <a:spcAft>
-                          <a:spcPts val="800"/>
-                        </a:spcAft>
-                        <a:buNone/>
-                      </a:pPr>
-                      <a:r>
-                        <a:rPr lang="en-GB" sz="2400" kern="100">
-                          <a:effectLst/>
-                        </a:rPr>
-                        <a:t>Maintenance/yr</a:t>
-                      </a:r>
-                      <a:endParaRPr lang="en-GB" sz="2400" kern="100">
-                        <a:effectLst/>
-                        <a:latin typeface="Aptos" panose="020B0004020202020204" pitchFamily="34" charset="0"/>
-                        <a:ea typeface="Aptos" panose="020B0004020202020204" pitchFamily="34" charset="0"/>
-                        <a:cs typeface="Times New Roman" panose="02020603050405020304" pitchFamily="18" charset="0"/>
-                      </a:endParaRPr>
-                    </a:p>
-                  </a:txBody>
-                  <a:tcPr marL="9525" marR="9525" marT="9525" marB="9525" anchor="ctr"/>
-                </a:tc>
-                <a:tc>
-                  <a:txBody>
-                    <a:bodyPr/>
-                    <a:lstStyle/>
-                    <a:p>
-                      <a:pPr>
-                        <a:lnSpc>
-                          <a:spcPct val="115000"/>
-                        </a:lnSpc>
-                        <a:spcAft>
-                          <a:spcPts val="800"/>
-                        </a:spcAft>
-                        <a:buNone/>
-                      </a:pPr>
-                      <a:r>
-                        <a:rPr lang="en-GB" sz="2400" kern="100">
-                          <a:effectLst/>
-                        </a:rPr>
-                        <a:t>$1k–$10k</a:t>
-                      </a:r>
-                      <a:endParaRPr lang="en-GB" sz="2400" kern="100">
-                        <a:effectLst/>
-                        <a:latin typeface="Aptos" panose="020B0004020202020204" pitchFamily="34" charset="0"/>
-                        <a:ea typeface="Aptos" panose="020B0004020202020204" pitchFamily="34" charset="0"/>
-                        <a:cs typeface="Times New Roman" panose="02020603050405020304" pitchFamily="18" charset="0"/>
-                      </a:endParaRPr>
-                    </a:p>
-                  </a:txBody>
-                  <a:tcPr marL="9525" marR="9525" marT="9525" marB="9525" anchor="ctr"/>
-                </a:tc>
-                <a:tc>
-                  <a:txBody>
-                    <a:bodyPr/>
-                    <a:lstStyle/>
-                    <a:p>
-                      <a:pPr>
-                        <a:lnSpc>
-                          <a:spcPct val="115000"/>
-                        </a:lnSpc>
-                        <a:spcAft>
-                          <a:spcPts val="800"/>
-                        </a:spcAft>
-                        <a:buNone/>
-                      </a:pPr>
-                      <a:r>
-                        <a:rPr lang="en-GB" sz="2400" kern="100">
-                          <a:effectLst/>
-                        </a:rPr>
-                        <a:t>$10k–$25k</a:t>
-                      </a:r>
-                      <a:endParaRPr lang="en-GB" sz="2400" kern="100">
-                        <a:effectLst/>
-                        <a:latin typeface="Aptos" panose="020B0004020202020204" pitchFamily="34" charset="0"/>
-                        <a:ea typeface="Aptos" panose="020B0004020202020204" pitchFamily="34" charset="0"/>
-                        <a:cs typeface="Times New Roman" panose="02020603050405020304" pitchFamily="18" charset="0"/>
-                      </a:endParaRPr>
-                    </a:p>
-                  </a:txBody>
-                  <a:tcPr marL="9525" marR="9525" marT="9525" marB="9525" anchor="ctr"/>
-                </a:tc>
-                <a:tc>
-                  <a:txBody>
-                    <a:bodyPr/>
-                    <a:lstStyle/>
-                    <a:p>
-                      <a:pPr>
-                        <a:lnSpc>
-                          <a:spcPct val="115000"/>
-                        </a:lnSpc>
-                        <a:spcAft>
-                          <a:spcPts val="800"/>
-                        </a:spcAft>
-                        <a:buNone/>
-                      </a:pPr>
-                      <a:r>
-                        <a:rPr lang="en-GB" sz="2400" kern="100">
-                          <a:effectLst/>
-                        </a:rPr>
-                        <a:t>$25k–$60k</a:t>
-                      </a:r>
-                      <a:endParaRPr lang="en-GB" sz="2400" kern="100">
-                        <a:effectLst/>
-                        <a:latin typeface="Aptos" panose="020B0004020202020204" pitchFamily="34" charset="0"/>
-                        <a:ea typeface="Aptos" panose="020B0004020202020204" pitchFamily="34" charset="0"/>
-                        <a:cs typeface="Times New Roman" panose="02020603050405020304" pitchFamily="18" charset="0"/>
-                      </a:endParaRPr>
-                    </a:p>
-                  </a:txBody>
-                  <a:tcPr marL="9525" marR="9525" marT="9525" marB="9525" anchor="ctr"/>
-                </a:tc>
-                <a:tc>
-                  <a:txBody>
-                    <a:bodyPr/>
-                    <a:lstStyle/>
-                    <a:p>
-                      <a:pPr>
-                        <a:lnSpc>
-                          <a:spcPct val="115000"/>
-                        </a:lnSpc>
-                        <a:spcAft>
-                          <a:spcPts val="800"/>
-                        </a:spcAft>
-                        <a:buNone/>
-                      </a:pPr>
-                      <a:r>
-                        <a:rPr lang="en-GB" sz="2400" kern="100">
-                          <a:effectLst/>
-                        </a:rPr>
-                        <a:t>$60k+</a:t>
-                      </a:r>
-                      <a:endParaRPr lang="en-GB" sz="2400" kern="100">
-                        <a:effectLst/>
-                        <a:latin typeface="Aptos" panose="020B0004020202020204" pitchFamily="34" charset="0"/>
-                        <a:ea typeface="Aptos" panose="020B0004020202020204" pitchFamily="34" charset="0"/>
-                        <a:cs typeface="Times New Roman" panose="02020603050405020304" pitchFamily="18" charset="0"/>
-                      </a:endParaRPr>
-                    </a:p>
-                  </a:txBody>
-                  <a:tcPr marL="9525" marR="9525" marT="9525" marB="9525" anchor="ctr"/>
-                </a:tc>
-                <a:extLst>
-                  <a:ext uri="{0D108BD9-81ED-4DB2-BD59-A6C34878D82A}">
-                    <a16:rowId xmlns:a16="http://schemas.microsoft.com/office/drawing/2014/main" val="533830037"/>
-                  </a:ext>
-                </a:extLst>
-              </a:tr>
-              <a:tr h="710293">
-                <a:tc>
-                  <a:txBody>
-                    <a:bodyPr/>
-                    <a:lstStyle/>
-                    <a:p>
-                      <a:pPr>
-                        <a:lnSpc>
-                          <a:spcPct val="115000"/>
-                        </a:lnSpc>
-                        <a:spcAft>
-                          <a:spcPts val="800"/>
-                        </a:spcAft>
-                        <a:buNone/>
-                      </a:pPr>
-                      <a:r>
-                        <a:rPr lang="en-GB" sz="2400" kern="100">
-                          <a:effectLst/>
-                        </a:rPr>
-                        <a:t>UX/UI Design</a:t>
-                      </a:r>
-                      <a:endParaRPr lang="en-GB" sz="2400" kern="100">
-                        <a:effectLst/>
-                        <a:latin typeface="Aptos" panose="020B0004020202020204" pitchFamily="34" charset="0"/>
-                        <a:ea typeface="Aptos" panose="020B0004020202020204" pitchFamily="34" charset="0"/>
-                        <a:cs typeface="Times New Roman" panose="02020603050405020304" pitchFamily="18" charset="0"/>
-                      </a:endParaRPr>
-                    </a:p>
-                  </a:txBody>
-                  <a:tcPr marL="9525" marR="9525" marT="9525" marB="9525" anchor="ctr"/>
-                </a:tc>
-                <a:tc>
-                  <a:txBody>
-                    <a:bodyPr/>
-                    <a:lstStyle/>
-                    <a:p>
-                      <a:pPr>
-                        <a:lnSpc>
-                          <a:spcPct val="115000"/>
-                        </a:lnSpc>
-                        <a:spcAft>
-                          <a:spcPts val="800"/>
-                        </a:spcAft>
-                        <a:buNone/>
-                      </a:pPr>
-                      <a:r>
-                        <a:rPr lang="en-GB" sz="2400" kern="100">
-                          <a:effectLst/>
-                        </a:rPr>
-                        <a:t>$5k–$10k</a:t>
-                      </a:r>
-                      <a:endParaRPr lang="en-GB" sz="2400" kern="100">
-                        <a:effectLst/>
-                        <a:latin typeface="Aptos" panose="020B0004020202020204" pitchFamily="34" charset="0"/>
-                        <a:ea typeface="Aptos" panose="020B0004020202020204" pitchFamily="34" charset="0"/>
-                        <a:cs typeface="Times New Roman" panose="02020603050405020304" pitchFamily="18" charset="0"/>
-                      </a:endParaRPr>
-                    </a:p>
-                  </a:txBody>
-                  <a:tcPr marL="9525" marR="9525" marT="9525" marB="9525" anchor="ctr"/>
-                </a:tc>
-                <a:tc>
-                  <a:txBody>
-                    <a:bodyPr/>
-                    <a:lstStyle/>
-                    <a:p>
-                      <a:pPr>
-                        <a:lnSpc>
-                          <a:spcPct val="115000"/>
-                        </a:lnSpc>
-                        <a:spcAft>
-                          <a:spcPts val="800"/>
-                        </a:spcAft>
-                        <a:buNone/>
-                      </a:pPr>
-                      <a:r>
-                        <a:rPr lang="en-GB" sz="2400" kern="100">
-                          <a:effectLst/>
-                        </a:rPr>
-                        <a:t>$10k–$25k</a:t>
-                      </a:r>
-                      <a:endParaRPr lang="en-GB" sz="2400" kern="100">
-                        <a:effectLst/>
-                        <a:latin typeface="Aptos" panose="020B0004020202020204" pitchFamily="34" charset="0"/>
-                        <a:ea typeface="Aptos" panose="020B0004020202020204" pitchFamily="34" charset="0"/>
-                        <a:cs typeface="Times New Roman" panose="02020603050405020304" pitchFamily="18" charset="0"/>
-                      </a:endParaRPr>
-                    </a:p>
-                  </a:txBody>
-                  <a:tcPr marL="9525" marR="9525" marT="9525" marB="9525" anchor="ctr"/>
-                </a:tc>
-                <a:tc>
-                  <a:txBody>
-                    <a:bodyPr/>
-                    <a:lstStyle/>
-                    <a:p>
-                      <a:pPr>
-                        <a:lnSpc>
-                          <a:spcPct val="115000"/>
-                        </a:lnSpc>
-                        <a:spcAft>
-                          <a:spcPts val="800"/>
-                        </a:spcAft>
-                        <a:buNone/>
-                      </a:pPr>
-                      <a:r>
-                        <a:rPr lang="en-GB" sz="2400" kern="100">
-                          <a:effectLst/>
-                        </a:rPr>
-                        <a:t>$25k–$50k</a:t>
-                      </a:r>
-                      <a:endParaRPr lang="en-GB" sz="2400" kern="100">
-                        <a:effectLst/>
-                        <a:latin typeface="Aptos" panose="020B0004020202020204" pitchFamily="34" charset="0"/>
-                        <a:ea typeface="Aptos" panose="020B0004020202020204" pitchFamily="34" charset="0"/>
-                        <a:cs typeface="Times New Roman" panose="02020603050405020304" pitchFamily="18" charset="0"/>
-                      </a:endParaRPr>
-                    </a:p>
-                  </a:txBody>
-                  <a:tcPr marL="9525" marR="9525" marT="9525" marB="9525" anchor="ctr"/>
-                </a:tc>
-                <a:tc>
-                  <a:txBody>
-                    <a:bodyPr/>
-                    <a:lstStyle/>
-                    <a:p>
-                      <a:pPr>
-                        <a:lnSpc>
-                          <a:spcPct val="115000"/>
-                        </a:lnSpc>
-                        <a:spcAft>
-                          <a:spcPts val="800"/>
-                        </a:spcAft>
-                        <a:buNone/>
-                      </a:pPr>
-                      <a:r>
-                        <a:rPr lang="en-GB" sz="2400" kern="100">
-                          <a:effectLst/>
-                        </a:rPr>
-                        <a:t>$50k+</a:t>
-                      </a:r>
-                      <a:endParaRPr lang="en-GB" sz="2400" kern="100">
-                        <a:effectLst/>
-                        <a:latin typeface="Aptos" panose="020B0004020202020204" pitchFamily="34" charset="0"/>
-                        <a:ea typeface="Aptos" panose="020B0004020202020204" pitchFamily="34" charset="0"/>
-                        <a:cs typeface="Times New Roman" panose="02020603050405020304" pitchFamily="18" charset="0"/>
-                      </a:endParaRPr>
-                    </a:p>
-                  </a:txBody>
-                  <a:tcPr marL="9525" marR="9525" marT="9525" marB="9525" anchor="ctr"/>
-                </a:tc>
-                <a:extLst>
-                  <a:ext uri="{0D108BD9-81ED-4DB2-BD59-A6C34878D82A}">
-                    <a16:rowId xmlns:a16="http://schemas.microsoft.com/office/drawing/2014/main" val="2541758987"/>
-                  </a:ext>
-                </a:extLst>
-              </a:tr>
-              <a:tr h="710293">
-                <a:tc>
-                  <a:txBody>
-                    <a:bodyPr/>
-                    <a:lstStyle/>
-                    <a:p>
-                      <a:pPr>
-                        <a:lnSpc>
-                          <a:spcPct val="115000"/>
-                        </a:lnSpc>
-                        <a:spcAft>
-                          <a:spcPts val="800"/>
-                        </a:spcAft>
-                        <a:buNone/>
-                      </a:pPr>
-                      <a:r>
-                        <a:rPr lang="en-GB" sz="2400" kern="100">
-                          <a:effectLst/>
-                        </a:rPr>
-                        <a:t>Testing &amp; QA</a:t>
-                      </a:r>
-                      <a:endParaRPr lang="en-GB" sz="2400" kern="100">
-                        <a:effectLst/>
-                        <a:latin typeface="Aptos" panose="020B0004020202020204" pitchFamily="34" charset="0"/>
-                        <a:ea typeface="Aptos" panose="020B0004020202020204" pitchFamily="34" charset="0"/>
-                        <a:cs typeface="Times New Roman" panose="02020603050405020304" pitchFamily="18" charset="0"/>
-                      </a:endParaRPr>
-                    </a:p>
-                  </a:txBody>
-                  <a:tcPr marL="9525" marR="9525" marT="9525" marB="9525" anchor="ctr"/>
-                </a:tc>
-                <a:tc>
-                  <a:txBody>
-                    <a:bodyPr/>
-                    <a:lstStyle/>
-                    <a:p>
-                      <a:pPr>
-                        <a:lnSpc>
-                          <a:spcPct val="115000"/>
-                        </a:lnSpc>
-                        <a:spcAft>
-                          <a:spcPts val="800"/>
-                        </a:spcAft>
-                        <a:buNone/>
-                      </a:pPr>
-                      <a:r>
-                        <a:rPr lang="en-GB" sz="2400" kern="100">
-                          <a:effectLst/>
-                        </a:rPr>
-                        <a:t>$1k–$8k</a:t>
-                      </a:r>
-                      <a:endParaRPr lang="en-GB" sz="2400" kern="100">
-                        <a:effectLst/>
-                        <a:latin typeface="Aptos" panose="020B0004020202020204" pitchFamily="34" charset="0"/>
-                        <a:ea typeface="Aptos" panose="020B0004020202020204" pitchFamily="34" charset="0"/>
-                        <a:cs typeface="Times New Roman" panose="02020603050405020304" pitchFamily="18" charset="0"/>
-                      </a:endParaRPr>
-                    </a:p>
-                  </a:txBody>
-                  <a:tcPr marL="9525" marR="9525" marT="9525" marB="9525" anchor="ctr"/>
-                </a:tc>
-                <a:tc>
-                  <a:txBody>
-                    <a:bodyPr/>
-                    <a:lstStyle/>
-                    <a:p>
-                      <a:pPr>
-                        <a:lnSpc>
-                          <a:spcPct val="115000"/>
-                        </a:lnSpc>
-                        <a:spcAft>
-                          <a:spcPts val="800"/>
-                        </a:spcAft>
-                        <a:buNone/>
-                      </a:pPr>
-                      <a:r>
-                        <a:rPr lang="en-GB" sz="2400" kern="100">
-                          <a:effectLst/>
-                        </a:rPr>
-                        <a:t>$8k–$20k</a:t>
-                      </a:r>
-                      <a:endParaRPr lang="en-GB" sz="2400" kern="100">
-                        <a:effectLst/>
-                        <a:latin typeface="Aptos" panose="020B0004020202020204" pitchFamily="34" charset="0"/>
-                        <a:ea typeface="Aptos" panose="020B0004020202020204" pitchFamily="34" charset="0"/>
-                        <a:cs typeface="Times New Roman" panose="02020603050405020304" pitchFamily="18" charset="0"/>
-                      </a:endParaRPr>
-                    </a:p>
-                  </a:txBody>
-                  <a:tcPr marL="9525" marR="9525" marT="9525" marB="9525" anchor="ctr"/>
-                </a:tc>
-                <a:tc>
-                  <a:txBody>
-                    <a:bodyPr/>
-                    <a:lstStyle/>
-                    <a:p>
-                      <a:pPr>
-                        <a:lnSpc>
-                          <a:spcPct val="115000"/>
-                        </a:lnSpc>
-                        <a:spcAft>
-                          <a:spcPts val="800"/>
-                        </a:spcAft>
-                        <a:buNone/>
-                      </a:pPr>
-                      <a:r>
-                        <a:rPr lang="en-GB" sz="2400" kern="100">
-                          <a:effectLst/>
-                        </a:rPr>
-                        <a:t>$20k–$50k</a:t>
-                      </a:r>
-                      <a:endParaRPr lang="en-GB" sz="2400" kern="100">
-                        <a:effectLst/>
-                        <a:latin typeface="Aptos" panose="020B0004020202020204" pitchFamily="34" charset="0"/>
-                        <a:ea typeface="Aptos" panose="020B0004020202020204" pitchFamily="34" charset="0"/>
-                        <a:cs typeface="Times New Roman" panose="02020603050405020304" pitchFamily="18" charset="0"/>
-                      </a:endParaRPr>
-                    </a:p>
-                  </a:txBody>
-                  <a:tcPr marL="9525" marR="9525" marT="9525" marB="9525" anchor="ctr"/>
-                </a:tc>
-                <a:tc>
-                  <a:txBody>
-                    <a:bodyPr/>
-                    <a:lstStyle/>
-                    <a:p>
-                      <a:pPr>
-                        <a:lnSpc>
-                          <a:spcPct val="115000"/>
-                        </a:lnSpc>
-                        <a:spcAft>
-                          <a:spcPts val="800"/>
-                        </a:spcAft>
-                        <a:buNone/>
-                      </a:pPr>
-                      <a:r>
-                        <a:rPr lang="en-GB" sz="2400" kern="100" dirty="0">
-                          <a:effectLst/>
-                        </a:rPr>
-                        <a:t>$50k+</a:t>
-                      </a:r>
-                      <a:endParaRPr lang="en-GB" sz="2400" kern="100" dirty="0">
-                        <a:effectLst/>
-                        <a:latin typeface="Aptos" panose="020B0004020202020204" pitchFamily="34" charset="0"/>
-                        <a:ea typeface="Aptos" panose="020B0004020202020204" pitchFamily="34" charset="0"/>
-                        <a:cs typeface="Times New Roman" panose="02020603050405020304" pitchFamily="18" charset="0"/>
-                      </a:endParaRPr>
-                    </a:p>
-                  </a:txBody>
-                  <a:tcPr marL="9525" marR="9525" marT="9525" marB="9525" anchor="ctr"/>
-                </a:tc>
-                <a:extLst>
-                  <a:ext uri="{0D108BD9-81ED-4DB2-BD59-A6C34878D82A}">
-                    <a16:rowId xmlns:a16="http://schemas.microsoft.com/office/drawing/2014/main" val="1667926459"/>
-                  </a:ext>
-                </a:extLst>
-              </a:tr>
-            </a:tbl>
-          </a:graphicData>
-        </a:graphic>
-      </p:graphicFrame>
+        </p:nvSpPr>
+        <p:spPr/>
+        <p:txBody>
+          <a:bodyPr>
+            <a:normAutofit/>
+          </a:bodyPr>
+          <a:lstStyle/>
+          <a:p>
+            <a:pPr marL="0" indent="0">
+              <a:buNone/>
+            </a:pPr>
+            <a:r>
+              <a:rPr lang="en-GB" sz="3600" dirty="0"/>
+              <a:t>We analyse Key Cost Factors like platform, design, and integrations and use various COST ESTIMATION METHODS. A detailed COST BREAKDOWN BY DEVELOPMENT PHASE from design deployment is essential for accurate budgeting</a:t>
+            </a:r>
+          </a:p>
+        </p:txBody>
+      </p:sp>
     </p:spTree>
     <p:extLst>
       <p:ext uri="{BB962C8B-B14F-4D97-AF65-F5344CB8AC3E}">
@@ -20014,7 +18110,7 @@
 </p:sld>
 </file>
 
-<file path=ppt/slides/slide27.xml><?xml version="1.0" encoding="utf-8"?>
+<file path=ppt/slides/slide22.xml><?xml version="1.0" encoding="utf-8"?>
 <p:sld xmlns:a="http://schemas.openxmlformats.org/drawingml/2006/main" xmlns:r="http://schemas.openxmlformats.org/officeDocument/2006/relationships" xmlns:p="http://schemas.openxmlformats.org/presentationml/2006/main">
   <p:cSld>
     <p:spTree>
@@ -20780,13 +18876,13 @@
         <p:spPr/>
         <p:txBody>
           <a:bodyPr>
-            <a:normAutofit/>
+            <a:normAutofit fontScale="90000"/>
           </a:bodyPr>
           <a:lstStyle/>
           <a:p>
             <a:r>
               <a:rPr lang="en-GB" sz="6000" dirty="0"/>
-              <a:t>JAVA</a:t>
+              <a:t>JAVA, KOTLIN, SWIFT, OBJECTIVE-C, DART, PYTHON</a:t>
             </a:r>
           </a:p>
         </p:txBody>

</xml_diff>